<commit_message>
A1 poster iteration 2: fix overflow, compress sections to fit 23.4in height
</commit_message>
<xml_diff>
--- a/poster/poster_a1.pptx
+++ b/poster/poster_a1.pptx
@@ -3105,7 +3105,7 @@
         <p:spPr>
           <a:xfrm>
             <a:off x="0" y="0"/>
-            <a:ext cx="30266640" cy="2500000"/>
+            <a:ext cx="30266640" cy="2200000"/>
           </a:xfrm>
           <a:prstGeom prst="rect">
             <a:avLst/>
@@ -3148,7 +3148,7 @@
         <p:spPr>
           <a:xfrm>
             <a:off x="0" y="0"/>
-            <a:ext cx="30266640" cy="70000"/>
+            <a:ext cx="30266640" cy="60000"/>
           </a:xfrm>
           <a:prstGeom prst="rect">
             <a:avLst/>
@@ -3190,8 +3190,8 @@
         </p:nvSpPr>
         <p:spPr>
           <a:xfrm>
-            <a:off x="0" y="2415000"/>
-            <a:ext cx="30266640" cy="85000"/>
+            <a:off x="0" y="2125000"/>
+            <a:ext cx="30266640" cy="75000"/>
           </a:xfrm>
           <a:prstGeom prst="rect">
             <a:avLst/>
@@ -3233,8 +3233,8 @@
         </p:nvSpPr>
         <p:spPr>
           <a:xfrm>
-            <a:off x="0" y="2405000"/>
-            <a:ext cx="30266640" cy="12000"/>
+            <a:off x="0" y="2115000"/>
+            <a:ext cx="30266640" cy="10000"/>
           </a:xfrm>
           <a:prstGeom prst="rect">
             <a:avLst/>
@@ -3276,8 +3276,8 @@
         </p:nvSpPr>
         <p:spPr>
           <a:xfrm>
-            <a:off x="800000" y="180000"/>
-            <a:ext cx="28666640" cy="1300000"/>
+            <a:off x="600000" y="130000"/>
+            <a:ext cx="29066640" cy="1200000"/>
           </a:xfrm>
           <a:prstGeom prst="rect">
             <a:avLst/>
@@ -3300,7 +3300,7 @@
               <a:spcAft>
                 <a:spcPts val="0"/>
               </a:spcAft>
-              <a:defRPr sz="6000" b="1">
+              <a:defRPr sz="5600" b="1">
                 <a:solidFill>
                   <a:srgbClr val="FFFFFF"/>
                 </a:solidFill>
@@ -3325,8 +3325,8 @@
         </p:nvSpPr>
         <p:spPr>
           <a:xfrm>
-            <a:off x="800000" y="1550000"/>
-            <a:ext cx="28666640" cy="400000"/>
+            <a:off x="600000" y="1400000"/>
+            <a:ext cx="29066640" cy="350000"/>
           </a:xfrm>
           <a:prstGeom prst="rect">
             <a:avLst/>
@@ -3349,7 +3349,7 @@
               <a:spcAft>
                 <a:spcPts val="0"/>
               </a:spcAft>
-              <a:defRPr sz="3000" b="0">
+              <a:defRPr sz="2800" b="0">
                 <a:solidFill>
                   <a:srgbClr val="BBCCDD"/>
                 </a:solidFill>
@@ -3370,8 +3370,8 @@
         </p:nvSpPr>
         <p:spPr>
           <a:xfrm>
-            <a:off x="500000" y="2050000"/>
-            <a:ext cx="45000" cy="45000"/>
+            <a:off x="400000" y="1850000"/>
+            <a:ext cx="40000" cy="40000"/>
           </a:xfrm>
           <a:prstGeom prst="rect">
             <a:avLst/>
@@ -3413,8 +3413,8 @@
         </p:nvSpPr>
         <p:spPr>
           <a:xfrm>
-            <a:off x="700000" y="2050000"/>
-            <a:ext cx="45000" cy="45000"/>
+            <a:off x="580000" y="1850000"/>
+            <a:ext cx="40000" cy="40000"/>
           </a:xfrm>
           <a:prstGeom prst="rect">
             <a:avLst/>
@@ -3456,8 +3456,8 @@
         </p:nvSpPr>
         <p:spPr>
           <a:xfrm>
-            <a:off x="900000" y="2050000"/>
-            <a:ext cx="45000" cy="45000"/>
+            <a:off x="760000" y="1850000"/>
+            <a:ext cx="40000" cy="40000"/>
           </a:xfrm>
           <a:prstGeom prst="rect">
             <a:avLst/>
@@ -3499,8 +3499,8 @@
         </p:nvSpPr>
         <p:spPr>
           <a:xfrm>
-            <a:off x="29721640" y="2050000"/>
-            <a:ext cx="45000" cy="45000"/>
+            <a:off x="29826640" y="1850000"/>
+            <a:ext cx="40000" cy="40000"/>
           </a:xfrm>
           <a:prstGeom prst="rect">
             <a:avLst/>
@@ -3542,8 +3542,8 @@
         </p:nvSpPr>
         <p:spPr>
           <a:xfrm>
-            <a:off x="29521640" y="2050000"/>
-            <a:ext cx="45000" cy="45000"/>
+            <a:off x="29646640" y="1850000"/>
+            <a:ext cx="40000" cy="40000"/>
           </a:xfrm>
           <a:prstGeom prst="rect">
             <a:avLst/>
@@ -3585,8 +3585,8 @@
         </p:nvSpPr>
         <p:spPr>
           <a:xfrm>
-            <a:off x="29321640" y="2050000"/>
-            <a:ext cx="45000" cy="45000"/>
+            <a:off x="29466640" y="1850000"/>
+            <a:ext cx="40000" cy="40000"/>
           </a:xfrm>
           <a:prstGeom prst="rect">
             <a:avLst/>
@@ -3628,8 +3628,8 @@
         </p:nvSpPr>
         <p:spPr>
           <a:xfrm>
-            <a:off x="10222213" y="2700000"/>
-            <a:ext cx="12000" cy="17996960"/>
+            <a:off x="10197213" y="2350000"/>
+            <a:ext cx="12000" cy="18496960"/>
           </a:xfrm>
           <a:prstGeom prst="rect">
             <a:avLst/>
@@ -3671,8 +3671,8 @@
         </p:nvSpPr>
         <p:spPr>
           <a:xfrm>
-            <a:off x="20044426" y="2700000"/>
-            <a:ext cx="12000" cy="17996960"/>
+            <a:off x="20069426" y="2350000"/>
+            <a:ext cx="12000" cy="18496960"/>
           </a:xfrm>
           <a:prstGeom prst="rect">
             <a:avLst/>
@@ -3714,8 +3714,8 @@
         </p:nvSpPr>
         <p:spPr>
           <a:xfrm>
-            <a:off x="600000" y="2700000"/>
-            <a:ext cx="9422213" cy="680000"/>
+            <a:off x="500000" y="2350000"/>
+            <a:ext cx="9522213" cy="560000"/>
           </a:xfrm>
           <a:prstGeom prst="rect">
             <a:avLst/>
@@ -3757,8 +3757,8 @@
         </p:nvSpPr>
         <p:spPr>
           <a:xfrm>
-            <a:off x="600000" y="2700000"/>
-            <a:ext cx="80000" cy="680000"/>
+            <a:off x="500000" y="2350000"/>
+            <a:ext cx="70000" cy="560000"/>
           </a:xfrm>
           <a:prstGeom prst="rect">
             <a:avLst/>
@@ -3800,8 +3800,8 @@
         </p:nvSpPr>
         <p:spPr>
           <a:xfrm>
-            <a:off x="720000" y="2780000"/>
-            <a:ext cx="380000" cy="520000"/>
+            <a:off x="600000" y="2410000"/>
+            <a:ext cx="340000" cy="440000"/>
           </a:xfrm>
           <a:prstGeom prst="rect">
             <a:avLst/>
@@ -3824,7 +3824,7 @@
               <a:spcAft>
                 <a:spcPts val="0"/>
               </a:spcAft>
-              <a:defRPr sz="3000" b="1">
+              <a:defRPr sz="2600" b="1">
                 <a:solidFill>
                   <a:srgbClr val="FFFFFF"/>
                 </a:solidFill>
@@ -3845,8 +3845,8 @@
         </p:nvSpPr>
         <p:spPr>
           <a:xfrm>
-            <a:off x="1020000" y="2800000"/>
-            <a:ext cx="9092213" cy="480000"/>
+            <a:off x="880000" y="2425000"/>
+            <a:ext cx="9232213" cy="410000"/>
           </a:xfrm>
           <a:prstGeom prst="rect">
             <a:avLst/>
@@ -3869,7 +3869,7 @@
               <a:spcAft>
                 <a:spcPts val="0"/>
               </a:spcAft>
-              <a:defRPr sz="3600" b="1">
+              <a:defRPr sz="3200" b="1">
                 <a:solidFill>
                   <a:srgbClr val="FFFFFF"/>
                 </a:solidFill>
@@ -3890,8 +3890,8 @@
         </p:nvSpPr>
         <p:spPr>
           <a:xfrm>
-            <a:off x="600000" y="3335000"/>
-            <a:ext cx="9422213" cy="45000"/>
+            <a:off x="500000" y="2870000"/>
+            <a:ext cx="9522213" cy="40000"/>
           </a:xfrm>
           <a:prstGeom prst="rect">
             <a:avLst/>
@@ -3933,8 +3933,8 @@
         </p:nvSpPr>
         <p:spPr>
           <a:xfrm>
-            <a:off x="600000" y="3380000"/>
-            <a:ext cx="9422213" cy="3500000"/>
+            <a:off x="500000" y="2910000"/>
+            <a:ext cx="9522213" cy="3200000"/>
           </a:xfrm>
           <a:prstGeom prst="roundRect">
             <a:avLst>
@@ -3980,8 +3980,8 @@
         </p:nvSpPr>
         <p:spPr>
           <a:xfrm>
-            <a:off x="800000" y="3510000"/>
-            <a:ext cx="9022213" cy="3280000"/>
+            <a:off x="680000" y="3040000"/>
+            <a:ext cx="9162213" cy="2980000"/>
           </a:xfrm>
           <a:prstGeom prst="rect">
             <a:avLst/>
@@ -4004,7 +4004,7 @@
               <a:spcAft>
                 <a:spcPts val="600"/>
               </a:spcAft>
-              <a:defRPr sz="2400" b="1">
+              <a:defRPr sz="2200" b="1">
                 <a:solidFill>
                   <a:srgbClr val="2E86AB"/>
                 </a:solidFill>
@@ -4026,7 +4026,7 @@
               <a:spcAft>
                 <a:spcPts val="1000"/>
               </a:spcAft>
-              <a:defRPr sz="2400" b="0">
+              <a:defRPr sz="2200" b="0">
                 <a:solidFill>
                   <a:srgbClr val="2D2D2D"/>
                 </a:solidFill>
@@ -4048,7 +4048,7 @@
               <a:spcAft>
                 <a:spcPts val="600"/>
               </a:spcAft>
-              <a:defRPr sz="2400" b="1">
+              <a:defRPr sz="2200" b="1">
                 <a:solidFill>
                   <a:srgbClr val="E84D60"/>
                 </a:solidFill>
@@ -4070,7 +4070,7 @@
               <a:spcAft>
                 <a:spcPts val="1000"/>
               </a:spcAft>
-              <a:defRPr sz="2400" b="0">
+              <a:defRPr sz="2200" b="0">
                 <a:solidFill>
                   <a:srgbClr val="2D2D2D"/>
                 </a:solidFill>
@@ -4092,7 +4092,7 @@
               <a:spcAft>
                 <a:spcPts val="600"/>
               </a:spcAft>
-              <a:defRPr sz="2400" b="1">
+              <a:defRPr sz="2200" b="1">
                 <a:solidFill>
                   <a:srgbClr val="2E86AB"/>
                 </a:solidFill>
@@ -4114,7 +4114,7 @@
               <a:spcAft>
                 <a:spcPts val="600"/>
               </a:spcAft>
-              <a:defRPr sz="2400" b="0">
+              <a:defRPr sz="2200" b="0">
                 <a:solidFill>
                   <a:srgbClr val="2D2D2D"/>
                 </a:solidFill>
@@ -4138,7 +4138,7 @@
               </a:spcAft>
             </a:pPr>
             <a:r>
-              <a:rPr sz="2200" b="0">
+              <a:rPr sz="2000" b="0">
                 <a:solidFill>
                   <a:srgbClr val="666666"/>
                 </a:solidFill>
@@ -4147,7 +4147,7 @@
               <a:t>  •  </a:t>
             </a:r>
             <a:r>
-              <a:rPr sz="2200" b="1">
+              <a:rPr sz="2000" b="1">
                 <a:solidFill>
                   <a:srgbClr val="27AE60"/>
                 </a:solidFill>
@@ -4178,7 +4178,7 @@
               </a:spcAft>
             </a:pPr>
             <a:r>
-              <a:rPr sz="2200" b="0">
+              <a:rPr sz="2000" b="0">
                 <a:solidFill>
                   <a:srgbClr val="666666"/>
                 </a:solidFill>
@@ -4187,7 +4187,7 @@
               <a:t>  •  </a:t>
             </a:r>
             <a:r>
-              <a:rPr sz="2200" b="1">
+              <a:rPr sz="2000" b="1">
                 <a:solidFill>
                   <a:srgbClr val="E67E22"/>
                 </a:solidFill>
@@ -4215,8 +4215,8 @@
         </p:nvSpPr>
         <p:spPr>
           <a:xfrm>
-            <a:off x="600000" y="7180000"/>
-            <a:ext cx="9422213" cy="680000"/>
+            <a:off x="500000" y="6310000"/>
+            <a:ext cx="9522213" cy="560000"/>
           </a:xfrm>
           <a:prstGeom prst="rect">
             <a:avLst/>
@@ -4258,8 +4258,8 @@
         </p:nvSpPr>
         <p:spPr>
           <a:xfrm>
-            <a:off x="600000" y="7180000"/>
-            <a:ext cx="80000" cy="680000"/>
+            <a:off x="500000" y="6310000"/>
+            <a:ext cx="70000" cy="560000"/>
           </a:xfrm>
           <a:prstGeom prst="rect">
             <a:avLst/>
@@ -4301,8 +4301,8 @@
         </p:nvSpPr>
         <p:spPr>
           <a:xfrm>
-            <a:off x="720000" y="7260000"/>
-            <a:ext cx="380000" cy="520000"/>
+            <a:off x="600000" y="6370000"/>
+            <a:ext cx="340000" cy="440000"/>
           </a:xfrm>
           <a:prstGeom prst="rect">
             <a:avLst/>
@@ -4325,7 +4325,7 @@
               <a:spcAft>
                 <a:spcPts val="0"/>
               </a:spcAft>
-              <a:defRPr sz="3000" b="1">
+              <a:defRPr sz="2600" b="1">
                 <a:solidFill>
                   <a:srgbClr val="FFFFFF"/>
                 </a:solidFill>
@@ -4346,8 +4346,8 @@
         </p:nvSpPr>
         <p:spPr>
           <a:xfrm>
-            <a:off x="1020000" y="7280000"/>
-            <a:ext cx="9092213" cy="480000"/>
+            <a:off x="880000" y="6385000"/>
+            <a:ext cx="9232213" cy="410000"/>
           </a:xfrm>
           <a:prstGeom prst="rect">
             <a:avLst/>
@@ -4370,7 +4370,7 @@
               <a:spcAft>
                 <a:spcPts val="0"/>
               </a:spcAft>
-              <a:defRPr sz="3600" b="1">
+              <a:defRPr sz="3200" b="1">
                 <a:solidFill>
                   <a:srgbClr val="FFFFFF"/>
                 </a:solidFill>
@@ -4391,8 +4391,8 @@
         </p:nvSpPr>
         <p:spPr>
           <a:xfrm>
-            <a:off x="600000" y="7815000"/>
-            <a:ext cx="9422213" cy="45000"/>
+            <a:off x="500000" y="6830000"/>
+            <a:ext cx="9522213" cy="40000"/>
           </a:xfrm>
           <a:prstGeom prst="rect">
             <a:avLst/>
@@ -4434,8 +4434,8 @@
         </p:nvSpPr>
         <p:spPr>
           <a:xfrm>
-            <a:off x="600000" y="7860000"/>
-            <a:ext cx="9422213" cy="3000000"/>
+            <a:off x="500000" y="6870000"/>
+            <a:ext cx="9522213" cy="2700000"/>
           </a:xfrm>
           <a:prstGeom prst="roundRect">
             <a:avLst>
@@ -4481,8 +4481,8 @@
         </p:nvSpPr>
         <p:spPr>
           <a:xfrm>
-            <a:off x="800000" y="7990000"/>
-            <a:ext cx="9022213" cy="2780000"/>
+            <a:off x="680000" y="7000000"/>
+            <a:ext cx="9162213" cy="2480000"/>
           </a:xfrm>
           <a:prstGeom prst="rect">
             <a:avLst/>
@@ -4507,7 +4507,7 @@
               </a:spcAft>
             </a:pPr>
             <a:r>
-              <a:rPr sz="2400" b="1">
+              <a:rPr sz="2200" b="1">
                 <a:solidFill>
                   <a:srgbClr val="2E86AB"/>
                 </a:solidFill>
@@ -4516,7 +4516,7 @@
               <a:t>Training: </a:t>
             </a:r>
             <a:r>
-              <a:rPr sz="2400" b="0">
+              <a:rPr sz="2200" b="0">
                 <a:solidFill>
                   <a:srgbClr val="2D2D2D"/>
                 </a:solidFill>
@@ -4538,7 +4538,7 @@
               </a:spcAft>
             </a:pPr>
             <a:r>
-              <a:rPr sz="2400" b="1">
+              <a:rPr sz="2200" b="1">
                 <a:solidFill>
                   <a:srgbClr val="2E86AB"/>
                 </a:solidFill>
@@ -4547,7 +4547,7 @@
               <a:t>Development: </a:t>
             </a:r>
             <a:r>
-              <a:rPr sz="2400" b="0">
+              <a:rPr sz="2200" b="0">
                 <a:solidFill>
                   <a:srgbClr val="2D2D2D"/>
                 </a:solidFill>
@@ -4569,7 +4569,7 @@
               </a:spcAft>
             </a:pPr>
             <a:r>
-              <a:rPr sz="2400" b="1">
+              <a:rPr sz="2200" b="1">
                 <a:solidFill>
                   <a:srgbClr val="2E86AB"/>
                 </a:solidFill>
@@ -4578,7 +4578,7 @@
               <a:t>Labels: </a:t>
             </a:r>
             <a:r>
-              <a:rPr sz="2400" b="0">
+              <a:rPr sz="2200" b="0">
                 <a:solidFill>
                   <a:srgbClr val="2D2D2D"/>
                 </a:solidFill>
@@ -4600,7 +4600,7 @@
               </a:spcAft>
             </a:pPr>
             <a:r>
-              <a:rPr sz="2400" b="1">
+              <a:rPr sz="2200" b="1">
                 <a:solidFill>
                   <a:srgbClr val="2E86AB"/>
                 </a:solidFill>
@@ -4609,7 +4609,7 @@
               <a:t>Domains: </a:t>
             </a:r>
             <a:r>
-              <a:rPr sz="2400" b="0">
+              <a:rPr sz="2200" b="0">
                 <a:solidFill>
                   <a:srgbClr val="2D2D2D"/>
                 </a:solidFill>
@@ -4648,7 +4648,7 @@
               <a:spcAft>
                 <a:spcPts val="600"/>
               </a:spcAft>
-              <a:defRPr sz="2400" b="1">
+              <a:defRPr sz="2200" b="1">
                 <a:solidFill>
                   <a:srgbClr val="2E86AB"/>
                 </a:solidFill>
@@ -4672,7 +4672,7 @@
               </a:spcAft>
             </a:pPr>
             <a:r>
-              <a:rPr sz="2200" b="0">
+              <a:rPr sz="2000" b="0">
                 <a:solidFill>
                   <a:srgbClr val="666666"/>
                 </a:solidFill>
@@ -4681,7 +4681,7 @@
               <a:t>  •  </a:t>
             </a:r>
             <a:r>
-              <a:rPr sz="2200" b="0">
+              <a:rPr sz="2000" b="0">
                 <a:solidFill>
                   <a:srgbClr val="2D2D2D"/>
                 </a:solidFill>
@@ -4703,7 +4703,7 @@
               </a:spcAft>
             </a:pPr>
             <a:r>
-              <a:rPr sz="2200" b="0">
+              <a:rPr sz="2000" b="0">
                 <a:solidFill>
                   <a:srgbClr val="666666"/>
                 </a:solidFill>
@@ -4712,7 +4712,7 @@
               <a:t>  •  </a:t>
             </a:r>
             <a:r>
-              <a:rPr sz="2200" b="0">
+              <a:rPr sz="2000" b="0">
                 <a:solidFill>
                   <a:srgbClr val="2D2D2D"/>
                 </a:solidFill>
@@ -4751,7 +4751,7 @@
               <a:spcAft>
                 <a:spcPts val="400"/>
               </a:spcAft>
-              <a:defRPr sz="2000" b="0" i="1">
+              <a:defRPr sz="1800" b="0" i="1">
                 <a:solidFill>
                   <a:srgbClr val="666666"/>
                 </a:solidFill>
@@ -4772,8 +4772,8 @@
         </p:nvSpPr>
         <p:spPr>
           <a:xfrm>
-            <a:off x="600000" y="11160000"/>
-            <a:ext cx="9422213" cy="680000"/>
+            <a:off x="500000" y="9770000"/>
+            <a:ext cx="9522213" cy="560000"/>
           </a:xfrm>
           <a:prstGeom prst="rect">
             <a:avLst/>
@@ -4815,8 +4815,8 @@
         </p:nvSpPr>
         <p:spPr>
           <a:xfrm>
-            <a:off x="600000" y="11160000"/>
-            <a:ext cx="80000" cy="680000"/>
+            <a:off x="500000" y="9770000"/>
+            <a:ext cx="70000" cy="560000"/>
           </a:xfrm>
           <a:prstGeom prst="rect">
             <a:avLst/>
@@ -4858,8 +4858,8 @@
         </p:nvSpPr>
         <p:spPr>
           <a:xfrm>
-            <a:off x="720000" y="11240000"/>
-            <a:ext cx="380000" cy="520000"/>
+            <a:off x="600000" y="9830000"/>
+            <a:ext cx="340000" cy="440000"/>
           </a:xfrm>
           <a:prstGeom prst="rect">
             <a:avLst/>
@@ -4882,7 +4882,7 @@
               <a:spcAft>
                 <a:spcPts val="0"/>
               </a:spcAft>
-              <a:defRPr sz="3000" b="1">
+              <a:defRPr sz="2600" b="1">
                 <a:solidFill>
                   <a:srgbClr val="FFFFFF"/>
                 </a:solidFill>
@@ -4903,8 +4903,8 @@
         </p:nvSpPr>
         <p:spPr>
           <a:xfrm>
-            <a:off x="1020000" y="11260000"/>
-            <a:ext cx="9092213" cy="480000"/>
+            <a:off x="880000" y="9845000"/>
+            <a:ext cx="9232213" cy="410000"/>
           </a:xfrm>
           <a:prstGeom prst="rect">
             <a:avLst/>
@@ -4927,7 +4927,7 @@
               <a:spcAft>
                 <a:spcPts val="0"/>
               </a:spcAft>
-              <a:defRPr sz="3600" b="1">
+              <a:defRPr sz="3200" b="1">
                 <a:solidFill>
                   <a:srgbClr val="FFFFFF"/>
                 </a:solidFill>
@@ -4948,8 +4948,8 @@
         </p:nvSpPr>
         <p:spPr>
           <a:xfrm>
-            <a:off x="600000" y="11795000"/>
-            <a:ext cx="9422213" cy="45000"/>
+            <a:off x="500000" y="10290000"/>
+            <a:ext cx="9522213" cy="40000"/>
           </a:xfrm>
           <a:prstGeom prst="rect">
             <a:avLst/>
@@ -4991,8 +4991,8 @@
         </p:nvSpPr>
         <p:spPr>
           <a:xfrm>
-            <a:off x="600000" y="11840000"/>
-            <a:ext cx="9422213" cy="5200000"/>
+            <a:off x="500000" y="10330000"/>
+            <a:ext cx="9522213" cy="4800000"/>
           </a:xfrm>
           <a:prstGeom prst="roundRect">
             <a:avLst>
@@ -5038,8 +5038,8 @@
         </p:nvSpPr>
         <p:spPr>
           <a:xfrm>
-            <a:off x="800000" y="11970000"/>
-            <a:ext cx="9022213" cy="4980000"/>
+            <a:off x="680000" y="10460000"/>
+            <a:ext cx="9162213" cy="4580000"/>
           </a:xfrm>
           <a:prstGeom prst="rect">
             <a:avLst/>
@@ -5062,7 +5062,7 @@
               <a:spcAft>
                 <a:spcPts val="800"/>
               </a:spcAft>
-              <a:defRPr sz="2400" b="1">
+              <a:defRPr sz="2200" b="1">
                 <a:solidFill>
                   <a:srgbClr val="2D2D2D"/>
                 </a:solidFill>
@@ -5084,7 +5084,7 @@
               <a:spcAft>
                 <a:spcPts val="600"/>
               </a:spcAft>
-              <a:defRPr sz="2400" b="1">
+              <a:defRPr sz="2200" b="1">
                 <a:solidFill>
                   <a:srgbClr val="2E86AB"/>
                 </a:solidFill>
@@ -5108,7 +5108,7 @@
               </a:spcAft>
             </a:pPr>
             <a:r>
-              <a:rPr sz="2200" b="0">
+              <a:rPr sz="2000" b="0">
                 <a:solidFill>
                   <a:srgbClr val="666666"/>
                 </a:solidFill>
@@ -5117,7 +5117,7 @@
               <a:t>  •  </a:t>
             </a:r>
             <a:r>
-              <a:rPr sz="2200" b="1">
+              <a:rPr sz="2000" b="1">
                 <a:solidFill>
                   <a:srgbClr val="2D2D2D"/>
                 </a:solidFill>
@@ -5148,7 +5148,7 @@
               </a:spcAft>
             </a:pPr>
             <a:r>
-              <a:rPr sz="2200" b="0">
+              <a:rPr sz="2000" b="0">
                 <a:solidFill>
                   <a:srgbClr val="666666"/>
                 </a:solidFill>
@@ -5157,7 +5157,7 @@
               <a:t>  •  </a:t>
             </a:r>
             <a:r>
-              <a:rPr sz="2200" b="1">
+              <a:rPr sz="2000" b="1">
                 <a:solidFill>
                   <a:srgbClr val="2D2D2D"/>
                 </a:solidFill>
@@ -5188,7 +5188,7 @@
               </a:spcAft>
             </a:pPr>
             <a:r>
-              <a:rPr sz="2200" b="0">
+              <a:rPr sz="2000" b="0">
                 <a:solidFill>
                   <a:srgbClr val="666666"/>
                 </a:solidFill>
@@ -5197,7 +5197,7 @@
               <a:t>  •  </a:t>
             </a:r>
             <a:r>
-              <a:rPr sz="2200" b="1">
+              <a:rPr sz="2000" b="1">
                 <a:solidFill>
                   <a:srgbClr val="2D2D2D"/>
                 </a:solidFill>
@@ -5228,7 +5228,7 @@
               </a:spcAft>
             </a:pPr>
             <a:r>
-              <a:rPr sz="2200" b="0">
+              <a:rPr sz="2000" b="0">
                 <a:solidFill>
                   <a:srgbClr val="666666"/>
                 </a:solidFill>
@@ -5237,7 +5237,7 @@
               <a:t>  •  </a:t>
             </a:r>
             <a:r>
-              <a:rPr sz="2200" b="1">
+              <a:rPr sz="2000" b="1">
                 <a:solidFill>
                   <a:srgbClr val="2D2D2D"/>
                 </a:solidFill>
@@ -5268,7 +5268,7 @@
               </a:spcAft>
             </a:pPr>
             <a:r>
-              <a:rPr sz="2200" b="0">
+              <a:rPr sz="2000" b="0">
                 <a:solidFill>
                   <a:srgbClr val="666666"/>
                 </a:solidFill>
@@ -5277,7 +5277,7 @@
               <a:t>  •  </a:t>
             </a:r>
             <a:r>
-              <a:rPr sz="2200" b="1">
+              <a:rPr sz="2000" b="1">
                 <a:solidFill>
                   <a:srgbClr val="2D2D2D"/>
                 </a:solidFill>
@@ -5308,7 +5308,7 @@
               </a:spcAft>
             </a:pPr>
             <a:r>
-              <a:rPr sz="2200" b="0">
+              <a:rPr sz="2000" b="0">
                 <a:solidFill>
                   <a:srgbClr val="666666"/>
                 </a:solidFill>
@@ -5317,7 +5317,7 @@
               <a:t>  •  </a:t>
             </a:r>
             <a:r>
-              <a:rPr sz="2200" b="1">
+              <a:rPr sz="2000" b="1">
                 <a:solidFill>
                   <a:srgbClr val="2D2D2D"/>
                 </a:solidFill>
@@ -5365,7 +5365,7 @@
               <a:spcAft>
                 <a:spcPts val="600"/>
               </a:spcAft>
-              <a:defRPr sz="2400" b="1">
+              <a:defRPr sz="2200" b="1">
                 <a:solidFill>
                   <a:srgbClr val="E84D60"/>
                 </a:solidFill>
@@ -5389,7 +5389,7 @@
               </a:spcAft>
             </a:pPr>
             <a:r>
-              <a:rPr sz="2200" b="0">
+              <a:rPr sz="2000" b="0">
                 <a:solidFill>
                   <a:srgbClr val="666666"/>
                 </a:solidFill>
@@ -5398,7 +5398,7 @@
               <a:t>  •  </a:t>
             </a:r>
             <a:r>
-              <a:rPr sz="2200" b="1">
+              <a:rPr sz="2000" b="1">
                 <a:solidFill>
                   <a:srgbClr val="E84D60"/>
                 </a:solidFill>
@@ -5429,7 +5429,7 @@
               </a:spcAft>
             </a:pPr>
             <a:r>
-              <a:rPr sz="2200" b="0">
+              <a:rPr sz="2000" b="0">
                 <a:solidFill>
                   <a:srgbClr val="666666"/>
                 </a:solidFill>
@@ -5438,7 +5438,7 @@
               <a:t>  •  </a:t>
             </a:r>
             <a:r>
-              <a:rPr sz="2200" b="1">
+              <a:rPr sz="2000" b="1">
                 <a:solidFill>
                   <a:srgbClr val="E84D60"/>
                 </a:solidFill>
@@ -5469,7 +5469,7 @@
               </a:spcAft>
             </a:pPr>
             <a:r>
-              <a:rPr sz="2200" b="0">
+              <a:rPr sz="2000" b="0">
                 <a:solidFill>
                   <a:srgbClr val="666666"/>
                 </a:solidFill>
@@ -5478,7 +5478,7 @@
               <a:t>  •  </a:t>
             </a:r>
             <a:r>
-              <a:rPr sz="2200" b="1">
+              <a:rPr sz="2000" b="1">
                 <a:solidFill>
                   <a:srgbClr val="E84D60"/>
                 </a:solidFill>
@@ -5526,7 +5526,7 @@
               <a:spcAft>
                 <a:spcPts val="400"/>
               </a:spcAft>
-              <a:defRPr sz="2400" b="1">
+              <a:defRPr sz="2200" b="1">
                 <a:solidFill>
                   <a:srgbClr val="2D2D2D"/>
                 </a:solidFill>
@@ -5548,7 +5548,7 @@
               <a:spcAft>
                 <a:spcPts val="400"/>
               </a:spcAft>
-              <a:defRPr sz="2000" b="0" i="1">
+              <a:defRPr sz="1800" b="0" i="1">
                 <a:solidFill>
                   <a:srgbClr val="666666"/>
                 </a:solidFill>
@@ -5569,8 +5569,8 @@
         </p:nvSpPr>
         <p:spPr>
           <a:xfrm>
-            <a:off x="600000" y="17340000"/>
-            <a:ext cx="9422213" cy="680000"/>
+            <a:off x="500000" y="15330000"/>
+            <a:ext cx="9522213" cy="560000"/>
           </a:xfrm>
           <a:prstGeom prst="rect">
             <a:avLst/>
@@ -5612,8 +5612,8 @@
         </p:nvSpPr>
         <p:spPr>
           <a:xfrm>
-            <a:off x="600000" y="17340000"/>
-            <a:ext cx="80000" cy="680000"/>
+            <a:off x="500000" y="15330000"/>
+            <a:ext cx="70000" cy="560000"/>
           </a:xfrm>
           <a:prstGeom prst="rect">
             <a:avLst/>
@@ -5655,8 +5655,8 @@
         </p:nvSpPr>
         <p:spPr>
           <a:xfrm>
-            <a:off x="830000" y="17440000"/>
-            <a:ext cx="9092213" cy="480000"/>
+            <a:off x="700000" y="15405000"/>
+            <a:ext cx="9232213" cy="410000"/>
           </a:xfrm>
           <a:prstGeom prst="rect">
             <a:avLst/>
@@ -5679,7 +5679,7 @@
               <a:spcAft>
                 <a:spcPts val="0"/>
               </a:spcAft>
-              <a:defRPr sz="3600" b="1">
+              <a:defRPr sz="3200" b="1">
                 <a:solidFill>
                   <a:srgbClr val="FFFFFF"/>
                 </a:solidFill>
@@ -5700,8 +5700,8 @@
         </p:nvSpPr>
         <p:spPr>
           <a:xfrm>
-            <a:off x="600000" y="17975000"/>
-            <a:ext cx="9422213" cy="45000"/>
+            <a:off x="500000" y="15850000"/>
+            <a:ext cx="9522213" cy="40000"/>
           </a:xfrm>
           <a:prstGeom prst="rect">
             <a:avLst/>
@@ -5743,8 +5743,8 @@
         </p:nvSpPr>
         <p:spPr>
           <a:xfrm>
-            <a:off x="600000" y="18020000"/>
-            <a:ext cx="9422213" cy="4800000"/>
+            <a:off x="500000" y="15890000"/>
+            <a:ext cx="9522213" cy="4200000"/>
           </a:xfrm>
           <a:prstGeom prst="roundRect">
             <a:avLst>
@@ -5798,8 +5798,8 @@
         </p:blipFill>
         <p:spPr>
           <a:xfrm>
-            <a:off x="780000" y="18270000"/>
-            <a:ext cx="9062213" cy="4300000"/>
+            <a:off x="650000" y="16090000"/>
+            <a:ext cx="9222213" cy="3800000"/>
           </a:xfrm>
           <a:prstGeom prst="rect">
             <a:avLst/>
@@ -5814,8 +5814,8 @@
         </p:nvSpPr>
         <p:spPr>
           <a:xfrm>
-            <a:off x="10422213" y="2700000"/>
-            <a:ext cx="9422213" cy="680000"/>
+            <a:off x="10372213" y="2350000"/>
+            <a:ext cx="9522213" cy="560000"/>
           </a:xfrm>
           <a:prstGeom prst="rect">
             <a:avLst/>
@@ -5857,8 +5857,8 @@
         </p:nvSpPr>
         <p:spPr>
           <a:xfrm>
-            <a:off x="10422213" y="2700000"/>
-            <a:ext cx="80000" cy="680000"/>
+            <a:off x="10372213" y="2350000"/>
+            <a:ext cx="70000" cy="560000"/>
           </a:xfrm>
           <a:prstGeom prst="rect">
             <a:avLst/>
@@ -5900,8 +5900,8 @@
         </p:nvSpPr>
         <p:spPr>
           <a:xfrm>
-            <a:off x="10542213" y="2780000"/>
-            <a:ext cx="380000" cy="520000"/>
+            <a:off x="10472213" y="2410000"/>
+            <a:ext cx="340000" cy="440000"/>
           </a:xfrm>
           <a:prstGeom prst="rect">
             <a:avLst/>
@@ -5924,7 +5924,7 @@
               <a:spcAft>
                 <a:spcPts val="0"/>
               </a:spcAft>
-              <a:defRPr sz="3000" b="1">
+              <a:defRPr sz="2600" b="1">
                 <a:solidFill>
                   <a:srgbClr val="FFFFFF"/>
                 </a:solidFill>
@@ -5945,8 +5945,8 @@
         </p:nvSpPr>
         <p:spPr>
           <a:xfrm>
-            <a:off x="10842213" y="2800000"/>
-            <a:ext cx="9092213" cy="480000"/>
+            <a:off x="10752213" y="2425000"/>
+            <a:ext cx="9232213" cy="410000"/>
           </a:xfrm>
           <a:prstGeom prst="rect">
             <a:avLst/>
@@ -5969,7 +5969,7 @@
               <a:spcAft>
                 <a:spcPts val="0"/>
               </a:spcAft>
-              <a:defRPr sz="3600" b="1">
+              <a:defRPr sz="3200" b="1">
                 <a:solidFill>
                   <a:srgbClr val="FFFFFF"/>
                 </a:solidFill>
@@ -5990,8 +5990,8 @@
         </p:nvSpPr>
         <p:spPr>
           <a:xfrm>
-            <a:off x="10422213" y="3335000"/>
-            <a:ext cx="9422213" cy="45000"/>
+            <a:off x="10372213" y="2870000"/>
+            <a:ext cx="9522213" cy="40000"/>
           </a:xfrm>
           <a:prstGeom prst="rect">
             <a:avLst/>
@@ -6033,8 +6033,8 @@
         </p:nvSpPr>
         <p:spPr>
           <a:xfrm>
-            <a:off x="10422213" y="3380000"/>
-            <a:ext cx="9422213" cy="4800000"/>
+            <a:off x="10372213" y="2910000"/>
+            <a:ext cx="9522213" cy="4200000"/>
           </a:xfrm>
           <a:prstGeom prst="roundRect">
             <a:avLst>
@@ -6080,8 +6080,8 @@
         </p:nvSpPr>
         <p:spPr>
           <a:xfrm>
-            <a:off x="10622213" y="3510000"/>
-            <a:ext cx="9022213" cy="4580000"/>
+            <a:off x="10552213" y="3040000"/>
+            <a:ext cx="9162213" cy="3980000"/>
           </a:xfrm>
           <a:prstGeom prst="rect">
             <a:avLst/>
@@ -6104,7 +6104,7 @@
               <a:spcAft>
                 <a:spcPts val="600"/>
               </a:spcAft>
-              <a:defRPr sz="2400" b="1">
+              <a:defRPr sz="2200" b="1">
                 <a:solidFill>
                   <a:srgbClr val="2E86AB"/>
                 </a:solidFill>
@@ -6128,7 +6128,7 @@
               </a:spcAft>
             </a:pPr>
             <a:r>
-              <a:rPr sz="2200" b="0">
+              <a:rPr sz="2000" b="0">
                 <a:solidFill>
                   <a:srgbClr val="666666"/>
                 </a:solidFill>
@@ -6137,7 +6137,7 @@
               <a:t>  •  </a:t>
             </a:r>
             <a:r>
-              <a:rPr sz="2200" b="1">
+              <a:rPr sz="2000" b="1">
                 <a:solidFill>
                   <a:srgbClr val="2D2D2D"/>
                 </a:solidFill>
@@ -6168,7 +6168,7 @@
               </a:spcAft>
             </a:pPr>
             <a:r>
-              <a:rPr sz="2200" b="0">
+              <a:rPr sz="2000" b="0">
                 <a:solidFill>
                   <a:srgbClr val="666666"/>
                 </a:solidFill>
@@ -6177,7 +6177,7 @@
               <a:t>  •  </a:t>
             </a:r>
             <a:r>
-              <a:rPr sz="2200" b="1">
+              <a:rPr sz="2000" b="1">
                 <a:solidFill>
                   <a:srgbClr val="2D2D2D"/>
                 </a:solidFill>
@@ -6208,7 +6208,7 @@
               </a:spcAft>
             </a:pPr>
             <a:r>
-              <a:rPr sz="2200" b="0">
+              <a:rPr sz="2000" b="0">
                 <a:solidFill>
                   <a:srgbClr val="666666"/>
                 </a:solidFill>
@@ -6217,7 +6217,7 @@
               <a:t>  •  </a:t>
             </a:r>
             <a:r>
-              <a:rPr sz="2200" b="1">
+              <a:rPr sz="2000" b="1">
                 <a:solidFill>
                   <a:srgbClr val="2D2D2D"/>
                 </a:solidFill>
@@ -6248,7 +6248,7 @@
               </a:spcAft>
             </a:pPr>
             <a:r>
-              <a:rPr sz="2200" b="0">
+              <a:rPr sz="2000" b="0">
                 <a:solidFill>
                   <a:srgbClr val="666666"/>
                 </a:solidFill>
@@ -6257,7 +6257,7 @@
               <a:t>  •  </a:t>
             </a:r>
             <a:r>
-              <a:rPr sz="2200" b="1">
+              <a:rPr sz="2000" b="1">
                 <a:solidFill>
                   <a:srgbClr val="2D2D2D"/>
                 </a:solidFill>
@@ -6305,7 +6305,7 @@
               <a:spcAft>
                 <a:spcPts val="600"/>
               </a:spcAft>
-              <a:defRPr sz="2400" b="1">
+              <a:defRPr sz="2200" b="1">
                 <a:solidFill>
                   <a:srgbClr val="E84D60"/>
                 </a:solidFill>
@@ -6329,7 +6329,7 @@
               </a:spcAft>
             </a:pPr>
             <a:r>
-              <a:rPr sz="2200" b="0">
+              <a:rPr sz="2000" b="0">
                 <a:solidFill>
                   <a:srgbClr val="666666"/>
                 </a:solidFill>
@@ -6338,7 +6338,7 @@
               <a:t>  •  </a:t>
             </a:r>
             <a:r>
-              <a:rPr sz="2200" b="1">
+              <a:rPr sz="2000" b="1">
                 <a:solidFill>
                   <a:srgbClr val="E84D60"/>
                 </a:solidFill>
@@ -6369,7 +6369,7 @@
               </a:spcAft>
             </a:pPr>
             <a:r>
-              <a:rPr sz="2200" b="0">
+              <a:rPr sz="2000" b="0">
                 <a:solidFill>
                   <a:srgbClr val="666666"/>
                 </a:solidFill>
@@ -6378,7 +6378,7 @@
               <a:t>  •  </a:t>
             </a:r>
             <a:r>
-              <a:rPr sz="2200" b="1">
+              <a:rPr sz="2000" b="1">
                 <a:solidFill>
                   <a:srgbClr val="E84D60"/>
                 </a:solidFill>
@@ -6409,7 +6409,7 @@
               </a:spcAft>
             </a:pPr>
             <a:r>
-              <a:rPr sz="2200" b="0">
+              <a:rPr sz="2000" b="0">
                 <a:solidFill>
                   <a:srgbClr val="666666"/>
                 </a:solidFill>
@@ -6418,7 +6418,7 @@
               <a:t>  •  </a:t>
             </a:r>
             <a:r>
-              <a:rPr sz="2200" b="0">
+              <a:rPr sz="2000" b="0">
                 <a:solidFill>
                   <a:srgbClr val="2D2D2D"/>
                 </a:solidFill>
@@ -6457,7 +6457,7 @@
               <a:spcAft>
                 <a:spcPts val="600"/>
               </a:spcAft>
-              <a:defRPr sz="2400" b="1">
+              <a:defRPr sz="2200" b="1">
                 <a:solidFill>
                   <a:srgbClr val="2E86AB"/>
                 </a:solidFill>
@@ -6481,7 +6481,7 @@
               </a:spcAft>
             </a:pPr>
             <a:r>
-              <a:rPr sz="2200" b="0">
+              <a:rPr sz="2000" b="0">
                 <a:solidFill>
                   <a:srgbClr val="666666"/>
                 </a:solidFill>
@@ -6490,7 +6490,7 @@
               <a:t>  •  </a:t>
             </a:r>
             <a:r>
-              <a:rPr sz="2200" b="0">
+              <a:rPr sz="2000" b="0">
                 <a:solidFill>
                   <a:srgbClr val="2D2D2D"/>
                 </a:solidFill>
@@ -6512,7 +6512,7 @@
               </a:spcAft>
             </a:pPr>
             <a:r>
-              <a:rPr sz="2200" b="0">
+              <a:rPr sz="2000" b="0">
                 <a:solidFill>
                   <a:srgbClr val="666666"/>
                 </a:solidFill>
@@ -6521,7 +6521,7 @@
               <a:t>  •  </a:t>
             </a:r>
             <a:r>
-              <a:rPr sz="2200" b="0">
+              <a:rPr sz="2000" b="0">
                 <a:solidFill>
                   <a:srgbClr val="2D2D2D"/>
                 </a:solidFill>
@@ -6540,8 +6540,8 @@
         </p:nvSpPr>
         <p:spPr>
           <a:xfrm>
-            <a:off x="10422213" y="8480000"/>
-            <a:ext cx="9422213" cy="680000"/>
+            <a:off x="10372213" y="7310000"/>
+            <a:ext cx="9522213" cy="560000"/>
           </a:xfrm>
           <a:prstGeom prst="rect">
             <a:avLst/>
@@ -6583,8 +6583,8 @@
         </p:nvSpPr>
         <p:spPr>
           <a:xfrm>
-            <a:off x="10422213" y="8480000"/>
-            <a:ext cx="80000" cy="680000"/>
+            <a:off x="10372213" y="7310000"/>
+            <a:ext cx="70000" cy="560000"/>
           </a:xfrm>
           <a:prstGeom prst="rect">
             <a:avLst/>
@@ -6626,8 +6626,8 @@
         </p:nvSpPr>
         <p:spPr>
           <a:xfrm>
-            <a:off x="10652213" y="8580000"/>
-            <a:ext cx="9092213" cy="480000"/>
+            <a:off x="10572213" y="7385000"/>
+            <a:ext cx="9232213" cy="410000"/>
           </a:xfrm>
           <a:prstGeom prst="rect">
             <a:avLst/>
@@ -6650,7 +6650,7 @@
               <a:spcAft>
                 <a:spcPts val="0"/>
               </a:spcAft>
-              <a:defRPr sz="3600" b="1">
+              <a:defRPr sz="3200" b="1">
                 <a:solidFill>
                   <a:srgbClr val="FFFFFF"/>
                 </a:solidFill>
@@ -6671,8 +6671,8 @@
         </p:nvSpPr>
         <p:spPr>
           <a:xfrm>
-            <a:off x="10422213" y="9115000"/>
-            <a:ext cx="9422213" cy="45000"/>
+            <a:off x="10372213" y="7830000"/>
+            <a:ext cx="9522213" cy="40000"/>
           </a:xfrm>
           <a:prstGeom prst="rect">
             <a:avLst/>
@@ -6714,8 +6714,8 @@
         </p:nvSpPr>
         <p:spPr>
           <a:xfrm>
-            <a:off x="10422213" y="9160000"/>
-            <a:ext cx="9422213" cy="5800000"/>
+            <a:off x="10372213" y="7870000"/>
+            <a:ext cx="9522213" cy="5000000"/>
           </a:xfrm>
           <a:prstGeom prst="roundRect">
             <a:avLst>
@@ -6769,8 +6769,8 @@
         </p:blipFill>
         <p:spPr>
           <a:xfrm>
-            <a:off x="10552213" y="9410000"/>
-            <a:ext cx="9162213" cy="5300000"/>
+            <a:off x="10492213" y="8090000"/>
+            <a:ext cx="9282213" cy="4500000"/>
           </a:xfrm>
           <a:prstGeom prst="rect">
             <a:avLst/>
@@ -6785,8 +6785,8 @@
         </p:nvSpPr>
         <p:spPr>
           <a:xfrm>
-            <a:off x="10422213" y="15260000"/>
-            <a:ext cx="9422213" cy="680000"/>
+            <a:off x="10372213" y="13070000"/>
+            <a:ext cx="9522213" cy="560000"/>
           </a:xfrm>
           <a:prstGeom prst="rect">
             <a:avLst/>
@@ -6828,8 +6828,8 @@
         </p:nvSpPr>
         <p:spPr>
           <a:xfrm>
-            <a:off x="10422213" y="15260000"/>
-            <a:ext cx="80000" cy="680000"/>
+            <a:off x="10372213" y="13070000"/>
+            <a:ext cx="70000" cy="560000"/>
           </a:xfrm>
           <a:prstGeom prst="rect">
             <a:avLst/>
@@ -6871,8 +6871,8 @@
         </p:nvSpPr>
         <p:spPr>
           <a:xfrm>
-            <a:off x="10542213" y="15340000"/>
-            <a:ext cx="380000" cy="520000"/>
+            <a:off x="10472213" y="13130000"/>
+            <a:ext cx="340000" cy="440000"/>
           </a:xfrm>
           <a:prstGeom prst="rect">
             <a:avLst/>
@@ -6895,7 +6895,7 @@
               <a:spcAft>
                 <a:spcPts val="0"/>
               </a:spcAft>
-              <a:defRPr sz="3000" b="1">
+              <a:defRPr sz="2600" b="1">
                 <a:solidFill>
                   <a:srgbClr val="FFFFFF"/>
                 </a:solidFill>
@@ -6916,8 +6916,8 @@
         </p:nvSpPr>
         <p:spPr>
           <a:xfrm>
-            <a:off x="10842213" y="15360000"/>
-            <a:ext cx="9092213" cy="480000"/>
+            <a:off x="10752213" y="13145000"/>
+            <a:ext cx="9232213" cy="410000"/>
           </a:xfrm>
           <a:prstGeom prst="rect">
             <a:avLst/>
@@ -6940,7 +6940,7 @@
               <a:spcAft>
                 <a:spcPts val="0"/>
               </a:spcAft>
-              <a:defRPr sz="3600" b="1">
+              <a:defRPr sz="3200" b="1">
                 <a:solidFill>
                   <a:srgbClr val="FFFFFF"/>
                 </a:solidFill>
@@ -6961,8 +6961,8 @@
         </p:nvSpPr>
         <p:spPr>
           <a:xfrm>
-            <a:off x="10422213" y="15895000"/>
-            <a:ext cx="9422213" cy="45000"/>
+            <a:off x="10372213" y="13590000"/>
+            <a:ext cx="9522213" cy="40000"/>
           </a:xfrm>
           <a:prstGeom prst="rect">
             <a:avLst/>
@@ -7004,8 +7004,8 @@
         </p:nvSpPr>
         <p:spPr>
           <a:xfrm>
-            <a:off x="10422213" y="15940000"/>
-            <a:ext cx="9422213" cy="4400000"/>
+            <a:off x="10372213" y="13630000"/>
+            <a:ext cx="9522213" cy="3800000"/>
           </a:xfrm>
           <a:prstGeom prst="roundRect">
             <a:avLst>
@@ -7051,8 +7051,8 @@
         </p:nvSpPr>
         <p:spPr>
           <a:xfrm>
-            <a:off x="10622213" y="16070000"/>
-            <a:ext cx="9022213" cy="4180000"/>
+            <a:off x="10552213" y="13760000"/>
+            <a:ext cx="9162213" cy="3580000"/>
           </a:xfrm>
           <a:prstGeom prst="rect">
             <a:avLst/>
@@ -7077,7 +7077,7 @@
               </a:spcAft>
             </a:pPr>
             <a:r>
-              <a:rPr sz="2400" b="1">
+              <a:rPr sz="2200" b="1">
                 <a:solidFill>
                   <a:srgbClr val="1B3A5C"/>
                 </a:solidFill>
@@ -7086,7 +7086,7 @@
               <a:t>Model</a:t>
             </a:r>
             <a:r>
-              <a:rPr sz="2400" b="0">
+              <a:rPr sz="2200" b="0">
                 <a:solidFill>
                   <a:srgbClr val="2D2D2D"/>
                 </a:solidFill>
@@ -7095,7 +7095,7 @@
               <a:t>                        </a:t>
             </a:r>
             <a:r>
-              <a:rPr sz="2400" b="1">
+              <a:rPr sz="2200" b="1">
                 <a:solidFill>
                   <a:srgbClr val="1B3A5C"/>
                 </a:solidFill>
@@ -7104,7 +7104,7 @@
               <a:t>Macro F1</a:t>
             </a:r>
             <a:r>
-              <a:rPr sz="2400" b="0">
+              <a:rPr sz="2200" b="0">
                 <a:solidFill>
                   <a:srgbClr val="2D2D2D"/>
                 </a:solidFill>
@@ -7113,7 +7113,7 @@
               <a:t>       </a:t>
             </a:r>
             <a:r>
-              <a:rPr sz="2400" b="1">
+              <a:rPr sz="2200" b="1">
                 <a:solidFill>
                   <a:srgbClr val="1B3A5C"/>
                 </a:solidFill>
@@ -7133,7 +7133,7 @@
               <a:spcAft>
                 <a:spcPts val="600"/>
               </a:spcAft>
-              <a:defRPr sz="2000" b="0">
+              <a:defRPr sz="1800" b="0">
                 <a:solidFill>
                   <a:srgbClr val="DDDDDD"/>
                 </a:solidFill>
@@ -7157,31 +7157,275 @@
               </a:spcAft>
             </a:pPr>
             <a:r>
+              <a:rPr sz="2000" b="0">
+                <a:solidFill>
+                  <a:srgbClr val="666666"/>
+                </a:solidFill>
+                <a:latin typeface="Calibri"/>
+              </a:rPr>
+              <a:t>SVM Baseline             </a:t>
+            </a:r>
+            <a:r>
+              <a:rPr sz="2000" b="0">
+                <a:solidFill>
+                  <a:srgbClr val="666666"/>
+                </a:solidFill>
+                <a:latin typeface="Calibri"/>
+              </a:rPr>
+              <a:t>0.5610</a:t>
+            </a:r>
+            <a:r>
+              <a:rPr sz="2000" b="0">
+                <a:solidFill>
+                  <a:srgbClr val="BBBBBB"/>
+                </a:solidFill>
+                <a:latin typeface="Calibri"/>
+              </a:rPr>
+              <a:t>           —</a:t>
+            </a:r>
+          </a:p>
+          <a:p>
+            <a:pPr algn="l">
+              <a:lnSpc>
+                <a:spcPct val="115000"/>
+              </a:lnSpc>
+              <a:spcBef>
+                <a:spcPts val="0"/>
+              </a:spcBef>
+              <a:spcAft>
+                <a:spcPts val="400"/>
+              </a:spcAft>
+            </a:pPr>
+            <a:r>
+              <a:rPr sz="2000" b="0">
+                <a:solidFill>
+                  <a:srgbClr val="666666"/>
+                </a:solidFill>
+                <a:latin typeface="Calibri"/>
+              </a:rPr>
+              <a:t>LSTM Baseline            </a:t>
+            </a:r>
+            <a:r>
+              <a:rPr sz="2000" b="0">
+                <a:solidFill>
+                  <a:srgbClr val="666666"/>
+                </a:solidFill>
+                <a:latin typeface="Calibri"/>
+              </a:rPr>
+              <a:t>0.6226</a:t>
+            </a:r>
+            <a:r>
+              <a:rPr sz="2000" b="0">
+                <a:solidFill>
+                  <a:srgbClr val="BBBBBB"/>
+                </a:solidFill>
+                <a:latin typeface="Calibri"/>
+              </a:rPr>
+              <a:t>           —</a:t>
+            </a:r>
+          </a:p>
+          <a:p>
+            <a:pPr algn="l">
+              <a:lnSpc>
+                <a:spcPct val="115000"/>
+              </a:lnSpc>
+              <a:spcBef>
+                <a:spcPts val="0"/>
+              </a:spcBef>
+              <a:spcAft>
+                <a:spcPts val="600"/>
+              </a:spcAft>
+            </a:pPr>
+            <a:r>
+              <a:rPr sz="2000" b="0">
+                <a:solidFill>
+                  <a:srgbClr val="666666"/>
+                </a:solidFill>
+                <a:latin typeface="Calibri"/>
+              </a:rPr>
+              <a:t>BERT Baseline            </a:t>
+            </a:r>
+            <a:r>
+              <a:rPr sz="2000" b="0">
+                <a:solidFill>
+                  <a:srgbClr val="666666"/>
+                </a:solidFill>
+                <a:latin typeface="Calibri"/>
+              </a:rPr>
+              <a:t>0.7854</a:t>
+            </a:r>
+            <a:r>
+              <a:rPr sz="2000" b="0">
+                <a:solidFill>
+                  <a:srgbClr val="BBBBBB"/>
+                </a:solidFill>
+                <a:latin typeface="Calibri"/>
+              </a:rPr>
+              <a:t>           —</a:t>
+            </a:r>
+          </a:p>
+          <a:p>
+            <a:pPr algn="l">
+              <a:lnSpc>
+                <a:spcPct val="115000"/>
+              </a:lnSpc>
+              <a:spcBef>
+                <a:spcPts val="0"/>
+              </a:spcBef>
+              <a:spcAft>
+                <a:spcPts val="600"/>
+              </a:spcAft>
+              <a:defRPr sz="1800" b="0">
+                <a:solidFill>
+                  <a:srgbClr val="DDDDDD"/>
+                </a:solidFill>
+                <a:latin typeface="Calibri"/>
+              </a:defRPr>
+            </a:pPr>
+            <a:r>
+              <a:t>──────────────────────────────────────────────────</a:t>
+            </a:r>
+          </a:p>
+          <a:p>
+            <a:pPr algn="l">
+              <a:lnSpc>
+                <a:spcPct val="115000"/>
+              </a:lnSpc>
+              <a:spcBef>
+                <a:spcPts val="0"/>
+              </a:spcBef>
+              <a:spcAft>
+                <a:spcPts val="600"/>
+              </a:spcAft>
+            </a:pPr>
+            <a:r>
+              <a:rPr sz="2200" b="1">
+                <a:solidFill>
+                  <a:srgbClr val="27AE60"/>
+                </a:solidFill>
+                <a:latin typeface="Calibri"/>
+              </a:rPr>
+              <a:t>★ Sol 1 (Cat A)      </a:t>
+            </a:r>
+            <a:r>
+              <a:rPr sz="2200" b="1">
+                <a:solidFill>
+                  <a:srgbClr val="27AE60"/>
+                </a:solidFill>
+                <a:latin typeface="Calibri"/>
+              </a:rPr>
+              <a:t>0.7340</a:t>
+            </a:r>
+            <a:r>
               <a:rPr sz="2200" b="0">
                 <a:solidFill>
+                  <a:srgbClr val="2D2D2D"/>
+                </a:solidFill>
+                <a:latin typeface="Calibri"/>
+              </a:rPr>
+              <a:t>     </a:t>
+            </a:r>
+            <a:r>
+              <a:rPr sz="2200" b="1">
+                <a:solidFill>
+                  <a:srgbClr val="27AE60"/>
+                </a:solidFill>
+                <a:latin typeface="Calibri"/>
+              </a:rPr>
+              <a:t>+30.8% vs SVM ***</a:t>
+            </a:r>
+          </a:p>
+          <a:p>
+            <a:pPr algn="l">
+              <a:lnSpc>
+                <a:spcPct val="115000"/>
+              </a:lnSpc>
+              <a:spcBef>
+                <a:spcPts val="0"/>
+              </a:spcBef>
+              <a:spcAft>
+                <a:spcPts val="800"/>
+              </a:spcAft>
+            </a:pPr>
+            <a:r>
+              <a:rPr sz="2200" b="1">
+                <a:solidFill>
+                  <a:srgbClr val="E67E22"/>
+                </a:solidFill>
+                <a:latin typeface="Calibri"/>
+              </a:rPr>
+              <a:t>★ Sol 2 (Cat B)      </a:t>
+            </a:r>
+            <a:r>
+              <a:rPr sz="2200" b="1">
+                <a:solidFill>
+                  <a:srgbClr val="E67E22"/>
+                </a:solidFill>
+                <a:latin typeface="Calibri"/>
+              </a:rPr>
+              <a:t>0.7422</a:t>
+            </a:r>
+            <a:r>
+              <a:rPr sz="2200" b="0">
+                <a:solidFill>
+                  <a:srgbClr val="2D2D2D"/>
+                </a:solidFill>
+                <a:latin typeface="Calibri"/>
+              </a:rPr>
+              <a:t>     </a:t>
+            </a:r>
+            <a:r>
+              <a:rPr sz="2200" b="1">
+                <a:solidFill>
+                  <a:srgbClr val="E67E22"/>
+                </a:solidFill>
+                <a:latin typeface="Calibri"/>
+              </a:rPr>
+              <a:t>+19.2% vs LSTM ***</a:t>
+            </a:r>
+          </a:p>
+          <a:p>
+            <a:pPr algn="l">
+              <a:lnSpc>
+                <a:spcPct val="115000"/>
+              </a:lnSpc>
+              <a:spcBef>
+                <a:spcPts val="0"/>
+              </a:spcBef>
+              <a:spcAft>
+                <a:spcPts val="600"/>
+              </a:spcAft>
+              <a:defRPr sz="1800" b="0">
+                <a:solidFill>
+                  <a:srgbClr val="DDDDDD"/>
+                </a:solidFill>
+                <a:latin typeface="Calibri"/>
+              </a:defRPr>
+            </a:pPr>
+            <a:r>
+              <a:t>──────────────────────────────────────────────────</a:t>
+            </a:r>
+          </a:p>
+          <a:p>
+            <a:pPr algn="l">
+              <a:lnSpc>
+                <a:spcPct val="115000"/>
+              </a:lnSpc>
+              <a:spcBef>
+                <a:spcPts val="0"/>
+              </a:spcBef>
+              <a:spcAft>
+                <a:spcPts val="400"/>
+              </a:spcAft>
+              <a:defRPr sz="1800" b="0" i="1">
+                <a:solidFill>
                   <a:srgbClr val="666666"/>
                 </a:solidFill>
                 <a:latin typeface="Calibri"/>
-              </a:rPr>
-              <a:t>SVM Baseline             </a:t>
-            </a:r>
-            <a:r>
-              <a:rPr sz="2200" b="0">
-                <a:solidFill>
-                  <a:srgbClr val="666666"/>
-                </a:solidFill>
-                <a:latin typeface="Calibri"/>
-              </a:rPr>
-              <a:t>0.5610</a:t>
-            </a:r>
-            <a:r>
-              <a:rPr sz="2200" b="0">
-                <a:solidFill>
-                  <a:srgbClr val="BBBBBB"/>
-                </a:solidFill>
-                <a:latin typeface="Calibri"/>
-              </a:rPr>
-              <a:t>           —</a:t>
+              </a:defRPr>
+            </a:pPr>
+            <a:r>
+              <a:t>*** p &lt; 0.001, McNemar’s test</a:t>
             </a:r>
           </a:p>
           <a:p>
@@ -7195,251 +7439,7 @@
               <a:spcAft>
                 <a:spcPts val="400"/>
               </a:spcAft>
-            </a:pPr>
-            <a:r>
-              <a:rPr sz="2200" b="0">
-                <a:solidFill>
-                  <a:srgbClr val="666666"/>
-                </a:solidFill>
-                <a:latin typeface="Calibri"/>
-              </a:rPr>
-              <a:t>LSTM Baseline            </a:t>
-            </a:r>
-            <a:r>
-              <a:rPr sz="2200" b="0">
-                <a:solidFill>
-                  <a:srgbClr val="666666"/>
-                </a:solidFill>
-                <a:latin typeface="Calibri"/>
-              </a:rPr>
-              <a:t>0.6226</a:t>
-            </a:r>
-            <a:r>
-              <a:rPr sz="2200" b="0">
-                <a:solidFill>
-                  <a:srgbClr val="BBBBBB"/>
-                </a:solidFill>
-                <a:latin typeface="Calibri"/>
-              </a:rPr>
-              <a:t>           —</a:t>
-            </a:r>
-          </a:p>
-          <a:p>
-            <a:pPr algn="l">
-              <a:lnSpc>
-                <a:spcPct val="115000"/>
-              </a:lnSpc>
-              <a:spcBef>
-                <a:spcPts val="0"/>
-              </a:spcBef>
-              <a:spcAft>
-                <a:spcPts val="600"/>
-              </a:spcAft>
-            </a:pPr>
-            <a:r>
-              <a:rPr sz="2200" b="0">
-                <a:solidFill>
-                  <a:srgbClr val="666666"/>
-                </a:solidFill>
-                <a:latin typeface="Calibri"/>
-              </a:rPr>
-              <a:t>BERT Baseline            </a:t>
-            </a:r>
-            <a:r>
-              <a:rPr sz="2200" b="0">
-                <a:solidFill>
-                  <a:srgbClr val="666666"/>
-                </a:solidFill>
-                <a:latin typeface="Calibri"/>
-              </a:rPr>
-              <a:t>0.7854</a:t>
-            </a:r>
-            <a:r>
-              <a:rPr sz="2200" b="0">
-                <a:solidFill>
-                  <a:srgbClr val="BBBBBB"/>
-                </a:solidFill>
-                <a:latin typeface="Calibri"/>
-              </a:rPr>
-              <a:t>           —</a:t>
-            </a:r>
-          </a:p>
-          <a:p>
-            <a:pPr algn="l">
-              <a:lnSpc>
-                <a:spcPct val="115000"/>
-              </a:lnSpc>
-              <a:spcBef>
-                <a:spcPts val="0"/>
-              </a:spcBef>
-              <a:spcAft>
-                <a:spcPts val="600"/>
-              </a:spcAft>
-              <a:defRPr sz="2000" b="0">
-                <a:solidFill>
-                  <a:srgbClr val="DDDDDD"/>
-                </a:solidFill>
-                <a:latin typeface="Calibri"/>
-              </a:defRPr>
-            </a:pPr>
-            <a:r>
-              <a:t>──────────────────────────────────────────────────</a:t>
-            </a:r>
-          </a:p>
-          <a:p>
-            <a:pPr algn="l">
-              <a:lnSpc>
-                <a:spcPct val="115000"/>
-              </a:lnSpc>
-              <a:spcBef>
-                <a:spcPts val="0"/>
-              </a:spcBef>
-              <a:spcAft>
-                <a:spcPts val="600"/>
-              </a:spcAft>
-            </a:pPr>
-            <a:r>
-              <a:rPr sz="2400" b="1">
-                <a:solidFill>
-                  <a:srgbClr val="27AE60"/>
-                </a:solidFill>
-                <a:latin typeface="Calibri"/>
-              </a:rPr>
-              <a:t>★ Sol 1 (Cat A)      </a:t>
-            </a:r>
-            <a:r>
-              <a:rPr sz="2400" b="1">
-                <a:solidFill>
-                  <a:srgbClr val="27AE60"/>
-                </a:solidFill>
-                <a:latin typeface="Calibri"/>
-              </a:rPr>
-              <a:t>0.7340</a:t>
-            </a:r>
-            <a:r>
-              <a:rPr sz="2400" b="0">
-                <a:solidFill>
-                  <a:srgbClr val="2D2D2D"/>
-                </a:solidFill>
-                <a:latin typeface="Calibri"/>
-              </a:rPr>
-              <a:t>     </a:t>
-            </a:r>
-            <a:r>
-              <a:rPr sz="2400" b="1">
-                <a:solidFill>
-                  <a:srgbClr val="27AE60"/>
-                </a:solidFill>
-                <a:latin typeface="Calibri"/>
-              </a:rPr>
-              <a:t>+30.8% vs SVM ***</a:t>
-            </a:r>
-          </a:p>
-          <a:p>
-            <a:pPr algn="l">
-              <a:lnSpc>
-                <a:spcPct val="115000"/>
-              </a:lnSpc>
-              <a:spcBef>
-                <a:spcPts val="0"/>
-              </a:spcBef>
-              <a:spcAft>
-                <a:spcPts val="800"/>
-              </a:spcAft>
-            </a:pPr>
-            <a:r>
-              <a:rPr sz="2400" b="1">
-                <a:solidFill>
-                  <a:srgbClr val="E67E22"/>
-                </a:solidFill>
-                <a:latin typeface="Calibri"/>
-              </a:rPr>
-              <a:t>★ Sol 2 (Cat B)      </a:t>
-            </a:r>
-            <a:r>
-              <a:rPr sz="2400" b="1">
-                <a:solidFill>
-                  <a:srgbClr val="E67E22"/>
-                </a:solidFill>
-                <a:latin typeface="Calibri"/>
-              </a:rPr>
-              <a:t>0.7422</a:t>
-            </a:r>
-            <a:r>
-              <a:rPr sz="2400" b="0">
-                <a:solidFill>
-                  <a:srgbClr val="2D2D2D"/>
-                </a:solidFill>
-                <a:latin typeface="Calibri"/>
-              </a:rPr>
-              <a:t>     </a:t>
-            </a:r>
-            <a:r>
-              <a:rPr sz="2400" b="1">
-                <a:solidFill>
-                  <a:srgbClr val="E67E22"/>
-                </a:solidFill>
-                <a:latin typeface="Calibri"/>
-              </a:rPr>
-              <a:t>+19.2% vs LSTM ***</a:t>
-            </a:r>
-          </a:p>
-          <a:p>
-            <a:pPr algn="l">
-              <a:lnSpc>
-                <a:spcPct val="115000"/>
-              </a:lnSpc>
-              <a:spcBef>
-                <a:spcPts val="0"/>
-              </a:spcBef>
-              <a:spcAft>
-                <a:spcPts val="600"/>
-              </a:spcAft>
-              <a:defRPr sz="2000" b="0">
-                <a:solidFill>
-                  <a:srgbClr val="DDDDDD"/>
-                </a:solidFill>
-                <a:latin typeface="Calibri"/>
-              </a:defRPr>
-            </a:pPr>
-            <a:r>
-              <a:t>──────────────────────────────────────────────────</a:t>
-            </a:r>
-          </a:p>
-          <a:p>
-            <a:pPr algn="l">
-              <a:lnSpc>
-                <a:spcPct val="115000"/>
-              </a:lnSpc>
-              <a:spcBef>
-                <a:spcPts val="0"/>
-              </a:spcBef>
-              <a:spcAft>
-                <a:spcPts val="400"/>
-              </a:spcAft>
-              <a:defRPr sz="2000" b="0" i="1">
-                <a:solidFill>
-                  <a:srgbClr val="666666"/>
-                </a:solidFill>
-                <a:latin typeface="Calibri"/>
-              </a:defRPr>
-            </a:pPr>
-            <a:r>
-              <a:t>*** p &lt; 0.001, McNemar’s test</a:t>
-            </a:r>
-          </a:p>
-          <a:p>
-            <a:pPr algn="l">
-              <a:lnSpc>
-                <a:spcPct val="115000"/>
-              </a:lnSpc>
-              <a:spcBef>
-                <a:spcPts val="0"/>
-              </a:spcBef>
-              <a:spcAft>
-                <a:spcPts val="400"/>
-              </a:spcAft>
-              <a:defRPr sz="2000" b="0">
+              <a:defRPr sz="1800" b="0">
                 <a:solidFill>
                   <a:srgbClr val="666666"/>
                 </a:solidFill>
@@ -7460,8 +7460,8 @@
         </p:nvSpPr>
         <p:spPr>
           <a:xfrm>
-            <a:off x="10422213" y="20640000"/>
-            <a:ext cx="9422213" cy="680000"/>
+            <a:off x="10372213" y="17630000"/>
+            <a:ext cx="9522213" cy="560000"/>
           </a:xfrm>
           <a:prstGeom prst="rect">
             <a:avLst/>
@@ -7503,8 +7503,8 @@
         </p:nvSpPr>
         <p:spPr>
           <a:xfrm>
-            <a:off x="10422213" y="20640000"/>
-            <a:ext cx="80000" cy="680000"/>
+            <a:off x="10372213" y="17630000"/>
+            <a:ext cx="70000" cy="560000"/>
           </a:xfrm>
           <a:prstGeom prst="rect">
             <a:avLst/>
@@ -7546,8 +7546,8 @@
         </p:nvSpPr>
         <p:spPr>
           <a:xfrm>
-            <a:off x="10542213" y="20720000"/>
-            <a:ext cx="380000" cy="520000"/>
+            <a:off x="10472213" y="17690000"/>
+            <a:ext cx="340000" cy="440000"/>
           </a:xfrm>
           <a:prstGeom prst="rect">
             <a:avLst/>
@@ -7570,7 +7570,7 @@
               <a:spcAft>
                 <a:spcPts val="0"/>
               </a:spcAft>
-              <a:defRPr sz="3000" b="1">
+              <a:defRPr sz="2600" b="1">
                 <a:solidFill>
                   <a:srgbClr val="FFFFFF"/>
                 </a:solidFill>
@@ -7591,8 +7591,8 @@
         </p:nvSpPr>
         <p:spPr>
           <a:xfrm>
-            <a:off x="10842213" y="20740000"/>
-            <a:ext cx="9092213" cy="480000"/>
+            <a:off x="10752213" y="17705000"/>
+            <a:ext cx="9232213" cy="410000"/>
           </a:xfrm>
           <a:prstGeom prst="rect">
             <a:avLst/>
@@ -7615,7 +7615,7 @@
               <a:spcAft>
                 <a:spcPts val="0"/>
               </a:spcAft>
-              <a:defRPr sz="3600" b="1">
+              <a:defRPr sz="3200" b="1">
                 <a:solidFill>
                   <a:srgbClr val="FFFFFF"/>
                 </a:solidFill>
@@ -7636,8 +7636,8 @@
         </p:nvSpPr>
         <p:spPr>
           <a:xfrm>
-            <a:off x="10422213" y="21275000"/>
-            <a:ext cx="9422213" cy="45000"/>
+            <a:off x="10372213" y="18150000"/>
+            <a:ext cx="9522213" cy="40000"/>
           </a:xfrm>
           <a:prstGeom prst="rect">
             <a:avLst/>
@@ -7679,8 +7679,8 @@
         </p:nvSpPr>
         <p:spPr>
           <a:xfrm>
-            <a:off x="10422213" y="21320000"/>
-            <a:ext cx="9422213" cy="2600000"/>
+            <a:off x="10372213" y="18190000"/>
+            <a:ext cx="9522213" cy="2400000"/>
           </a:xfrm>
           <a:prstGeom prst="roundRect">
             <a:avLst>
@@ -7726,8 +7726,8 @@
         </p:nvSpPr>
         <p:spPr>
           <a:xfrm>
-            <a:off x="10622213" y="21450000"/>
-            <a:ext cx="9022213" cy="2380000"/>
+            <a:off x="10552213" y="18320000"/>
+            <a:ext cx="9162213" cy="2180000"/>
           </a:xfrm>
           <a:prstGeom prst="rect">
             <a:avLst/>
@@ -7750,7 +7750,7 @@
               <a:spcAft>
                 <a:spcPts val="400"/>
               </a:spcAft>
-              <a:defRPr sz="2400" b="1">
+              <a:defRPr sz="2200" b="1">
                 <a:solidFill>
                   <a:srgbClr val="2E86AB"/>
                 </a:solidFill>
@@ -7774,7 +7774,7 @@
               </a:spcAft>
             </a:pPr>
             <a:r>
-              <a:rPr sz="2200" b="0">
+              <a:rPr sz="2000" b="0">
                 <a:solidFill>
                   <a:srgbClr val="666666"/>
                 </a:solidFill>
@@ -7783,7 +7783,7 @@
               <a:t>  •  </a:t>
             </a:r>
             <a:r>
-              <a:rPr sz="2200" b="0">
+              <a:rPr sz="2000" b="0">
                 <a:solidFill>
                   <a:srgbClr val="2D2D2D"/>
                 </a:solidFill>
@@ -7822,7 +7822,7 @@
               <a:spcAft>
                 <a:spcPts val="400"/>
               </a:spcAft>
-              <a:defRPr sz="2400" b="1">
+              <a:defRPr sz="2200" b="1">
                 <a:solidFill>
                   <a:srgbClr val="2E86AB"/>
                 </a:solidFill>
@@ -7846,7 +7846,7 @@
               </a:spcAft>
             </a:pPr>
             <a:r>
-              <a:rPr sz="2200" b="0">
+              <a:rPr sz="2000" b="0">
                 <a:solidFill>
                   <a:srgbClr val="666666"/>
                 </a:solidFill>
@@ -7855,7 +7855,7 @@
               <a:t>  •  </a:t>
             </a:r>
             <a:r>
-              <a:rPr sz="2200" b="0">
+              <a:rPr sz="2000" b="0">
                 <a:solidFill>
                   <a:srgbClr val="2D2D2D"/>
                 </a:solidFill>
@@ -7894,7 +7894,7 @@
               <a:spcAft>
                 <a:spcPts val="400"/>
               </a:spcAft>
-              <a:defRPr sz="2400" b="1">
+              <a:defRPr sz="2200" b="1">
                 <a:solidFill>
                   <a:srgbClr val="2E86AB"/>
                 </a:solidFill>
@@ -7918,7 +7918,7 @@
               </a:spcAft>
             </a:pPr>
             <a:r>
-              <a:rPr sz="2200" b="0">
+              <a:rPr sz="2000" b="0">
                 <a:solidFill>
                   <a:srgbClr val="666666"/>
                 </a:solidFill>
@@ -7927,7 +7927,7 @@
               <a:t>  •  </a:t>
             </a:r>
             <a:r>
-              <a:rPr sz="2200" b="0">
+              <a:rPr sz="2000" b="0">
                 <a:solidFill>
                   <a:srgbClr val="2D2D2D"/>
                 </a:solidFill>
@@ -7949,7 +7949,7 @@
               </a:spcAft>
             </a:pPr>
             <a:r>
-              <a:rPr sz="2200" b="0">
+              <a:rPr sz="2000" b="0">
                 <a:solidFill>
                   <a:srgbClr val="666666"/>
                 </a:solidFill>
@@ -7958,7 +7958,7 @@
               <a:t>  •  </a:t>
             </a:r>
             <a:r>
-              <a:rPr sz="2200" b="0">
+              <a:rPr sz="2000" b="0">
                 <a:solidFill>
                   <a:srgbClr val="2D2D2D"/>
                 </a:solidFill>
@@ -7977,8 +7977,8 @@
         </p:nvSpPr>
         <p:spPr>
           <a:xfrm>
-            <a:off x="20244426" y="2700000"/>
-            <a:ext cx="9422213" cy="680000"/>
+            <a:off x="20244426" y="2350000"/>
+            <a:ext cx="9522213" cy="560000"/>
           </a:xfrm>
           <a:prstGeom prst="rect">
             <a:avLst/>
@@ -8020,8 +8020,8 @@
         </p:nvSpPr>
         <p:spPr>
           <a:xfrm>
-            <a:off x="20244426" y="2700000"/>
-            <a:ext cx="80000" cy="680000"/>
+            <a:off x="20244426" y="2350000"/>
+            <a:ext cx="70000" cy="560000"/>
           </a:xfrm>
           <a:prstGeom prst="rect">
             <a:avLst/>
@@ -8063,8 +8063,8 @@
         </p:nvSpPr>
         <p:spPr>
           <a:xfrm>
-            <a:off x="20364426" y="2780000"/>
-            <a:ext cx="380000" cy="520000"/>
+            <a:off x="20344426" y="2410000"/>
+            <a:ext cx="340000" cy="440000"/>
           </a:xfrm>
           <a:prstGeom prst="rect">
             <a:avLst/>
@@ -8087,7 +8087,7 @@
               <a:spcAft>
                 <a:spcPts val="0"/>
               </a:spcAft>
-              <a:defRPr sz="3000" b="1">
+              <a:defRPr sz="2600" b="1">
                 <a:solidFill>
                   <a:srgbClr val="FFFFFF"/>
                 </a:solidFill>
@@ -8108,8 +8108,8 @@
         </p:nvSpPr>
         <p:spPr>
           <a:xfrm>
-            <a:off x="20664426" y="2800000"/>
-            <a:ext cx="9092213" cy="480000"/>
+            <a:off x="20624426" y="2425000"/>
+            <a:ext cx="9232213" cy="410000"/>
           </a:xfrm>
           <a:prstGeom prst="rect">
             <a:avLst/>
@@ -8132,7 +8132,7 @@
               <a:spcAft>
                 <a:spcPts val="0"/>
               </a:spcAft>
-              <a:defRPr sz="3600" b="1">
+              <a:defRPr sz="3200" b="1">
                 <a:solidFill>
                   <a:srgbClr val="FFFFFF"/>
                 </a:solidFill>
@@ -8153,8 +8153,8 @@
         </p:nvSpPr>
         <p:spPr>
           <a:xfrm>
-            <a:off x="20244426" y="3335000"/>
-            <a:ext cx="9422213" cy="45000"/>
+            <a:off x="20244426" y="2870000"/>
+            <a:ext cx="9522213" cy="40000"/>
           </a:xfrm>
           <a:prstGeom prst="rect">
             <a:avLst/>
@@ -8196,8 +8196,8 @@
         </p:nvSpPr>
         <p:spPr>
           <a:xfrm>
-            <a:off x="20244426" y="3380000"/>
-            <a:ext cx="9422213" cy="4600000"/>
+            <a:off x="20244426" y="2910000"/>
+            <a:ext cx="9522213" cy="3800000"/>
           </a:xfrm>
           <a:prstGeom prst="roundRect">
             <a:avLst>
@@ -8251,8 +8251,8 @@
         </p:blipFill>
         <p:spPr>
           <a:xfrm>
-            <a:off x="20424426" y="3680000"/>
-            <a:ext cx="9062213" cy="4000000"/>
+            <a:off x="20394426" y="3160000"/>
+            <a:ext cx="9222213" cy="3300000"/>
           </a:xfrm>
           <a:prstGeom prst="rect">
             <a:avLst/>
@@ -8267,8 +8267,8 @@
         </p:nvSpPr>
         <p:spPr>
           <a:xfrm>
-            <a:off x="20244426" y="8280000"/>
-            <a:ext cx="9422213" cy="680000"/>
+            <a:off x="20244426" y="6910000"/>
+            <a:ext cx="9522213" cy="560000"/>
           </a:xfrm>
           <a:prstGeom prst="rect">
             <a:avLst/>
@@ -8310,8 +8310,8 @@
         </p:nvSpPr>
         <p:spPr>
           <a:xfrm>
-            <a:off x="20244426" y="8280000"/>
-            <a:ext cx="80000" cy="680000"/>
+            <a:off x="20244426" y="6910000"/>
+            <a:ext cx="70000" cy="560000"/>
           </a:xfrm>
           <a:prstGeom prst="rect">
             <a:avLst/>
@@ -8353,8 +8353,8 @@
         </p:nvSpPr>
         <p:spPr>
           <a:xfrm>
-            <a:off x="20474426" y="8380000"/>
-            <a:ext cx="9092213" cy="480000"/>
+            <a:off x="20444426" y="6985000"/>
+            <a:ext cx="9232213" cy="410000"/>
           </a:xfrm>
           <a:prstGeom prst="rect">
             <a:avLst/>
@@ -8377,7 +8377,7 @@
               <a:spcAft>
                 <a:spcPts val="0"/>
               </a:spcAft>
-              <a:defRPr sz="3600" b="1">
+              <a:defRPr sz="3200" b="1">
                 <a:solidFill>
                   <a:srgbClr val="FFFFFF"/>
                 </a:solidFill>
@@ -8398,8 +8398,8 @@
         </p:nvSpPr>
         <p:spPr>
           <a:xfrm>
-            <a:off x="20244426" y="8915000"/>
-            <a:ext cx="9422213" cy="45000"/>
+            <a:off x="20244426" y="7430000"/>
+            <a:ext cx="9522213" cy="40000"/>
           </a:xfrm>
           <a:prstGeom prst="rect">
             <a:avLst/>
@@ -8441,8 +8441,8 @@
         </p:nvSpPr>
         <p:spPr>
           <a:xfrm>
-            <a:off x="20244426" y="8960000"/>
-            <a:ext cx="9422213" cy="3800000"/>
+            <a:off x="20244426" y="7470000"/>
+            <a:ext cx="9522213" cy="3200000"/>
           </a:xfrm>
           <a:prstGeom prst="roundRect">
             <a:avLst>
@@ -8496,8 +8496,8 @@
         </p:blipFill>
         <p:spPr>
           <a:xfrm>
-            <a:off x="20344426" y="9260000"/>
-            <a:ext cx="9222213" cy="3200000"/>
+            <a:off x="20344426" y="7720000"/>
+            <a:ext cx="9322213" cy="2700000"/>
           </a:xfrm>
           <a:prstGeom prst="rect">
             <a:avLst/>
@@ -8512,8 +8512,8 @@
         </p:nvSpPr>
         <p:spPr>
           <a:xfrm>
-            <a:off x="20244426" y="13060000"/>
-            <a:ext cx="9422213" cy="680000"/>
+            <a:off x="20244426" y="10870000"/>
+            <a:ext cx="9522213" cy="560000"/>
           </a:xfrm>
           <a:prstGeom prst="rect">
             <a:avLst/>
@@ -8555,8 +8555,8 @@
         </p:nvSpPr>
         <p:spPr>
           <a:xfrm>
-            <a:off x="20244426" y="13060000"/>
-            <a:ext cx="80000" cy="680000"/>
+            <a:off x="20244426" y="10870000"/>
+            <a:ext cx="70000" cy="560000"/>
           </a:xfrm>
           <a:prstGeom prst="rect">
             <a:avLst/>
@@ -8598,8 +8598,8 @@
         </p:nvSpPr>
         <p:spPr>
           <a:xfrm>
-            <a:off x="20364426" y="13140000"/>
-            <a:ext cx="380000" cy="520000"/>
+            <a:off x="20344426" y="10930000"/>
+            <a:ext cx="340000" cy="440000"/>
           </a:xfrm>
           <a:prstGeom prst="rect">
             <a:avLst/>
@@ -8622,7 +8622,7 @@
               <a:spcAft>
                 <a:spcPts val="0"/>
               </a:spcAft>
-              <a:defRPr sz="3000" b="1">
+              <a:defRPr sz="2600" b="1">
                 <a:solidFill>
                   <a:srgbClr val="FFFFFF"/>
                 </a:solidFill>
@@ -8643,8 +8643,8 @@
         </p:nvSpPr>
         <p:spPr>
           <a:xfrm>
-            <a:off x="20664426" y="13160000"/>
-            <a:ext cx="9092213" cy="480000"/>
+            <a:off x="20624426" y="10945000"/>
+            <a:ext cx="9232213" cy="410000"/>
           </a:xfrm>
           <a:prstGeom prst="rect">
             <a:avLst/>
@@ -8667,7 +8667,7 @@
               <a:spcAft>
                 <a:spcPts val="0"/>
               </a:spcAft>
-              <a:defRPr sz="3600" b="1">
+              <a:defRPr sz="3200" b="1">
                 <a:solidFill>
                   <a:srgbClr val="FFFFFF"/>
                 </a:solidFill>
@@ -8688,8 +8688,8 @@
         </p:nvSpPr>
         <p:spPr>
           <a:xfrm>
-            <a:off x="20244426" y="13695000"/>
-            <a:ext cx="9422213" cy="45000"/>
+            <a:off x="20244426" y="11390000"/>
+            <a:ext cx="9522213" cy="40000"/>
           </a:xfrm>
           <a:prstGeom prst="rect">
             <a:avLst/>
@@ -8731,8 +8731,8 @@
         </p:nvSpPr>
         <p:spPr>
           <a:xfrm>
-            <a:off x="20244426" y="13740000"/>
-            <a:ext cx="9422213" cy="4000000"/>
+            <a:off x="20244426" y="11430000"/>
+            <a:ext cx="9522213" cy="3500000"/>
           </a:xfrm>
           <a:prstGeom prst="roundRect">
             <a:avLst>
@@ -8778,8 +8778,8 @@
         </p:nvSpPr>
         <p:spPr>
           <a:xfrm>
-            <a:off x="20444426" y="13870000"/>
-            <a:ext cx="9022213" cy="3780000"/>
+            <a:off x="20424426" y="11560000"/>
+            <a:ext cx="9162213" cy="3280000"/>
           </a:xfrm>
           <a:prstGeom prst="rect">
             <a:avLst/>
@@ -8804,7 +8804,7 @@
               </a:spcAft>
             </a:pPr>
             <a:r>
-              <a:rPr sz="2400" b="1">
+              <a:rPr sz="2200" b="1">
                 <a:solidFill>
                   <a:srgbClr val="2E86AB"/>
                 </a:solidFill>
@@ -8813,7 +8813,7 @@
               <a:t>Inter-model agreement: </a:t>
             </a:r>
             <a:r>
-              <a:rPr sz="2400" b="0">
+              <a:rPr sz="2200" b="0">
                 <a:solidFill>
                   <a:srgbClr val="2D2D2D"/>
                 </a:solidFill>
@@ -8833,7 +8833,7 @@
               <a:spcAft>
                 <a:spcPts val="800"/>
               </a:spcAft>
-              <a:defRPr sz="2200" b="0">
+              <a:defRPr sz="2000" b="0">
                 <a:solidFill>
                   <a:srgbClr val="666666"/>
                 </a:solidFill>
@@ -8855,7 +8855,7 @@
               <a:spcAft>
                 <a:spcPts val="600"/>
               </a:spcAft>
-              <a:defRPr sz="2400" b="1">
+              <a:defRPr sz="2200" b="1">
                 <a:solidFill>
                   <a:srgbClr val="2D2D2D"/>
                 </a:solidFill>
@@ -8879,109 +8879,109 @@
               </a:spcAft>
             </a:pPr>
             <a:r>
+              <a:rPr sz="2000" b="1">
+                <a:solidFill>
+                  <a:srgbClr val="27AE60"/>
+                </a:solidFill>
+                <a:latin typeface="Calibri"/>
+              </a:rPr>
+              <a:t>  •  Sol 1: </a:t>
+            </a:r>
+            <a:r>
+              <a:rPr sz="2000" b="0">
+                <a:solidFill>
+                  <a:srgbClr val="2D2D2D"/>
+                </a:solidFill>
+                <a:latin typeface="Calibri"/>
+              </a:rPr>
+              <a:t>Struggles with short texts (&lt;200 tokens) — insufficient stylometric features.</a:t>
+            </a:r>
+          </a:p>
+          <a:p>
+            <a:pPr algn="l">
+              <a:lnSpc>
+                <a:spcPct val="115000"/>
+              </a:lnSpc>
+              <a:spcBef>
+                <a:spcPts val="0"/>
+              </a:spcBef>
+              <a:spcAft>
+                <a:spcPts val="400"/>
+              </a:spcAft>
+            </a:pPr>
+            <a:r>
+              <a:rPr sz="2000" b="1">
+                <a:solidFill>
+                  <a:srgbClr val="E67E22"/>
+                </a:solidFill>
+                <a:latin typeface="Calibri"/>
+              </a:rPr>
+              <a:t>  •  Sol 2: </a:t>
+            </a:r>
+            <a:r>
+              <a:rPr sz="2000" b="0">
+                <a:solidFill>
+                  <a:srgbClr val="2D2D2D"/>
+                </a:solidFill>
+                <a:latin typeface="Calibri"/>
+              </a:rPr>
+              <a:t>Struggles with formal/structured texts — less char-level variation.</a:t>
+            </a:r>
+          </a:p>
+          <a:p>
+            <a:pPr algn="l">
+              <a:lnSpc>
+                <a:spcPct val="115000"/>
+              </a:lnSpc>
+              <a:spcBef>
+                <a:spcPts val="0"/>
+              </a:spcBef>
+              <a:spcAft>
+                <a:spcPts val="600"/>
+              </a:spcAft>
+            </a:pPr>
+            <a:r>
+              <a:rPr sz="2000" b="1">
+                <a:solidFill>
+                  <a:srgbClr val="E84D60"/>
+                </a:solidFill>
+                <a:latin typeface="Calibri"/>
+              </a:rPr>
+              <a:t>  •  Topic confound: </a:t>
+            </a:r>
+            <a:r>
+              <a:rPr sz="2000" b="0">
+                <a:solidFill>
+                  <a:srgbClr val="2D2D2D"/>
+                </a:solidFill>
+                <a:latin typeface="Calibri"/>
+              </a:rPr>
+              <a:t>Elevated FP rates on same-topic pairs; GRL in Sol 2 partially mitigates.</a:t>
+            </a:r>
+          </a:p>
+          <a:p>
+            <a:pPr algn="l">
+              <a:lnSpc>
+                <a:spcPct val="115000"/>
+              </a:lnSpc>
+              <a:spcBef>
+                <a:spcPts val="0"/>
+              </a:spcBef>
+              <a:spcAft>
+                <a:spcPts val="600"/>
+              </a:spcAft>
+            </a:pPr>
+            <a:r>
               <a:rPr sz="2200" b="1">
                 <a:solidFill>
-                  <a:srgbClr val="27AE60"/>
-                </a:solidFill>
-                <a:latin typeface="Calibri"/>
-              </a:rPr>
-              <a:t>  •  Sol 1: </a:t>
+                  <a:srgbClr val="2E86AB"/>
+                </a:solidFill>
+                <a:latin typeface="Calibri"/>
+              </a:rPr>
+              <a:t>Ablation: </a:t>
             </a:r>
             <a:r>
               <a:rPr sz="2200" b="0">
-                <a:solidFill>
-                  <a:srgbClr val="2D2D2D"/>
-                </a:solidFill>
-                <a:latin typeface="Calibri"/>
-              </a:rPr>
-              <a:t>Struggles with short texts (&lt;200 tokens) — insufficient stylometric features.</a:t>
-            </a:r>
-          </a:p>
-          <a:p>
-            <a:pPr algn="l">
-              <a:lnSpc>
-                <a:spcPct val="115000"/>
-              </a:lnSpc>
-              <a:spcBef>
-                <a:spcPts val="0"/>
-              </a:spcBef>
-              <a:spcAft>
-                <a:spcPts val="400"/>
-              </a:spcAft>
-            </a:pPr>
-            <a:r>
-              <a:rPr sz="2200" b="1">
-                <a:solidFill>
-                  <a:srgbClr val="E67E22"/>
-                </a:solidFill>
-                <a:latin typeface="Calibri"/>
-              </a:rPr>
-              <a:t>  •  Sol 2: </a:t>
-            </a:r>
-            <a:r>
-              <a:rPr sz="2200" b="0">
-                <a:solidFill>
-                  <a:srgbClr val="2D2D2D"/>
-                </a:solidFill>
-                <a:latin typeface="Calibri"/>
-              </a:rPr>
-              <a:t>Struggles with formal/structured texts — less char-level variation.</a:t>
-            </a:r>
-          </a:p>
-          <a:p>
-            <a:pPr algn="l">
-              <a:lnSpc>
-                <a:spcPct val="115000"/>
-              </a:lnSpc>
-              <a:spcBef>
-                <a:spcPts val="0"/>
-              </a:spcBef>
-              <a:spcAft>
-                <a:spcPts val="600"/>
-              </a:spcAft>
-            </a:pPr>
-            <a:r>
-              <a:rPr sz="2200" b="1">
-                <a:solidFill>
-                  <a:srgbClr val="E84D60"/>
-                </a:solidFill>
-                <a:latin typeface="Calibri"/>
-              </a:rPr>
-              <a:t>  •  Topic confound: </a:t>
-            </a:r>
-            <a:r>
-              <a:rPr sz="2200" b="0">
-                <a:solidFill>
-                  <a:srgbClr val="2D2D2D"/>
-                </a:solidFill>
-                <a:latin typeface="Calibri"/>
-              </a:rPr>
-              <a:t>Elevated FP rates on same-topic pairs; GRL in Sol 2 partially mitigates.</a:t>
-            </a:r>
-          </a:p>
-          <a:p>
-            <a:pPr algn="l">
-              <a:lnSpc>
-                <a:spcPct val="115000"/>
-              </a:lnSpc>
-              <a:spcBef>
-                <a:spcPts val="0"/>
-              </a:spcBef>
-              <a:spcAft>
-                <a:spcPts val="600"/>
-              </a:spcAft>
-            </a:pPr>
-            <a:r>
-              <a:rPr sz="2400" b="1">
-                <a:solidFill>
-                  <a:srgbClr val="2E86AB"/>
-                </a:solidFill>
-                <a:latin typeface="Calibri"/>
-              </a:rPr>
-              <a:t>Ablation: </a:t>
-            </a:r>
-            <a:r>
-              <a:rPr sz="2400" b="0">
                 <a:solidFill>
                   <a:srgbClr val="2D2D2D"/>
                 </a:solidFill>
@@ -9000,8 +9000,8 @@
         </p:nvSpPr>
         <p:spPr>
           <a:xfrm>
-            <a:off x="20244426" y="18040000"/>
-            <a:ext cx="9422213" cy="680000"/>
+            <a:off x="20244426" y="15130000"/>
+            <a:ext cx="9522213" cy="560000"/>
           </a:xfrm>
           <a:prstGeom prst="rect">
             <a:avLst/>
@@ -9043,8 +9043,8 @@
         </p:nvSpPr>
         <p:spPr>
           <a:xfrm>
-            <a:off x="20244426" y="18040000"/>
-            <a:ext cx="80000" cy="680000"/>
+            <a:off x="20244426" y="15130000"/>
+            <a:ext cx="70000" cy="560000"/>
           </a:xfrm>
           <a:prstGeom prst="rect">
             <a:avLst/>
@@ -9086,8 +9086,8 @@
         </p:nvSpPr>
         <p:spPr>
           <a:xfrm>
-            <a:off x="20364426" y="18120000"/>
-            <a:ext cx="380000" cy="520000"/>
+            <a:off x="20344426" y="15190000"/>
+            <a:ext cx="340000" cy="440000"/>
           </a:xfrm>
           <a:prstGeom prst="rect">
             <a:avLst/>
@@ -9110,7 +9110,7 @@
               <a:spcAft>
                 <a:spcPts val="0"/>
               </a:spcAft>
-              <a:defRPr sz="3000" b="1">
+              <a:defRPr sz="2600" b="1">
                 <a:solidFill>
                   <a:srgbClr val="FFFFFF"/>
                 </a:solidFill>
@@ -9131,8 +9131,8 @@
         </p:nvSpPr>
         <p:spPr>
           <a:xfrm>
-            <a:off x="20664426" y="18140000"/>
-            <a:ext cx="9092213" cy="480000"/>
+            <a:off x="20624426" y="15205000"/>
+            <a:ext cx="9232213" cy="410000"/>
           </a:xfrm>
           <a:prstGeom prst="rect">
             <a:avLst/>
@@ -9155,7 +9155,7 @@
               <a:spcAft>
                 <a:spcPts val="0"/>
               </a:spcAft>
-              <a:defRPr sz="3600" b="1">
+              <a:defRPr sz="3200" b="1">
                 <a:solidFill>
                   <a:srgbClr val="FFFFFF"/>
                 </a:solidFill>
@@ -9176,8 +9176,8 @@
         </p:nvSpPr>
         <p:spPr>
           <a:xfrm>
-            <a:off x="20244426" y="18675000"/>
-            <a:ext cx="9422213" cy="45000"/>
+            <a:off x="20244426" y="15650000"/>
+            <a:ext cx="9522213" cy="40000"/>
           </a:xfrm>
           <a:prstGeom prst="rect">
             <a:avLst/>
@@ -9219,8 +9219,8 @@
         </p:nvSpPr>
         <p:spPr>
           <a:xfrm>
-            <a:off x="20244426" y="18720000"/>
-            <a:ext cx="9422213" cy="2700000"/>
+            <a:off x="20244426" y="15690000"/>
+            <a:ext cx="9522213" cy="2500000"/>
           </a:xfrm>
           <a:prstGeom prst="roundRect">
             <a:avLst>
@@ -9266,8 +9266,8 @@
         </p:nvSpPr>
         <p:spPr>
           <a:xfrm>
-            <a:off x="20444426" y="18850000"/>
-            <a:ext cx="9022213" cy="2480000"/>
+            <a:off x="20424426" y="15820000"/>
+            <a:ext cx="9162213" cy="2280000"/>
           </a:xfrm>
           <a:prstGeom prst="rect">
             <a:avLst/>
@@ -9290,7 +9290,7 @@
               <a:spcAft>
                 <a:spcPts val="400"/>
               </a:spcAft>
-              <a:defRPr sz="2400" b="1">
+              <a:defRPr sz="2200" b="1">
                 <a:solidFill>
                   <a:srgbClr val="E84D60"/>
                 </a:solidFill>
@@ -9314,7 +9314,7 @@
               </a:spcAft>
             </a:pPr>
             <a:r>
-              <a:rPr sz="2200" b="0">
+              <a:rPr sz="2000" b="0">
                 <a:solidFill>
                   <a:srgbClr val="666666"/>
                 </a:solidFill>
@@ -9323,7 +9323,7 @@
               <a:t>  •  </a:t>
             </a:r>
             <a:r>
-              <a:rPr sz="2200" b="0">
+              <a:rPr sz="2000" b="0">
                 <a:solidFill>
                   <a:srgbClr val="2D2D2D"/>
                 </a:solidFill>
@@ -9345,7 +9345,7 @@
               </a:spcAft>
             </a:pPr>
             <a:r>
-              <a:rPr sz="2200" b="0">
+              <a:rPr sz="2000" b="0">
                 <a:solidFill>
                   <a:srgbClr val="666666"/>
                 </a:solidFill>
@@ -9354,7 +9354,7 @@
               <a:t>  •  </a:t>
             </a:r>
             <a:r>
-              <a:rPr sz="2200" b="0">
+              <a:rPr sz="2000" b="0">
                 <a:solidFill>
                   <a:srgbClr val="2D2D2D"/>
                 </a:solidFill>
@@ -9376,7 +9376,7 @@
               </a:spcAft>
             </a:pPr>
             <a:r>
-              <a:rPr sz="2200" b="0">
+              <a:rPr sz="2000" b="0">
                 <a:solidFill>
                   <a:srgbClr val="666666"/>
                 </a:solidFill>
@@ -9385,7 +9385,7 @@
               <a:t>  •  </a:t>
             </a:r>
             <a:r>
-              <a:rPr sz="2200" b="0">
+              <a:rPr sz="2000" b="0">
                 <a:solidFill>
                   <a:srgbClr val="2D2D2D"/>
                 </a:solidFill>
@@ -9407,7 +9407,7 @@
               </a:spcAft>
             </a:pPr>
             <a:r>
-              <a:rPr sz="2200" b="0">
+              <a:rPr sz="2000" b="0">
                 <a:solidFill>
                   <a:srgbClr val="666666"/>
                 </a:solidFill>
@@ -9416,7 +9416,7 @@
               <a:t>  •  </a:t>
             </a:r>
             <a:r>
-              <a:rPr sz="2200" b="0">
+              <a:rPr sz="2000" b="0">
                 <a:solidFill>
                   <a:srgbClr val="2D2D2D"/>
                 </a:solidFill>
@@ -9455,7 +9455,7 @@
               <a:spcAft>
                 <a:spcPts val="400"/>
               </a:spcAft>
-              <a:defRPr sz="2400" b="1">
+              <a:defRPr sz="2200" b="1">
                 <a:solidFill>
                   <a:srgbClr val="E67E22"/>
                 </a:solidFill>
@@ -9479,7 +9479,7 @@
               </a:spcAft>
             </a:pPr>
             <a:r>
-              <a:rPr sz="2200" b="0">
+              <a:rPr sz="2000" b="0">
                 <a:solidFill>
                   <a:srgbClr val="666666"/>
                 </a:solidFill>
@@ -9488,7 +9488,7 @@
               <a:t>  •  </a:t>
             </a:r>
             <a:r>
-              <a:rPr sz="2200" b="0">
+              <a:rPr sz="2000" b="0">
                 <a:solidFill>
                   <a:srgbClr val="2D2D2D"/>
                 </a:solidFill>
@@ -9510,7 +9510,7 @@
               </a:spcAft>
             </a:pPr>
             <a:r>
-              <a:rPr sz="2200" b="0">
+              <a:rPr sz="2000" b="0">
                 <a:solidFill>
                   <a:srgbClr val="666666"/>
                 </a:solidFill>
@@ -9519,7 +9519,7 @@
               <a:t>  •  </a:t>
             </a:r>
             <a:r>
-              <a:rPr sz="2200" b="0">
+              <a:rPr sz="2000" b="0">
                 <a:solidFill>
                   <a:srgbClr val="2D2D2D"/>
                 </a:solidFill>
@@ -9538,8 +9538,8 @@
         </p:nvSpPr>
         <p:spPr>
           <a:xfrm>
-            <a:off x="20244426" y="21720000"/>
-            <a:ext cx="9422213" cy="680000"/>
+            <a:off x="20244426" y="18390000"/>
+            <a:ext cx="9522213" cy="560000"/>
           </a:xfrm>
           <a:prstGeom prst="rect">
             <a:avLst/>
@@ -9581,8 +9581,8 @@
         </p:nvSpPr>
         <p:spPr>
           <a:xfrm>
-            <a:off x="20244426" y="21720000"/>
-            <a:ext cx="80000" cy="680000"/>
+            <a:off x="20244426" y="18390000"/>
+            <a:ext cx="70000" cy="560000"/>
           </a:xfrm>
           <a:prstGeom prst="rect">
             <a:avLst/>
@@ -9624,8 +9624,8 @@
         </p:nvSpPr>
         <p:spPr>
           <a:xfrm>
-            <a:off x="20474426" y="21820000"/>
-            <a:ext cx="9092213" cy="480000"/>
+            <a:off x="20444426" y="18465000"/>
+            <a:ext cx="9232213" cy="410000"/>
           </a:xfrm>
           <a:prstGeom prst="rect">
             <a:avLst/>
@@ -9648,7 +9648,7 @@
               <a:spcAft>
                 <a:spcPts val="0"/>
               </a:spcAft>
-              <a:defRPr sz="3600" b="1">
+              <a:defRPr sz="3200" b="1">
                 <a:solidFill>
                   <a:srgbClr val="FFFFFF"/>
                 </a:solidFill>
@@ -9669,8 +9669,8 @@
         </p:nvSpPr>
         <p:spPr>
           <a:xfrm>
-            <a:off x="20244426" y="22355000"/>
-            <a:ext cx="9422213" cy="45000"/>
+            <a:off x="20244426" y="18910000"/>
+            <a:ext cx="9522213" cy="40000"/>
           </a:xfrm>
           <a:prstGeom prst="rect">
             <a:avLst/>
@@ -9712,8 +9712,8 @@
         </p:nvSpPr>
         <p:spPr>
           <a:xfrm>
-            <a:off x="20244426" y="22400000"/>
-            <a:ext cx="9422213" cy="1800000"/>
+            <a:off x="20244426" y="18950000"/>
+            <a:ext cx="9522213" cy="1600000"/>
           </a:xfrm>
           <a:prstGeom prst="roundRect">
             <a:avLst>
@@ -9759,8 +9759,8 @@
         </p:nvSpPr>
         <p:spPr>
           <a:xfrm>
-            <a:off x="20444426" y="22530000"/>
-            <a:ext cx="9022213" cy="1580000"/>
+            <a:off x="20424426" y="19080000"/>
+            <a:ext cx="9162213" cy="1380000"/>
           </a:xfrm>
           <a:prstGeom prst="rect">
             <a:avLst/>
@@ -9783,7 +9783,7 @@
               <a:spcAft>
                 <a:spcPts val="300"/>
               </a:spcAft>
-              <a:defRPr sz="2000" b="0">
+              <a:defRPr sz="1800" b="0">
                 <a:solidFill>
                   <a:srgbClr val="666666"/>
                 </a:solidFill>
@@ -9805,7 +9805,7 @@
               <a:spcAft>
                 <a:spcPts val="300"/>
               </a:spcAft>
-              <a:defRPr sz="2000" b="0">
+              <a:defRPr sz="1800" b="0">
                 <a:solidFill>
                   <a:srgbClr val="666666"/>
                 </a:solidFill>
@@ -9827,7 +9827,7 @@
               <a:spcAft>
                 <a:spcPts val="300"/>
               </a:spcAft>
-              <a:defRPr sz="2000" b="0">
+              <a:defRPr sz="1800" b="0">
                 <a:solidFill>
                   <a:srgbClr val="666666"/>
                 </a:solidFill>
@@ -9849,7 +9849,7 @@
               <a:spcAft>
                 <a:spcPts val="300"/>
               </a:spcAft>
-              <a:defRPr sz="2000" b="0">
+              <a:defRPr sz="1800" b="0">
                 <a:solidFill>
                   <a:srgbClr val="666666"/>
                 </a:solidFill>
@@ -9870,8 +9870,8 @@
         </p:nvSpPr>
         <p:spPr>
           <a:xfrm>
-            <a:off x="0" y="20896960"/>
-            <a:ext cx="30266640" cy="500000"/>
+            <a:off x="0" y="20946960"/>
+            <a:ext cx="30266640" cy="450000"/>
           </a:xfrm>
           <a:prstGeom prst="rect">
             <a:avLst/>
@@ -9913,7 +9913,7 @@
         </p:nvSpPr>
         <p:spPr>
           <a:xfrm>
-            <a:off x="0" y="20896960"/>
+            <a:off x="0" y="20946960"/>
             <a:ext cx="30266640" cy="45000"/>
           </a:xfrm>
           <a:prstGeom prst="rect">
@@ -9956,8 +9956,8 @@
         </p:nvSpPr>
         <p:spPr>
           <a:xfrm>
-            <a:off x="600000" y="21006960"/>
-            <a:ext cx="29066640" cy="320000"/>
+            <a:off x="600000" y="21056960"/>
+            <a:ext cx="29066640" cy="270000"/>
           </a:xfrm>
           <a:prstGeom prst="rect">
             <a:avLst/>

</xml_diff>

<commit_message>
A1 poster v2: Rebalance columns, fix F1 chart annotations, move Eval to col2
</commit_message>
<xml_diff>
--- a/poster/poster_a1.pptx
+++ b/poster/poster_a1.pptx
@@ -7269,7 +7269,7 @@
         </p:nvSpPr>
         <p:spPr>
           <a:xfrm>
-            <a:off x="20241092" y="2230000"/>
+            <a:off x="10345546" y="17380000"/>
             <a:ext cx="9575546" cy="520000"/>
           </a:xfrm>
           <a:prstGeom prst="rect">
@@ -7312,7 +7312,7 @@
         </p:nvSpPr>
         <p:spPr>
           <a:xfrm>
-            <a:off x="20241092" y="2230000"/>
+            <a:off x="10345546" y="17380000"/>
             <a:ext cx="60000" cy="520000"/>
           </a:xfrm>
           <a:prstGeom prst="rect">
@@ -7355,7 +7355,7 @@
         </p:nvSpPr>
         <p:spPr>
           <a:xfrm>
-            <a:off x="20341092" y="2290000"/>
+            <a:off x="10445546" y="17440000"/>
             <a:ext cx="320000" cy="400000"/>
           </a:xfrm>
           <a:prstGeom prst="rect">
@@ -7387,7 +7387,7 @@
               </a:defRPr>
             </a:pPr>
             <a:r>
-              <a:t>6</a:t>
+              <a:t>8</a:t>
             </a:r>
           </a:p>
         </p:txBody>
@@ -7400,7 +7400,7 @@
         </p:nvSpPr>
         <p:spPr>
           <a:xfrm>
-            <a:off x="20601092" y="2295000"/>
+            <a:off x="10705546" y="17445000"/>
             <a:ext cx="9325546" cy="390000"/>
           </a:xfrm>
           <a:prstGeom prst="rect">
@@ -7432,7 +7432,7 @@
               </a:defRPr>
             </a:pPr>
             <a:r>
-              <a:t>Performance Comparison</a:t>
+              <a:t>Evaluation &amp; Conclusions</a:t>
             </a:r>
           </a:p>
         </p:txBody>
@@ -7445,7 +7445,7 @@
         </p:nvSpPr>
         <p:spPr>
           <a:xfrm>
-            <a:off x="20241092" y="2715000"/>
+            <a:off x="10345546" y="17865000"/>
             <a:ext cx="9575546" cy="35000"/>
           </a:xfrm>
           <a:prstGeom prst="rect">
@@ -7488,8 +7488,8 @@
         </p:nvSpPr>
         <p:spPr>
           <a:xfrm>
-            <a:off x="20241092" y="2750000"/>
-            <a:ext cx="9575546" cy="3600000"/>
+            <a:off x="10345546" y="17900000"/>
+            <a:ext cx="9575546" cy="2200000"/>
           </a:xfrm>
           <a:prstGeom prst="roundRect">
             <a:avLst>
@@ -7527,30 +7527,309 @@
           </a:p>
         </p:txBody>
       </p:sp>
-      <p:pic>
-        <p:nvPicPr>
-          <p:cNvPr id="64" name="Picture 63" descr="f1_chart_a1.png"/>
-          <p:cNvPicPr>
-            <a:picLocks noChangeAspect="1"/>
-          </p:cNvPicPr>
+      <p:sp>
+        <p:nvSpPr>
+          <p:cNvPr id="64" name="TextBox 63"/>
+          <p:cNvSpPr txBox="1"/>
           <p:nvPr/>
-        </p:nvPicPr>
-        <p:blipFill>
-          <a:blip r:embed="rId4"/>
-          <a:stretch>
-            <a:fillRect/>
-          </a:stretch>
-        </p:blipFill>
-        <p:spPr>
-          <a:xfrm>
-            <a:off x="20361092" y="2970000"/>
-            <a:ext cx="9335546" cy="3150000"/>
+        </p:nvSpPr>
+        <p:spPr>
+          <a:xfrm>
+            <a:off x="10505546" y="18010000"/>
+            <a:ext cx="9255546" cy="2020000"/>
           </a:xfrm>
           <a:prstGeom prst="rect">
             <a:avLst/>
           </a:prstGeom>
-        </p:spPr>
-      </p:pic>
+          <a:noFill/>
+        </p:spPr>
+        <p:txBody>
+          <a:bodyPr wrap="square">
+            <a:spAutoFit/>
+          </a:bodyPr>
+          <a:lstStyle/>
+          <a:p>
+            <a:pPr algn="l">
+              <a:lnSpc>
+                <a:spcPct val="115000"/>
+              </a:lnSpc>
+              <a:spcBef>
+                <a:spcPts val="0"/>
+              </a:spcBef>
+              <a:spcAft>
+                <a:spcPts val="300"/>
+              </a:spcAft>
+              <a:defRPr sz="2200" b="1">
+                <a:solidFill>
+                  <a:srgbClr val="2E86AB"/>
+                </a:solidFill>
+                <a:latin typeface="Calibri"/>
+              </a:defRPr>
+            </a:pPr>
+            <a:r>
+              <a:t>Evaluation Methods:</a:t>
+            </a:r>
+          </a:p>
+          <a:p>
+            <a:pPr algn="l">
+              <a:lnSpc>
+                <a:spcPct val="115000"/>
+              </a:lnSpc>
+              <a:spcBef>
+                <a:spcPts val="0"/>
+              </a:spcBef>
+              <a:spcAft>
+                <a:spcPts val="300"/>
+              </a:spcAft>
+            </a:pPr>
+            <a:r>
+              <a:rPr sz="2000" b="0">
+                <a:solidFill>
+                  <a:srgbClr val="666666"/>
+                </a:solidFill>
+                <a:latin typeface="Calibri"/>
+              </a:rPr>
+              <a:t>  •  </a:t>
+            </a:r>
+            <a:r>
+              <a:rPr sz="2000" b="0">
+                <a:solidFill>
+                  <a:srgbClr val="2D2D2D"/>
+                </a:solidFill>
+                <a:latin typeface="Calibri"/>
+              </a:rPr>
+              <a:t>Macro F1 (primary), MCC, per-class P/R</a:t>
+            </a:r>
+          </a:p>
+          <a:p>
+            <a:pPr algn="l">
+              <a:lnSpc>
+                <a:spcPct val="115000"/>
+              </a:lnSpc>
+              <a:spcBef>
+                <a:spcPts val="0"/>
+              </a:spcBef>
+              <a:spcAft>
+                <a:spcPts val="300"/>
+              </a:spcAft>
+            </a:pPr>
+            <a:r>
+              <a:rPr sz="2000" b="0">
+                <a:solidFill>
+                  <a:srgbClr val="666666"/>
+                </a:solidFill>
+                <a:latin typeface="Calibri"/>
+              </a:rPr>
+              <a:t>  •  </a:t>
+            </a:r>
+            <a:r>
+              <a:rPr sz="2000" b="0">
+                <a:solidFill>
+                  <a:srgbClr val="2D2D2D"/>
+                </a:solidFill>
+                <a:latin typeface="Calibri"/>
+              </a:rPr>
+              <a:t>McNemar’s paired significance test (p &lt; 0.001)</a:t>
+            </a:r>
+          </a:p>
+          <a:p>
+            <a:pPr algn="l">
+              <a:lnSpc>
+                <a:spcPct val="115000"/>
+              </a:lnSpc>
+              <a:spcBef>
+                <a:spcPts val="0"/>
+              </a:spcBef>
+              <a:spcAft>
+                <a:spcPts val="300"/>
+              </a:spcAft>
+            </a:pPr>
+            <a:r>
+              <a:rPr sz="2000" b="0">
+                <a:solidFill>
+                  <a:srgbClr val="666666"/>
+                </a:solidFill>
+                <a:latin typeface="Calibri"/>
+              </a:rPr>
+              <a:t>  •  </a:t>
+            </a:r>
+            <a:r>
+              <a:rPr sz="2000" b="0">
+                <a:solidFill>
+                  <a:srgbClr val="2D2D2D"/>
+                </a:solidFill>
+                <a:latin typeface="Calibri"/>
+              </a:rPr>
+              <a:t>Feature ablation (Sol 1) + GRL ablation (Sol 2)</a:t>
+            </a:r>
+          </a:p>
+          <a:p>
+            <a:pPr algn="l">
+              <a:lnSpc>
+                <a:spcPct val="115000"/>
+              </a:lnSpc>
+              <a:spcBef>
+                <a:spcPts val="0"/>
+              </a:spcBef>
+              <a:spcAft>
+                <a:spcPts val="300"/>
+              </a:spcAft>
+            </a:pPr>
+            <a:r>
+              <a:rPr sz="2000" b="0">
+                <a:solidFill>
+                  <a:srgbClr val="666666"/>
+                </a:solidFill>
+                <a:latin typeface="Calibri"/>
+              </a:rPr>
+              <a:t>  •  </a:t>
+            </a:r>
+            <a:r>
+              <a:rPr sz="2000" b="0">
+                <a:solidFill>
+                  <a:srgbClr val="2D2D2D"/>
+                </a:solidFill>
+                <a:latin typeface="Calibri"/>
+              </a:rPr>
+              <a:t>Inter-model agreement (Cohen’s κ ≈ 0.40)</a:t>
+            </a:r>
+          </a:p>
+          <a:p>
+            <a:pPr algn="l">
+              <a:lnSpc>
+                <a:spcPct val="115000"/>
+              </a:lnSpc>
+              <a:spcBef>
+                <a:spcPts val="0"/>
+              </a:spcBef>
+              <a:spcAft>
+                <a:spcPts val="400"/>
+              </a:spcAft>
+              <a:defRPr sz="300" b="0">
+                <a:solidFill>
+                  <a:srgbClr val="2D2D2D"/>
+                </a:solidFill>
+                <a:latin typeface="Calibri"/>
+              </a:defRPr>
+            </a:pPr>
+          </a:p>
+          <a:p>
+            <a:pPr algn="l">
+              <a:lnSpc>
+                <a:spcPct val="115000"/>
+              </a:lnSpc>
+              <a:spcBef>
+                <a:spcPts val="0"/>
+              </a:spcBef>
+              <a:spcAft>
+                <a:spcPts val="300"/>
+              </a:spcAft>
+              <a:defRPr sz="2200" b="1">
+                <a:solidFill>
+                  <a:srgbClr val="2E86AB"/>
+                </a:solidFill>
+                <a:latin typeface="Calibri"/>
+              </a:defRPr>
+            </a:pPr>
+            <a:r>
+              <a:t>Key Conclusions:</a:t>
+            </a:r>
+          </a:p>
+          <a:p>
+            <a:pPr algn="l">
+              <a:lnSpc>
+                <a:spcPct val="115000"/>
+              </a:lnSpc>
+              <a:spcBef>
+                <a:spcPts val="0"/>
+              </a:spcBef>
+              <a:spcAft>
+                <a:spcPts val="300"/>
+              </a:spcAft>
+            </a:pPr>
+            <a:r>
+              <a:rPr sz="2000" b="0">
+                <a:solidFill>
+                  <a:srgbClr val="666666"/>
+                </a:solidFill>
+                <a:latin typeface="Calibri"/>
+              </a:rPr>
+              <a:t>  •  </a:t>
+            </a:r>
+            <a:r>
+              <a:rPr sz="2000" b="0">
+                <a:solidFill>
+                  <a:srgbClr val="2D2D2D"/>
+                </a:solidFill>
+                <a:latin typeface="Calibri"/>
+              </a:rPr>
+              <a:t>Both solutions significantly outperform their baselines</a:t>
+            </a:r>
+          </a:p>
+          <a:p>
+            <a:pPr algn="l">
+              <a:lnSpc>
+                <a:spcPct val="115000"/>
+              </a:lnSpc>
+              <a:spcBef>
+                <a:spcPts val="0"/>
+              </a:spcBef>
+              <a:spcAft>
+                <a:spcPts val="300"/>
+              </a:spcAft>
+            </a:pPr>
+            <a:r>
+              <a:rPr sz="2000" b="0">
+                <a:solidFill>
+                  <a:srgbClr val="666666"/>
+                </a:solidFill>
+                <a:latin typeface="Calibri"/>
+              </a:rPr>
+              <a:t>  •  </a:t>
+            </a:r>
+            <a:r>
+              <a:rPr sz="2000" b="0">
+                <a:solidFill>
+                  <a:srgbClr val="2D2D2D"/>
+                </a:solidFill>
+                <a:latin typeface="Calibri"/>
+              </a:rPr>
+              <a:t>Complementary approaches: feature engineering + neural</a:t>
+            </a:r>
+          </a:p>
+          <a:p>
+            <a:pPr algn="l">
+              <a:lnSpc>
+                <a:spcPct val="115000"/>
+              </a:lnSpc>
+              <a:spcBef>
+                <a:spcPts val="0"/>
+              </a:spcBef>
+              <a:spcAft>
+                <a:spcPts val="300"/>
+              </a:spcAft>
+            </a:pPr>
+            <a:r>
+              <a:rPr sz="2000" b="0">
+                <a:solidFill>
+                  <a:srgbClr val="666666"/>
+                </a:solidFill>
+                <a:latin typeface="Calibri"/>
+              </a:rPr>
+              <a:t>  •  </a:t>
+            </a:r>
+            <a:r>
+              <a:rPr sz="2000" b="0">
+                <a:solidFill>
+                  <a:srgbClr val="2D2D2D"/>
+                </a:solidFill>
+                <a:latin typeface="Calibri"/>
+              </a:rPr>
+              <a:t>Novel features and adversarial debiasing add measurable value</a:t>
+            </a:r>
+          </a:p>
+        </p:txBody>
+      </p:sp>
       <p:sp>
         <p:nvSpPr>
           <p:cNvPr id="65" name="Rectangle 64"/>
@@ -7559,7 +7838,7 @@
         </p:nvSpPr>
         <p:spPr>
           <a:xfrm>
-            <a:off x="20241092" y="6530000"/>
+            <a:off x="20241092" y="2230000"/>
             <a:ext cx="9575546" cy="520000"/>
           </a:xfrm>
           <a:prstGeom prst="rect">
@@ -7602,7 +7881,7 @@
         </p:nvSpPr>
         <p:spPr>
           <a:xfrm>
-            <a:off x="20241092" y="6530000"/>
+            <a:off x="20241092" y="2230000"/>
             <a:ext cx="60000" cy="520000"/>
           </a:xfrm>
           <a:prstGeom prst="rect">
@@ -7645,8 +7924,8 @@
         </p:nvSpPr>
         <p:spPr>
           <a:xfrm>
-            <a:off x="20421092" y="6595000"/>
-            <a:ext cx="9325546" cy="390000"/>
+            <a:off x="20341092" y="2290000"/>
+            <a:ext cx="320000" cy="400000"/>
           </a:xfrm>
           <a:prstGeom prst="rect">
             <a:avLst/>
@@ -7659,6 +7938,51 @@
           </a:bodyPr>
           <a:lstStyle/>
           <a:p>
+            <a:pPr algn="ctr">
+              <a:lnSpc>
+                <a:spcPct val="115000"/>
+              </a:lnSpc>
+              <a:spcBef>
+                <a:spcPts val="0"/>
+              </a:spcBef>
+              <a:spcAft>
+                <a:spcPts val="0"/>
+              </a:spcAft>
+              <a:defRPr sz="2400" b="1" i="0">
+                <a:solidFill>
+                  <a:srgbClr val="FFFFFF"/>
+                </a:solidFill>
+                <a:latin typeface="Calibri"/>
+              </a:defRPr>
+            </a:pPr>
+            <a:r>
+              <a:t>6</a:t>
+            </a:r>
+          </a:p>
+        </p:txBody>
+      </p:sp>
+      <p:sp>
+        <p:nvSpPr>
+          <p:cNvPr id="68" name="TextBox 67"/>
+          <p:cNvSpPr txBox="1"/>
+          <p:nvPr/>
+        </p:nvSpPr>
+        <p:spPr>
+          <a:xfrm>
+            <a:off x="20601092" y="2295000"/>
+            <a:ext cx="9325546" cy="390000"/>
+          </a:xfrm>
+          <a:prstGeom prst="rect">
+            <a:avLst/>
+          </a:prstGeom>
+          <a:noFill/>
+        </p:spPr>
+        <p:txBody>
+          <a:bodyPr wrap="square">
+            <a:spAutoFit/>
+          </a:bodyPr>
+          <a:lstStyle/>
+          <a:p>
             <a:pPr algn="l">
               <a:lnSpc>
                 <a:spcPct val="115000"/>
@@ -7677,20 +8001,20 @@
               </a:defRPr>
             </a:pPr>
             <a:r>
-              <a:t>Confusion Matrices</a:t>
-            </a:r>
-          </a:p>
-        </p:txBody>
-      </p:sp>
-      <p:sp>
-        <p:nvSpPr>
-          <p:cNvPr id="68" name="Rectangle 67"/>
+              <a:t>Performance Comparison</a:t>
+            </a:r>
+          </a:p>
+        </p:txBody>
+      </p:sp>
+      <p:sp>
+        <p:nvSpPr>
+          <p:cNvPr id="69" name="Rectangle 68"/>
           <p:cNvSpPr/>
           <p:nvPr/>
         </p:nvSpPr>
         <p:spPr>
           <a:xfrm>
-            <a:off x="20241092" y="7015000"/>
+            <a:off x="20241092" y="2715000"/>
             <a:ext cx="9575546" cy="35000"/>
           </a:xfrm>
           <a:prstGeom prst="rect">
@@ -7727,14 +8051,14 @@
       </p:sp>
       <p:sp>
         <p:nvSpPr>
-          <p:cNvPr id="69" name="Rounded Rectangle 68"/>
+          <p:cNvPr id="70" name="Rounded Rectangle 69"/>
           <p:cNvSpPr/>
           <p:nvPr/>
         </p:nvSpPr>
         <p:spPr>
           <a:xfrm>
-            <a:off x="20241092" y="7050000"/>
-            <a:ext cx="9575546" cy="3100000"/>
+            <a:off x="20241092" y="2750000"/>
+            <a:ext cx="9575546" cy="3600000"/>
           </a:xfrm>
           <a:prstGeom prst="roundRect">
             <a:avLst>
@@ -7774,22 +8098,22 @@
       </p:sp>
       <p:pic>
         <p:nvPicPr>
-          <p:cNvPr id="70" name="Picture 69" descr="cm_a1.png"/>
+          <p:cNvPr id="71" name="Picture 70" descr="f1_chart_a1.png"/>
           <p:cNvPicPr>
             <a:picLocks noChangeAspect="1"/>
           </p:cNvPicPr>
           <p:nvPr/>
         </p:nvPicPr>
         <p:blipFill>
-          <a:blip r:embed="rId5"/>
+          <a:blip r:embed="rId4"/>
           <a:stretch>
             <a:fillRect/>
           </a:stretch>
         </p:blipFill>
         <p:spPr>
           <a:xfrm>
-            <a:off x="20321092" y="7270000"/>
-            <a:ext cx="9415546" cy="2650000"/>
+            <a:off x="20361092" y="2970000"/>
+            <a:ext cx="9335546" cy="3150000"/>
           </a:xfrm>
           <a:prstGeom prst="rect">
             <a:avLst/>
@@ -7798,13 +8122,13 @@
       </p:pic>
       <p:sp>
         <p:nvSpPr>
-          <p:cNvPr id="71" name="Rectangle 70"/>
+          <p:cNvPr id="72" name="Rectangle 71"/>
           <p:cNvSpPr/>
           <p:nvPr/>
         </p:nvSpPr>
         <p:spPr>
           <a:xfrm>
-            <a:off x="20241092" y="10330000"/>
+            <a:off x="20241092" y="6530000"/>
             <a:ext cx="9575546" cy="520000"/>
           </a:xfrm>
           <a:prstGeom prst="rect">
@@ -7841,13 +8165,13 @@
       </p:sp>
       <p:sp>
         <p:nvSpPr>
-          <p:cNvPr id="72" name="Rectangle 71"/>
+          <p:cNvPr id="73" name="Rectangle 72"/>
           <p:cNvSpPr/>
           <p:nvPr/>
         </p:nvSpPr>
         <p:spPr>
           <a:xfrm>
-            <a:off x="20241092" y="10330000"/>
+            <a:off x="20241092" y="6530000"/>
             <a:ext cx="60000" cy="520000"/>
           </a:xfrm>
           <a:prstGeom prst="rect">
@@ -7884,14 +8208,14 @@
       </p:sp>
       <p:sp>
         <p:nvSpPr>
-          <p:cNvPr id="73" name="TextBox 72"/>
+          <p:cNvPr id="74" name="TextBox 73"/>
           <p:cNvSpPr txBox="1"/>
           <p:nvPr/>
         </p:nvSpPr>
         <p:spPr>
           <a:xfrm>
-            <a:off x="20341092" y="10390000"/>
-            <a:ext cx="320000" cy="400000"/>
+            <a:off x="20421092" y="6595000"/>
+            <a:ext cx="9325546" cy="390000"/>
           </a:xfrm>
           <a:prstGeom prst="rect">
             <a:avLst/>
@@ -7904,17 +8228,17 @@
           </a:bodyPr>
           <a:lstStyle/>
           <a:p>
-            <a:pPr algn="ctr">
-              <a:lnSpc>
-                <a:spcPct val="115000"/>
-              </a:lnSpc>
-              <a:spcBef>
-                <a:spcPts val="0"/>
-              </a:spcBef>
-              <a:spcAft>
-                <a:spcPts val="0"/>
-              </a:spcAft>
-              <a:defRPr sz="2400" b="1" i="0">
+            <a:pPr algn="l">
+              <a:lnSpc>
+                <a:spcPct val="115000"/>
+              </a:lnSpc>
+              <a:spcBef>
+                <a:spcPts val="0"/>
+              </a:spcBef>
+              <a:spcAft>
+                <a:spcPts val="0"/>
+              </a:spcAft>
+              <a:defRPr sz="3000" b="1" i="0">
                 <a:solidFill>
                   <a:srgbClr val="FFFFFF"/>
                 </a:solidFill>
@@ -7922,52 +8246,7 @@
               </a:defRPr>
             </a:pPr>
             <a:r>
-              <a:t>7</a:t>
-            </a:r>
-          </a:p>
-        </p:txBody>
-      </p:sp>
-      <p:sp>
-        <p:nvSpPr>
-          <p:cNvPr id="74" name="TextBox 73"/>
-          <p:cNvSpPr txBox="1"/>
-          <p:nvPr/>
-        </p:nvSpPr>
-        <p:spPr>
-          <a:xfrm>
-            <a:off x="20601092" y="10395000"/>
-            <a:ext cx="9325546" cy="390000"/>
-          </a:xfrm>
-          <a:prstGeom prst="rect">
-            <a:avLst/>
-          </a:prstGeom>
-          <a:noFill/>
-        </p:spPr>
-        <p:txBody>
-          <a:bodyPr wrap="square">
-            <a:spAutoFit/>
-          </a:bodyPr>
-          <a:lstStyle/>
-          <a:p>
-            <a:pPr algn="l">
-              <a:lnSpc>
-                <a:spcPct val="115000"/>
-              </a:lnSpc>
-              <a:spcBef>
-                <a:spcPts val="0"/>
-              </a:spcBef>
-              <a:spcAft>
-                <a:spcPts val="0"/>
-              </a:spcAft>
-              <a:defRPr sz="3000" b="1" i="0">
-                <a:solidFill>
-                  <a:srgbClr val="FFFFFF"/>
-                </a:solidFill>
-                <a:latin typeface="Calibri"/>
-              </a:defRPr>
-            </a:pPr>
-            <a:r>
-              <a:t>Error Analysis</a:t>
+              <a:t>Confusion Matrices</a:t>
             </a:r>
           </a:p>
         </p:txBody>
@@ -7980,7 +8259,7 @@
         </p:nvSpPr>
         <p:spPr>
           <a:xfrm>
-            <a:off x="20241092" y="10815000"/>
+            <a:off x="20241092" y="7015000"/>
             <a:ext cx="9575546" cy="35000"/>
           </a:xfrm>
           <a:prstGeom prst="rect">
@@ -8023,8 +8302,8 @@
         </p:nvSpPr>
         <p:spPr>
           <a:xfrm>
-            <a:off x="20241092" y="10850000"/>
-            <a:ext cx="9575546" cy="3200000"/>
+            <a:off x="20241092" y="7050000"/>
+            <a:ext cx="9575546" cy="3100000"/>
           </a:xfrm>
           <a:prstGeom prst="roundRect">
             <a:avLst>
@@ -8062,259 +8341,30 @@
           </a:p>
         </p:txBody>
       </p:sp>
-      <p:sp>
-        <p:nvSpPr>
-          <p:cNvPr id="77" name="TextBox 76"/>
-          <p:cNvSpPr txBox="1"/>
+      <p:pic>
+        <p:nvPicPr>
+          <p:cNvPr id="77" name="Picture 76" descr="cm_a1.png"/>
+          <p:cNvPicPr>
+            <a:picLocks noChangeAspect="1"/>
+          </p:cNvPicPr>
           <p:nvPr/>
-        </p:nvSpPr>
-        <p:spPr>
-          <a:xfrm>
-            <a:off x="20401092" y="10960000"/>
-            <a:ext cx="9255546" cy="3020000"/>
+        </p:nvPicPr>
+        <p:blipFill>
+          <a:blip r:embed="rId5"/>
+          <a:stretch>
+            <a:fillRect/>
+          </a:stretch>
+        </p:blipFill>
+        <p:spPr>
+          <a:xfrm>
+            <a:off x="20321092" y="7270000"/>
+            <a:ext cx="9415546" cy="2650000"/>
           </a:xfrm>
           <a:prstGeom prst="rect">
             <a:avLst/>
           </a:prstGeom>
-          <a:noFill/>
-        </p:spPr>
-        <p:txBody>
-          <a:bodyPr wrap="square">
-            <a:spAutoFit/>
-          </a:bodyPr>
-          <a:lstStyle/>
-          <a:p>
-            <a:pPr algn="l">
-              <a:lnSpc>
-                <a:spcPct val="115000"/>
-              </a:lnSpc>
-              <a:spcBef>
-                <a:spcPts val="0"/>
-              </a:spcBef>
-              <a:spcAft>
-                <a:spcPts val="500"/>
-              </a:spcAft>
-            </a:pPr>
-            <a:r>
-              <a:rPr sz="2200" b="1">
-                <a:solidFill>
-                  <a:srgbClr val="2E86AB"/>
-                </a:solidFill>
-                <a:latin typeface="Calibri"/>
-              </a:rPr>
-              <a:t>Inter-model agreement: </a:t>
-            </a:r>
-            <a:r>
-              <a:rPr sz="2200" b="0">
-                <a:solidFill>
-                  <a:srgbClr val="2D2D2D"/>
-                </a:solidFill>
-                <a:latin typeface="Calibri"/>
-              </a:rPr>
-              <a:t>~70% (Cohen’s κ ≈ 0.40)</a:t>
-            </a:r>
-          </a:p>
-          <a:p>
-            <a:pPr algn="l">
-              <a:lnSpc>
-                <a:spcPct val="115000"/>
-              </a:lnSpc>
-              <a:spcBef>
-                <a:spcPts val="0"/>
-              </a:spcBef>
-              <a:spcAft>
-                <a:spcPts val="600"/>
-              </a:spcAft>
-              <a:defRPr sz="2000" b="0">
-                <a:solidFill>
-                  <a:srgbClr val="666666"/>
-                </a:solidFill>
-                <a:latin typeface="Calibri"/>
-              </a:defRPr>
-            </a:pPr>
-            <a:r>
-              <a:t>Models capture complementary stylistic patterns.</a:t>
-            </a:r>
-          </a:p>
-          <a:p>
-            <a:pPr algn="l">
-              <a:lnSpc>
-                <a:spcPct val="115000"/>
-              </a:lnSpc>
-              <a:spcBef>
-                <a:spcPts val="0"/>
-              </a:spcBef>
-              <a:spcAft>
-                <a:spcPts val="500"/>
-              </a:spcAft>
-              <a:defRPr sz="2200" b="1">
-                <a:solidFill>
-                  <a:srgbClr val="2D2D2D"/>
-                </a:solidFill>
-                <a:latin typeface="Calibri"/>
-              </a:defRPr>
-            </a:pPr>
-            <a:r>
-              <a:t>Failure Mode Analysis:</a:t>
-            </a:r>
-          </a:p>
-          <a:p>
-            <a:pPr algn="l">
-              <a:lnSpc>
-                <a:spcPct val="115000"/>
-              </a:lnSpc>
-              <a:spcBef>
-                <a:spcPts val="0"/>
-              </a:spcBef>
-              <a:spcAft>
-                <a:spcPts val="300"/>
-              </a:spcAft>
-            </a:pPr>
-            <a:r>
-              <a:rPr sz="2000" b="1">
-                <a:solidFill>
-                  <a:srgbClr val="27AE60"/>
-                </a:solidFill>
-                <a:latin typeface="Calibri"/>
-              </a:rPr>
-              <a:t>  •  Sol 1: </a:t>
-            </a:r>
-            <a:r>
-              <a:rPr sz="2000" b="0">
-                <a:solidFill>
-                  <a:srgbClr val="2D2D2D"/>
-                </a:solidFill>
-                <a:latin typeface="Calibri"/>
-              </a:rPr>
-              <a:t>Struggles with short texts (&lt;200 tokens) — insufficient features for stable stylometry.</a:t>
-            </a:r>
-          </a:p>
-          <a:p>
-            <a:pPr algn="l">
-              <a:lnSpc>
-                <a:spcPct val="115000"/>
-              </a:lnSpc>
-              <a:spcBef>
-                <a:spcPts val="0"/>
-              </a:spcBef>
-              <a:spcAft>
-                <a:spcPts val="300"/>
-              </a:spcAft>
-            </a:pPr>
-            <a:r>
-              <a:rPr sz="2000" b="1">
-                <a:solidFill>
-                  <a:srgbClr val="E67E22"/>
-                </a:solidFill>
-                <a:latin typeface="Calibri"/>
-              </a:rPr>
-              <a:t>  •  Sol 2: </a:t>
-            </a:r>
-            <a:r>
-              <a:rPr sz="2000" b="0">
-                <a:solidFill>
-                  <a:srgbClr val="2D2D2D"/>
-                </a:solidFill>
-                <a:latin typeface="Calibri"/>
-              </a:rPr>
-              <a:t>Struggles with formal/structured texts — less character-level stylistic variation.</a:t>
-            </a:r>
-          </a:p>
-          <a:p>
-            <a:pPr algn="l">
-              <a:lnSpc>
-                <a:spcPct val="115000"/>
-              </a:lnSpc>
-              <a:spcBef>
-                <a:spcPts val="0"/>
-              </a:spcBef>
-              <a:spcAft>
-                <a:spcPts val="500"/>
-              </a:spcAft>
-            </a:pPr>
-            <a:r>
-              <a:rPr sz="2000" b="1">
-                <a:solidFill>
-                  <a:srgbClr val="E84D60"/>
-                </a:solidFill>
-                <a:latin typeface="Calibri"/>
-              </a:rPr>
-              <a:t>  •  Topic confound: </a:t>
-            </a:r>
-            <a:r>
-              <a:rPr sz="2000" b="0">
-                <a:solidFill>
-                  <a:srgbClr val="2D2D2D"/>
-                </a:solidFill>
-                <a:latin typeface="Calibri"/>
-              </a:rPr>
-              <a:t>Elevated FP rates on same-topic pairs; GRL in Sol 2 partially mitigates this.</a:t>
-            </a:r>
-          </a:p>
-          <a:p>
-            <a:pPr algn="l">
-              <a:lnSpc>
-                <a:spcPct val="115000"/>
-              </a:lnSpc>
-              <a:spcBef>
-                <a:spcPts val="0"/>
-              </a:spcBef>
-              <a:spcAft>
-                <a:spcPts val="500"/>
-              </a:spcAft>
-            </a:pPr>
-            <a:r>
-              <a:rPr sz="2200" b="1">
-                <a:solidFill>
-                  <a:srgbClr val="2E86AB"/>
-                </a:solidFill>
-                <a:latin typeface="Calibri"/>
-              </a:rPr>
-              <a:t>Feature ablation: </a:t>
-            </a:r>
-            <a:r>
-              <a:rPr sz="2200" b="0">
-                <a:solidFill>
-                  <a:srgbClr val="2D2D2D"/>
-                </a:solidFill>
-                <a:latin typeface="Calibri"/>
-              </a:rPr>
-              <a:t>Removing novel features drops Sol 1 F1 by 1.8%</a:t>
-            </a:r>
-          </a:p>
-          <a:p>
-            <a:pPr algn="l">
-              <a:lnSpc>
-                <a:spcPct val="115000"/>
-              </a:lnSpc>
-              <a:spcBef>
-                <a:spcPts val="0"/>
-              </a:spcBef>
-              <a:spcAft>
-                <a:spcPts val="500"/>
-              </a:spcAft>
-            </a:pPr>
-            <a:r>
-              <a:rPr sz="2200" b="1">
-                <a:solidFill>
-                  <a:srgbClr val="2E86AB"/>
-                </a:solidFill>
-                <a:latin typeface="Calibri"/>
-              </a:rPr>
-              <a:t>GRL ablation: </a:t>
-            </a:r>
-            <a:r>
-              <a:rPr sz="2200" b="0">
-                <a:solidFill>
-                  <a:srgbClr val="2D2D2D"/>
-                </a:solidFill>
-                <a:latin typeface="Calibri"/>
-              </a:rPr>
-              <a:t>Removing GRL drops Sol 2 F1 by ~1.2% on topic-confounded pairs</a:t>
-            </a:r>
-          </a:p>
-        </p:txBody>
-      </p:sp>
+        </p:spPr>
+      </p:pic>
       <p:sp>
         <p:nvSpPr>
           <p:cNvPr id="78" name="Rectangle 77"/>
@@ -8323,7 +8373,7 @@
         </p:nvSpPr>
         <p:spPr>
           <a:xfrm>
-            <a:off x="20241092" y="14230000"/>
+            <a:off x="20241092" y="10330000"/>
             <a:ext cx="9575546" cy="520000"/>
           </a:xfrm>
           <a:prstGeom prst="rect">
@@ -8366,7 +8416,7 @@
         </p:nvSpPr>
         <p:spPr>
           <a:xfrm>
-            <a:off x="20241092" y="14230000"/>
+            <a:off x="20241092" y="10330000"/>
             <a:ext cx="60000" cy="520000"/>
           </a:xfrm>
           <a:prstGeom prst="rect">
@@ -8409,7 +8459,7 @@
         </p:nvSpPr>
         <p:spPr>
           <a:xfrm>
-            <a:off x="20341092" y="14290000"/>
+            <a:off x="20341092" y="10390000"/>
             <a:ext cx="320000" cy="400000"/>
           </a:xfrm>
           <a:prstGeom prst="rect">
@@ -8441,7 +8491,7 @@
               </a:defRPr>
             </a:pPr>
             <a:r>
-              <a:t>8</a:t>
+              <a:t>7</a:t>
             </a:r>
           </a:p>
         </p:txBody>
@@ -8454,7 +8504,7 @@
         </p:nvSpPr>
         <p:spPr>
           <a:xfrm>
-            <a:off x="20601092" y="14295000"/>
+            <a:off x="20601092" y="10395000"/>
             <a:ext cx="9325546" cy="390000"/>
           </a:xfrm>
           <a:prstGeom prst="rect">
@@ -8486,7 +8536,7 @@
               </a:defRPr>
             </a:pPr>
             <a:r>
-              <a:t>Evaluation Methodology</a:t>
+              <a:t>Error Analysis</a:t>
             </a:r>
           </a:p>
         </p:txBody>
@@ -8499,7 +8549,7 @@
         </p:nvSpPr>
         <p:spPr>
           <a:xfrm>
-            <a:off x="20241092" y="14715000"/>
+            <a:off x="20241092" y="10815000"/>
             <a:ext cx="9575546" cy="35000"/>
           </a:xfrm>
           <a:prstGeom prst="rect">
@@ -8542,8 +8592,8 @@
         </p:nvSpPr>
         <p:spPr>
           <a:xfrm>
-            <a:off x="20241092" y="14750000"/>
-            <a:ext cx="9575546" cy="1800000"/>
+            <a:off x="20241092" y="10850000"/>
+            <a:ext cx="9575546" cy="3200000"/>
           </a:xfrm>
           <a:prstGeom prst="roundRect">
             <a:avLst>
@@ -8589,8 +8639,8 @@
         </p:nvSpPr>
         <p:spPr>
           <a:xfrm>
-            <a:off x="20401092" y="14860000"/>
-            <a:ext cx="9255546" cy="1620000"/>
+            <a:off x="20401092" y="10960000"/>
+            <a:ext cx="9255546" cy="3020000"/>
           </a:xfrm>
           <a:prstGeom prst="rect">
             <a:avLst/>
@@ -8611,17 +8661,123 @@
                 <a:spcPts val="0"/>
               </a:spcBef>
               <a:spcAft>
+                <a:spcPts val="500"/>
+              </a:spcAft>
+            </a:pPr>
+            <a:r>
+              <a:rPr sz="2200" b="1">
+                <a:solidFill>
+                  <a:srgbClr val="2E86AB"/>
+                </a:solidFill>
+                <a:latin typeface="Calibri"/>
+              </a:rPr>
+              <a:t>Inter-model agreement: </a:t>
+            </a:r>
+            <a:r>
+              <a:rPr sz="2200" b="0">
+                <a:solidFill>
+                  <a:srgbClr val="2D2D2D"/>
+                </a:solidFill>
+                <a:latin typeface="Calibri"/>
+              </a:rPr>
+              <a:t>~70% (Cohen’s κ ≈ 0.40)</a:t>
+            </a:r>
+          </a:p>
+          <a:p>
+            <a:pPr algn="l">
+              <a:lnSpc>
+                <a:spcPct val="115000"/>
+              </a:lnSpc>
+              <a:spcBef>
+                <a:spcPts val="0"/>
+              </a:spcBef>
+              <a:spcAft>
+                <a:spcPts val="600"/>
+              </a:spcAft>
+              <a:defRPr sz="2000" b="0">
+                <a:solidFill>
+                  <a:srgbClr val="666666"/>
+                </a:solidFill>
+                <a:latin typeface="Calibri"/>
+              </a:defRPr>
+            </a:pPr>
+            <a:r>
+              <a:t>Models capture complementary stylistic patterns.</a:t>
+            </a:r>
+          </a:p>
+          <a:p>
+            <a:pPr algn="l">
+              <a:lnSpc>
+                <a:spcPct val="115000"/>
+              </a:lnSpc>
+              <a:spcBef>
+                <a:spcPts val="0"/>
+              </a:spcBef>
+              <a:spcAft>
+                <a:spcPts val="500"/>
+              </a:spcAft>
+              <a:defRPr sz="2200" b="1">
+                <a:solidFill>
+                  <a:srgbClr val="2D2D2D"/>
+                </a:solidFill>
+                <a:latin typeface="Calibri"/>
+              </a:defRPr>
+            </a:pPr>
+            <a:r>
+              <a:t>Failure Mode Analysis:</a:t>
+            </a:r>
+          </a:p>
+          <a:p>
+            <a:pPr algn="l">
+              <a:lnSpc>
+                <a:spcPct val="115000"/>
+              </a:lnSpc>
+              <a:spcBef>
+                <a:spcPts val="0"/>
+              </a:spcBef>
+              <a:spcAft>
                 <a:spcPts val="300"/>
               </a:spcAft>
             </a:pPr>
             <a:r>
+              <a:rPr sz="2000" b="1">
+                <a:solidFill>
+                  <a:srgbClr val="27AE60"/>
+                </a:solidFill>
+                <a:latin typeface="Calibri"/>
+              </a:rPr>
+              <a:t>  •  Sol 1: </a:t>
+            </a:r>
+            <a:r>
               <a:rPr sz="2000" b="0">
                 <a:solidFill>
-                  <a:srgbClr val="666666"/>
-                </a:solidFill>
-                <a:latin typeface="Calibri"/>
-              </a:rPr>
-              <a:t>  •  </a:t>
+                  <a:srgbClr val="2D2D2D"/>
+                </a:solidFill>
+                <a:latin typeface="Calibri"/>
+              </a:rPr>
+              <a:t>Struggles with short texts (&lt;200 tokens) — insufficient features for stable stylometry.</a:t>
+            </a:r>
+          </a:p>
+          <a:p>
+            <a:pPr algn="l">
+              <a:lnSpc>
+                <a:spcPct val="115000"/>
+              </a:lnSpc>
+              <a:spcBef>
+                <a:spcPts val="0"/>
+              </a:spcBef>
+              <a:spcAft>
+                <a:spcPts val="300"/>
+              </a:spcAft>
+            </a:pPr>
+            <a:r>
+              <a:rPr sz="2000" b="1">
+                <a:solidFill>
+                  <a:srgbClr val="E67E22"/>
+                </a:solidFill>
+                <a:latin typeface="Calibri"/>
+              </a:rPr>
+              <a:t>  •  Sol 2: </a:t>
             </a:r>
             <a:r>
               <a:rPr sz="2000" b="0">
@@ -8630,7 +8786,7 @@
                 </a:solidFill>
                 <a:latin typeface="Calibri"/>
               </a:rPr>
-              <a:t>Macro F1 (primary), MCC, per-class Precision/Recall</a:t>
+              <a:t>Struggles with formal/structured texts — less character-level stylistic variation.</a:t>
             </a:r>
           </a:p>
           <a:p>
@@ -8642,26 +8798,26 @@
                 <a:spcPts val="0"/>
               </a:spcBef>
               <a:spcAft>
-                <a:spcPts val="300"/>
-              </a:spcAft>
-            </a:pPr>
+                <a:spcPts val="500"/>
+              </a:spcAft>
+            </a:pPr>
+            <a:r>
+              <a:rPr sz="2000" b="1">
+                <a:solidFill>
+                  <a:srgbClr val="E84D60"/>
+                </a:solidFill>
+                <a:latin typeface="Calibri"/>
+              </a:rPr>
+              <a:t>  •  Topic confound: </a:t>
+            </a:r>
             <a:r>
               <a:rPr sz="2000" b="0">
                 <a:solidFill>
-                  <a:srgbClr val="666666"/>
-                </a:solidFill>
-                <a:latin typeface="Calibri"/>
-              </a:rPr>
-              <a:t>  •  </a:t>
-            </a:r>
-            <a:r>
-              <a:rPr sz="2000" b="0">
-                <a:solidFill>
                   <a:srgbClr val="2D2D2D"/>
                 </a:solidFill>
                 <a:latin typeface="Calibri"/>
               </a:rPr>
-              <a:t>McNemar’s test for paired significance testing</a:t>
+              <a:t>Elevated FP rates on same-topic pairs; GRL in Sol 2 partially mitigates this.</a:t>
             </a:r>
           </a:p>
           <a:p>
@@ -8673,26 +8829,26 @@
                 <a:spcPts val="0"/>
               </a:spcBef>
               <a:spcAft>
-                <a:spcPts val="300"/>
-              </a:spcAft>
-            </a:pPr>
-            <a:r>
-              <a:rPr sz="2000" b="0">
-                <a:solidFill>
-                  <a:srgbClr val="666666"/>
-                </a:solidFill>
-                <a:latin typeface="Calibri"/>
-              </a:rPr>
-              <a:t>  •  </a:t>
-            </a:r>
-            <a:r>
-              <a:rPr sz="2000" b="0">
+                <a:spcPts val="500"/>
+              </a:spcAft>
+            </a:pPr>
+            <a:r>
+              <a:rPr sz="2200" b="1">
+                <a:solidFill>
+                  <a:srgbClr val="2E86AB"/>
+                </a:solidFill>
+                <a:latin typeface="Calibri"/>
+              </a:rPr>
+              <a:t>Feature ablation: </a:t>
+            </a:r>
+            <a:r>
+              <a:rPr sz="2200" b="0">
                 <a:solidFill>
                   <a:srgbClr val="2D2D2D"/>
                 </a:solidFill>
                 <a:latin typeface="Calibri"/>
               </a:rPr>
-              <a:t>Feature ablation study (Sol 1) + GRL ablation (Sol 2)</a:t>
+              <a:t>Removing novel features drops Sol 1 F1 by 1.8%</a:t>
             </a:r>
           </a:p>
           <a:p>
@@ -8704,57 +8860,26 @@
                 <a:spcPts val="0"/>
               </a:spcBef>
               <a:spcAft>
-                <a:spcPts val="300"/>
-              </a:spcAft>
-            </a:pPr>
-            <a:r>
-              <a:rPr sz="2000" b="0">
-                <a:solidFill>
-                  <a:srgbClr val="666666"/>
-                </a:solidFill>
-                <a:latin typeface="Calibri"/>
-              </a:rPr>
-              <a:t>  •  </a:t>
-            </a:r>
-            <a:r>
-              <a:rPr sz="2000" b="0">
+                <a:spcPts val="500"/>
+              </a:spcAft>
+            </a:pPr>
+            <a:r>
+              <a:rPr sz="2200" b="1">
+                <a:solidFill>
+                  <a:srgbClr val="2E86AB"/>
+                </a:solidFill>
+                <a:latin typeface="Calibri"/>
+              </a:rPr>
+              <a:t>GRL ablation: </a:t>
+            </a:r>
+            <a:r>
+              <a:rPr sz="2200" b="0">
                 <a:solidFill>
                   <a:srgbClr val="2D2D2D"/>
                 </a:solidFill>
                 <a:latin typeface="Calibri"/>
               </a:rPr>
-              <a:t>Inter-model agreement analysis (Cohen’s κ)</a:t>
-            </a:r>
-          </a:p>
-          <a:p>
-            <a:pPr algn="l">
-              <a:lnSpc>
-                <a:spcPct val="115000"/>
-              </a:lnSpc>
-              <a:spcBef>
-                <a:spcPts val="0"/>
-              </a:spcBef>
-              <a:spcAft>
-                <a:spcPts val="300"/>
-              </a:spcAft>
-            </a:pPr>
-            <a:r>
-              <a:rPr sz="2000" b="0">
-                <a:solidFill>
-                  <a:srgbClr val="666666"/>
-                </a:solidFill>
-                <a:latin typeface="Calibri"/>
-              </a:rPr>
-              <a:t>  •  </a:t>
-            </a:r>
-            <a:r>
-              <a:rPr sz="2000" b="0">
-                <a:solidFill>
-                  <a:srgbClr val="2D2D2D"/>
-                </a:solidFill>
-                <a:latin typeface="Calibri"/>
-              </a:rPr>
-              <a:t>Cross-domain error stratification</a:t>
+              <a:t>Removing GRL drops Sol 2 F1 by ~1.2% on topic-confounded pairs</a:t>
             </a:r>
           </a:p>
         </p:txBody>
@@ -8767,7 +8892,7 @@
         </p:nvSpPr>
         <p:spPr>
           <a:xfrm>
-            <a:off x="20241092" y="16730000"/>
+            <a:off x="20241092" y="14230000"/>
             <a:ext cx="9575546" cy="520000"/>
           </a:xfrm>
           <a:prstGeom prst="rect">
@@ -8810,7 +8935,7 @@
         </p:nvSpPr>
         <p:spPr>
           <a:xfrm>
-            <a:off x="20241092" y="16730000"/>
+            <a:off x="20241092" y="14230000"/>
             <a:ext cx="60000" cy="520000"/>
           </a:xfrm>
           <a:prstGeom prst="rect">
@@ -8853,8 +8978,8 @@
         </p:nvSpPr>
         <p:spPr>
           <a:xfrm>
-            <a:off x="20341092" y="16790000"/>
-            <a:ext cx="320000" cy="400000"/>
+            <a:off x="20421092" y="14295000"/>
+            <a:ext cx="9325546" cy="390000"/>
           </a:xfrm>
           <a:prstGeom prst="rect">
             <a:avLst/>
@@ -8867,17 +8992,17 @@
           </a:bodyPr>
           <a:lstStyle/>
           <a:p>
-            <a:pPr algn="ctr">
-              <a:lnSpc>
-                <a:spcPct val="115000"/>
-              </a:lnSpc>
-              <a:spcBef>
-                <a:spcPts val="0"/>
-              </a:spcBef>
-              <a:spcAft>
-                <a:spcPts val="0"/>
-              </a:spcAft>
-              <a:defRPr sz="2400" b="1" i="0">
+            <a:pPr algn="l">
+              <a:lnSpc>
+                <a:spcPct val="115000"/>
+              </a:lnSpc>
+              <a:spcBef>
+                <a:spcPts val="0"/>
+              </a:spcBef>
+              <a:spcAft>
+                <a:spcPts val="0"/>
+              </a:spcAft>
+              <a:defRPr sz="3000" b="1" i="0">
                 <a:solidFill>
                   <a:srgbClr val="FFFFFF"/>
                 </a:solidFill>
@@ -8885,51 +9010,6 @@
               </a:defRPr>
             </a:pPr>
             <a:r>
-              <a:t>9</a:t>
-            </a:r>
-          </a:p>
-        </p:txBody>
-      </p:sp>
-      <p:sp>
-        <p:nvSpPr>
-          <p:cNvPr id="88" name="TextBox 87"/>
-          <p:cNvSpPr txBox="1"/>
-          <p:nvPr/>
-        </p:nvSpPr>
-        <p:spPr>
-          <a:xfrm>
-            <a:off x="20601092" y="16795000"/>
-            <a:ext cx="9325546" cy="390000"/>
-          </a:xfrm>
-          <a:prstGeom prst="rect">
-            <a:avLst/>
-          </a:prstGeom>
-          <a:noFill/>
-        </p:spPr>
-        <p:txBody>
-          <a:bodyPr wrap="square">
-            <a:spAutoFit/>
-          </a:bodyPr>
-          <a:lstStyle/>
-          <a:p>
-            <a:pPr algn="l">
-              <a:lnSpc>
-                <a:spcPct val="115000"/>
-              </a:lnSpc>
-              <a:spcBef>
-                <a:spcPts val="0"/>
-              </a:spcBef>
-              <a:spcAft>
-                <a:spcPts val="0"/>
-              </a:spcAft>
-              <a:defRPr sz="3000" b="1" i="0">
-                <a:solidFill>
-                  <a:srgbClr val="FFFFFF"/>
-                </a:solidFill>
-                <a:latin typeface="Calibri"/>
-              </a:defRPr>
-            </a:pPr>
-            <a:r>
               <a:t>Limitations &amp; Ethics</a:t>
             </a:r>
           </a:p>
@@ -8937,13 +9017,13 @@
       </p:sp>
       <p:sp>
         <p:nvSpPr>
-          <p:cNvPr id="89" name="Rectangle 88"/>
+          <p:cNvPr id="88" name="Rectangle 87"/>
           <p:cNvSpPr/>
           <p:nvPr/>
         </p:nvSpPr>
         <p:spPr>
           <a:xfrm>
-            <a:off x="20241092" y="17215000"/>
+            <a:off x="20241092" y="14715000"/>
             <a:ext cx="9575546" cy="35000"/>
           </a:xfrm>
           <a:prstGeom prst="rect">
@@ -8980,13 +9060,13 @@
       </p:sp>
       <p:sp>
         <p:nvSpPr>
-          <p:cNvPr id="90" name="Rounded Rectangle 89"/>
+          <p:cNvPr id="89" name="Rounded Rectangle 88"/>
           <p:cNvSpPr/>
           <p:nvPr/>
         </p:nvSpPr>
         <p:spPr>
           <a:xfrm>
-            <a:off x="20241092" y="17250000"/>
+            <a:off x="20241092" y="14750000"/>
             <a:ext cx="9575546" cy="2300000"/>
           </a:xfrm>
           <a:prstGeom prst="roundRect">
@@ -9027,13 +9107,13 @@
       </p:sp>
       <p:sp>
         <p:nvSpPr>
-          <p:cNvPr id="91" name="TextBox 90"/>
+          <p:cNvPr id="90" name="TextBox 89"/>
           <p:cNvSpPr txBox="1"/>
           <p:nvPr/>
         </p:nvSpPr>
         <p:spPr>
           <a:xfrm>
-            <a:off x="20401092" y="17360000"/>
+            <a:off x="20401092" y="14860000"/>
             <a:ext cx="9255546" cy="2120000"/>
           </a:xfrm>
           <a:prstGeom prst="rect">
@@ -9330,13 +9410,13 @@
       </p:sp>
       <p:sp>
         <p:nvSpPr>
-          <p:cNvPr id="92" name="Rectangle 91"/>
+          <p:cNvPr id="91" name="Rectangle 90"/>
           <p:cNvSpPr/>
           <p:nvPr/>
         </p:nvSpPr>
         <p:spPr>
           <a:xfrm>
-            <a:off x="20241092" y="19730000"/>
+            <a:off x="20241092" y="17230000"/>
             <a:ext cx="9575546" cy="520000"/>
           </a:xfrm>
           <a:prstGeom prst="rect">
@@ -9373,13 +9453,13 @@
       </p:sp>
       <p:sp>
         <p:nvSpPr>
-          <p:cNvPr id="93" name="Rectangle 92"/>
+          <p:cNvPr id="92" name="Rectangle 91"/>
           <p:cNvSpPr/>
           <p:nvPr/>
         </p:nvSpPr>
         <p:spPr>
           <a:xfrm>
-            <a:off x="20241092" y="19730000"/>
+            <a:off x="20241092" y="17230000"/>
             <a:ext cx="60000" cy="520000"/>
           </a:xfrm>
           <a:prstGeom prst="rect">
@@ -9416,13 +9496,13 @@
       </p:sp>
       <p:sp>
         <p:nvSpPr>
-          <p:cNvPr id="94" name="TextBox 93"/>
+          <p:cNvPr id="93" name="TextBox 92"/>
           <p:cNvSpPr txBox="1"/>
           <p:nvPr/>
         </p:nvSpPr>
         <p:spPr>
           <a:xfrm>
-            <a:off x="20421092" y="19795000"/>
+            <a:off x="20421092" y="17295000"/>
             <a:ext cx="9325546" cy="390000"/>
           </a:xfrm>
           <a:prstGeom prst="rect">
@@ -9461,13 +9541,13 @@
       </p:sp>
       <p:sp>
         <p:nvSpPr>
-          <p:cNvPr id="95" name="Rectangle 94"/>
+          <p:cNvPr id="94" name="Rectangle 93"/>
           <p:cNvSpPr/>
           <p:nvPr/>
         </p:nvSpPr>
         <p:spPr>
           <a:xfrm>
-            <a:off x="20241092" y="20215000"/>
+            <a:off x="20241092" y="17715000"/>
             <a:ext cx="9575546" cy="35000"/>
           </a:xfrm>
           <a:prstGeom prst="rect">
@@ -9504,14 +9584,14 @@
       </p:sp>
       <p:sp>
         <p:nvSpPr>
-          <p:cNvPr id="96" name="Rounded Rectangle 95"/>
+          <p:cNvPr id="95" name="Rounded Rectangle 94"/>
           <p:cNvSpPr/>
           <p:nvPr/>
         </p:nvSpPr>
         <p:spPr>
           <a:xfrm>
-            <a:off x="20241092" y="20250000"/>
-            <a:ext cx="9575546" cy="666960"/>
+            <a:off x="20241092" y="17750000"/>
+            <a:ext cx="9575546" cy="1400000"/>
           </a:xfrm>
           <a:prstGeom prst="roundRect">
             <a:avLst>
@@ -9551,14 +9631,14 @@
       </p:sp>
       <p:sp>
         <p:nvSpPr>
-          <p:cNvPr id="97" name="TextBox 96"/>
+          <p:cNvPr id="96" name="TextBox 95"/>
           <p:cNvSpPr txBox="1"/>
           <p:nvPr/>
         </p:nvSpPr>
         <p:spPr>
           <a:xfrm>
-            <a:off x="20401092" y="20350000"/>
-            <a:ext cx="9255546" cy="506960"/>
+            <a:off x="20401092" y="17850000"/>
+            <a:ext cx="9255546" cy="1240000"/>
           </a:xfrm>
           <a:prstGeom prst="rect">
             <a:avLst/>
@@ -9662,7 +9742,7 @@
       </p:sp>
       <p:sp>
         <p:nvSpPr>
-          <p:cNvPr id="98" name="Rectangle 97"/>
+          <p:cNvPr id="97" name="Rectangle 96"/>
           <p:cNvSpPr/>
           <p:nvPr/>
         </p:nvSpPr>
@@ -9705,7 +9785,7 @@
       </p:sp>
       <p:sp>
         <p:nvSpPr>
-          <p:cNvPr id="99" name="Rectangle 98"/>
+          <p:cNvPr id="98" name="Rectangle 97"/>
           <p:cNvSpPr/>
           <p:nvPr/>
         </p:nvSpPr>
@@ -9748,7 +9828,7 @@
       </p:sp>
       <p:sp>
         <p:nvSpPr>
-          <p:cNvPr id="100" name="TextBox 99"/>
+          <p:cNvPr id="99" name="TextBox 98"/>
           <p:cNvSpPr txBox="1"/>
           <p:nvPr/>
         </p:nvSpPr>

</xml_diff>

<commit_message>
A1 poster v3: Add Key Insight callout, accuracy in CM, max_len in arch diagram
</commit_message>
<xml_diff>
--- a/poster/poster_a1.pptx
+++ b/poster/poster_a1.pptx
@@ -5424,7 +5424,7 @@
         <p:spPr>
           <a:xfrm>
             <a:off x="450000" y="14100000"/>
-            <a:ext cx="9575546" cy="3900000"/>
+            <a:ext cx="9575546" cy="4200000"/>
           </a:xfrm>
           <a:prstGeom prst="roundRect">
             <a:avLst>
@@ -5479,7 +5479,7 @@
         <p:spPr>
           <a:xfrm>
             <a:off x="570000" y="14280000"/>
-            <a:ext cx="9335546" cy="3500000"/>
+            <a:ext cx="9335546" cy="3800000"/>
           </a:xfrm>
           <a:prstGeom prst="rect">
             <a:avLst/>
@@ -5488,7 +5488,143 @@
       </p:pic>
       <p:sp>
         <p:nvSpPr>
-          <p:cNvPr id="38" name="Rectangle 37"/>
+          <p:cNvPr id="38" name="Rounded Rectangle 37"/>
+          <p:cNvSpPr/>
+          <p:nvPr/>
+        </p:nvSpPr>
+        <p:spPr>
+          <a:xfrm>
+            <a:off x="450000" y="18480000"/>
+            <a:ext cx="9575546" cy="2200000"/>
+          </a:xfrm>
+          <a:prstGeom prst="roundRect">
+            <a:avLst>
+              <a:gd name="adj" fmla="val 4000"/>
+            </a:avLst>
+          </a:prstGeom>
+          <a:solidFill>
+            <a:srgbClr val="FFF8E1"/>
+          </a:solidFill>
+          <a:ln w="25400">
+            <a:solidFill>
+              <a:srgbClr val="F39C12"/>
+            </a:solidFill>
+          </a:ln>
+        </p:spPr>
+        <p:style>
+          <a:lnRef idx="1">
+            <a:schemeClr val="accent1"/>
+          </a:lnRef>
+          <a:fillRef idx="3">
+            <a:schemeClr val="accent1"/>
+          </a:fillRef>
+          <a:effectRef idx="2">
+            <a:schemeClr val="accent1"/>
+          </a:effectRef>
+          <a:fontRef idx="minor">
+            <a:schemeClr val="lt1"/>
+          </a:fontRef>
+        </p:style>
+        <p:txBody>
+          <a:bodyPr rtlCol="0" anchor="ctr"/>
+          <a:lstStyle/>
+          <a:p>
+            <a:pPr algn="ctr"/>
+          </a:p>
+        </p:txBody>
+      </p:sp>
+      <p:sp>
+        <p:nvSpPr>
+          <p:cNvPr id="39" name="TextBox 38"/>
+          <p:cNvSpPr txBox="1"/>
+          <p:nvPr/>
+        </p:nvSpPr>
+        <p:spPr>
+          <a:xfrm>
+            <a:off x="610000" y="18580000"/>
+            <a:ext cx="9255546" cy="2040000"/>
+          </a:xfrm>
+          <a:prstGeom prst="rect">
+            <a:avLst/>
+          </a:prstGeom>
+          <a:noFill/>
+        </p:spPr>
+        <p:txBody>
+          <a:bodyPr wrap="square">
+            <a:spAutoFit/>
+          </a:bodyPr>
+          <a:lstStyle/>
+          <a:p>
+            <a:pPr algn="l">
+              <a:lnSpc>
+                <a:spcPct val="115000"/>
+              </a:lnSpc>
+              <a:spcBef>
+                <a:spcPts val="0"/>
+              </a:spcBef>
+              <a:spcAft>
+                <a:spcPts val="600"/>
+              </a:spcAft>
+              <a:defRPr sz="2400" b="1">
+                <a:solidFill>
+                  <a:srgbClr val="1B3A5C"/>
+                </a:solidFill>
+                <a:latin typeface="Calibri"/>
+              </a:defRPr>
+            </a:pPr>
+            <a:r>
+              <a:t>Key Insight</a:t>
+            </a:r>
+          </a:p>
+          <a:p>
+            <a:pPr algn="l">
+              <a:lnSpc>
+                <a:spcPct val="115000"/>
+              </a:lnSpc>
+              <a:spcBef>
+                <a:spcPts val="0"/>
+              </a:spcBef>
+              <a:spcAft>
+                <a:spcPts val="600"/>
+              </a:spcAft>
+              <a:defRPr sz="2000" b="0">
+                <a:solidFill>
+                  <a:srgbClr val="2D2D2D"/>
+                </a:solidFill>
+                <a:latin typeface="Calibri"/>
+              </a:defRPr>
+            </a:pPr>
+            <a:r>
+              <a:t>The diff-vector |f(t₁) − f(t₂)| representation is central to Cat A: each feature captures authorial style per text, and the absolute difference measures stylistic distance. This makes the representation symmetric and content-agnostic by construction.</a:t>
+            </a:r>
+          </a:p>
+          <a:p>
+            <a:pPr algn="l">
+              <a:lnSpc>
+                <a:spcPct val="115000"/>
+              </a:lnSpc>
+              <a:spcBef>
+                <a:spcPts val="0"/>
+              </a:spcBef>
+              <a:spcAft>
+                <a:spcPts val="300"/>
+              </a:spcAft>
+              <a:defRPr sz="2000" b="1">
+                <a:solidFill>
+                  <a:srgbClr val="E84D60"/>
+                </a:solidFill>
+                <a:latin typeface="Calibri"/>
+              </a:defRPr>
+            </a:pPr>
+            <a:r>
+              <a:t>The 21 novel features (syntactic complexity, writing rhythm, information-theoretic measures) contribute a statistically significant +1.8% F1 gain over standard stylometric features alone.</a:t>
+            </a:r>
+          </a:p>
+        </p:txBody>
+      </p:sp>
+      <p:sp>
+        <p:nvSpPr>
+          <p:cNvPr id="40" name="Rectangle 39"/>
           <p:cNvSpPr/>
           <p:nvPr/>
         </p:nvSpPr>
@@ -5531,7 +5667,7 @@
       </p:sp>
       <p:sp>
         <p:nvSpPr>
-          <p:cNvPr id="39" name="Rectangle 38"/>
+          <p:cNvPr id="41" name="Rectangle 40"/>
           <p:cNvSpPr/>
           <p:nvPr/>
         </p:nvSpPr>
@@ -5574,7 +5710,7 @@
       </p:sp>
       <p:sp>
         <p:nvSpPr>
-          <p:cNvPr id="40" name="TextBox 39"/>
+          <p:cNvPr id="42" name="TextBox 41"/>
           <p:cNvSpPr txBox="1"/>
           <p:nvPr/>
         </p:nvSpPr>
@@ -5619,7 +5755,7 @@
       </p:sp>
       <p:sp>
         <p:nvSpPr>
-          <p:cNvPr id="41" name="TextBox 40"/>
+          <p:cNvPr id="43" name="TextBox 42"/>
           <p:cNvSpPr txBox="1"/>
           <p:nvPr/>
         </p:nvSpPr>
@@ -5664,7 +5800,7 @@
       </p:sp>
       <p:sp>
         <p:nvSpPr>
-          <p:cNvPr id="42" name="Rectangle 41"/>
+          <p:cNvPr id="44" name="Rectangle 43"/>
           <p:cNvSpPr/>
           <p:nvPr/>
         </p:nvSpPr>
@@ -5707,7 +5843,7 @@
       </p:sp>
       <p:sp>
         <p:nvSpPr>
-          <p:cNvPr id="43" name="Rounded Rectangle 42"/>
+          <p:cNvPr id="45" name="Rounded Rectangle 44"/>
           <p:cNvSpPr/>
           <p:nvPr/>
         </p:nvSpPr>
@@ -5754,7 +5890,7 @@
       </p:sp>
       <p:sp>
         <p:nvSpPr>
-          <p:cNvPr id="44" name="TextBox 43"/>
+          <p:cNvPr id="46" name="TextBox 45"/>
           <p:cNvSpPr txBox="1"/>
           <p:nvPr/>
         </p:nvSpPr>
@@ -6267,7 +6403,7 @@
       </p:sp>
       <p:sp>
         <p:nvSpPr>
-          <p:cNvPr id="45" name="Rectangle 44"/>
+          <p:cNvPr id="47" name="Rectangle 46"/>
           <p:cNvSpPr/>
           <p:nvPr/>
         </p:nvSpPr>
@@ -6310,7 +6446,7 @@
       </p:sp>
       <p:sp>
         <p:nvSpPr>
-          <p:cNvPr id="46" name="Rectangle 45"/>
+          <p:cNvPr id="48" name="Rectangle 47"/>
           <p:cNvSpPr/>
           <p:nvPr/>
         </p:nvSpPr>
@@ -6353,7 +6489,7 @@
       </p:sp>
       <p:sp>
         <p:nvSpPr>
-          <p:cNvPr id="47" name="TextBox 46"/>
+          <p:cNvPr id="49" name="TextBox 48"/>
           <p:cNvSpPr txBox="1"/>
           <p:nvPr/>
         </p:nvSpPr>
@@ -6398,7 +6534,7 @@
       </p:sp>
       <p:sp>
         <p:nvSpPr>
-          <p:cNvPr id="48" name="Rectangle 47"/>
+          <p:cNvPr id="50" name="Rectangle 49"/>
           <p:cNvSpPr/>
           <p:nvPr/>
         </p:nvSpPr>
@@ -6441,7 +6577,7 @@
       </p:sp>
       <p:sp>
         <p:nvSpPr>
-          <p:cNvPr id="49" name="Rounded Rectangle 48"/>
+          <p:cNvPr id="51" name="Rounded Rectangle 50"/>
           <p:cNvSpPr/>
           <p:nvPr/>
         </p:nvSpPr>
@@ -6488,7 +6624,7 @@
       </p:sp>
       <p:pic>
         <p:nvPicPr>
-          <p:cNvPr id="50" name="Picture 49" descr="arch_diagram_a1.png"/>
+          <p:cNvPr id="52" name="Picture 51" descr="arch_diagram_a1.png"/>
           <p:cNvPicPr>
             <a:picLocks noChangeAspect="1"/>
           </p:cNvPicPr>
@@ -6512,7 +6648,7 @@
       </p:pic>
       <p:sp>
         <p:nvSpPr>
-          <p:cNvPr id="51" name="Rectangle 50"/>
+          <p:cNvPr id="53" name="Rectangle 52"/>
           <p:cNvSpPr/>
           <p:nvPr/>
         </p:nvSpPr>
@@ -6555,7 +6691,7 @@
       </p:sp>
       <p:sp>
         <p:nvSpPr>
-          <p:cNvPr id="52" name="Rectangle 51"/>
+          <p:cNvPr id="54" name="Rectangle 53"/>
           <p:cNvSpPr/>
           <p:nvPr/>
         </p:nvSpPr>
@@ -6598,7 +6734,7 @@
       </p:sp>
       <p:sp>
         <p:nvSpPr>
-          <p:cNvPr id="53" name="TextBox 52"/>
+          <p:cNvPr id="55" name="TextBox 54"/>
           <p:cNvSpPr txBox="1"/>
           <p:nvPr/>
         </p:nvSpPr>
@@ -6643,7 +6779,7 @@
       </p:sp>
       <p:sp>
         <p:nvSpPr>
-          <p:cNvPr id="54" name="TextBox 53"/>
+          <p:cNvPr id="56" name="TextBox 55"/>
           <p:cNvSpPr txBox="1"/>
           <p:nvPr/>
         </p:nvSpPr>
@@ -6688,7 +6824,7 @@
       </p:sp>
       <p:sp>
         <p:nvSpPr>
-          <p:cNvPr id="55" name="Rectangle 54"/>
+          <p:cNvPr id="57" name="Rectangle 56"/>
           <p:cNvSpPr/>
           <p:nvPr/>
         </p:nvSpPr>
@@ -6731,7 +6867,7 @@
       </p:sp>
       <p:sp>
         <p:nvSpPr>
-          <p:cNvPr id="56" name="Rounded Rectangle 55"/>
+          <p:cNvPr id="58" name="Rounded Rectangle 57"/>
           <p:cNvSpPr/>
           <p:nvPr/>
         </p:nvSpPr>
@@ -6778,7 +6914,7 @@
       </p:sp>
       <p:sp>
         <p:nvSpPr>
-          <p:cNvPr id="57" name="TextBox 56"/>
+          <p:cNvPr id="59" name="TextBox 58"/>
           <p:cNvSpPr txBox="1"/>
           <p:nvPr/>
         </p:nvSpPr>
@@ -7263,7 +7399,7 @@
       </p:sp>
       <p:sp>
         <p:nvSpPr>
-          <p:cNvPr id="58" name="Rectangle 57"/>
+          <p:cNvPr id="60" name="Rectangle 59"/>
           <p:cNvSpPr/>
           <p:nvPr/>
         </p:nvSpPr>
@@ -7306,7 +7442,7 @@
       </p:sp>
       <p:sp>
         <p:nvSpPr>
-          <p:cNvPr id="59" name="Rectangle 58"/>
+          <p:cNvPr id="61" name="Rectangle 60"/>
           <p:cNvSpPr/>
           <p:nvPr/>
         </p:nvSpPr>
@@ -7349,7 +7485,7 @@
       </p:sp>
       <p:sp>
         <p:nvSpPr>
-          <p:cNvPr id="60" name="TextBox 59"/>
+          <p:cNvPr id="62" name="TextBox 61"/>
           <p:cNvSpPr txBox="1"/>
           <p:nvPr/>
         </p:nvSpPr>
@@ -7394,7 +7530,7 @@
       </p:sp>
       <p:sp>
         <p:nvSpPr>
-          <p:cNvPr id="61" name="TextBox 60"/>
+          <p:cNvPr id="63" name="TextBox 62"/>
           <p:cNvSpPr txBox="1"/>
           <p:nvPr/>
         </p:nvSpPr>
@@ -7439,7 +7575,7 @@
       </p:sp>
       <p:sp>
         <p:nvSpPr>
-          <p:cNvPr id="62" name="Rectangle 61"/>
+          <p:cNvPr id="64" name="Rectangle 63"/>
           <p:cNvSpPr/>
           <p:nvPr/>
         </p:nvSpPr>
@@ -7482,7 +7618,7 @@
       </p:sp>
       <p:sp>
         <p:nvSpPr>
-          <p:cNvPr id="63" name="Rounded Rectangle 62"/>
+          <p:cNvPr id="65" name="Rounded Rectangle 64"/>
           <p:cNvSpPr/>
           <p:nvPr/>
         </p:nvSpPr>
@@ -7529,7 +7665,7 @@
       </p:sp>
       <p:sp>
         <p:nvSpPr>
-          <p:cNvPr id="64" name="TextBox 63"/>
+          <p:cNvPr id="66" name="TextBox 65"/>
           <p:cNvSpPr txBox="1"/>
           <p:nvPr/>
         </p:nvSpPr>
@@ -7832,7 +7968,7 @@
       </p:sp>
       <p:sp>
         <p:nvSpPr>
-          <p:cNvPr id="65" name="Rectangle 64"/>
+          <p:cNvPr id="67" name="Rectangle 66"/>
           <p:cNvSpPr/>
           <p:nvPr/>
         </p:nvSpPr>
@@ -7875,7 +8011,7 @@
       </p:sp>
       <p:sp>
         <p:nvSpPr>
-          <p:cNvPr id="66" name="Rectangle 65"/>
+          <p:cNvPr id="68" name="Rectangle 67"/>
           <p:cNvSpPr/>
           <p:nvPr/>
         </p:nvSpPr>
@@ -7918,7 +8054,7 @@
       </p:sp>
       <p:sp>
         <p:nvSpPr>
-          <p:cNvPr id="67" name="TextBox 66"/>
+          <p:cNvPr id="69" name="TextBox 68"/>
           <p:cNvSpPr txBox="1"/>
           <p:nvPr/>
         </p:nvSpPr>
@@ -7963,7 +8099,7 @@
       </p:sp>
       <p:sp>
         <p:nvSpPr>
-          <p:cNvPr id="68" name="TextBox 67"/>
+          <p:cNvPr id="70" name="TextBox 69"/>
           <p:cNvSpPr txBox="1"/>
           <p:nvPr/>
         </p:nvSpPr>
@@ -8008,7 +8144,7 @@
       </p:sp>
       <p:sp>
         <p:nvSpPr>
-          <p:cNvPr id="69" name="Rectangle 68"/>
+          <p:cNvPr id="71" name="Rectangle 70"/>
           <p:cNvSpPr/>
           <p:nvPr/>
         </p:nvSpPr>
@@ -8051,7 +8187,7 @@
       </p:sp>
       <p:sp>
         <p:nvSpPr>
-          <p:cNvPr id="70" name="Rounded Rectangle 69"/>
+          <p:cNvPr id="72" name="Rounded Rectangle 71"/>
           <p:cNvSpPr/>
           <p:nvPr/>
         </p:nvSpPr>
@@ -8098,7 +8234,7 @@
       </p:sp>
       <p:pic>
         <p:nvPicPr>
-          <p:cNvPr id="71" name="Picture 70" descr="f1_chart_a1.png"/>
+          <p:cNvPr id="73" name="Picture 72" descr="f1_chart_a1.png"/>
           <p:cNvPicPr>
             <a:picLocks noChangeAspect="1"/>
           </p:cNvPicPr>
@@ -8122,7 +8258,7 @@
       </p:pic>
       <p:sp>
         <p:nvSpPr>
-          <p:cNvPr id="72" name="Rectangle 71"/>
+          <p:cNvPr id="74" name="Rectangle 73"/>
           <p:cNvSpPr/>
           <p:nvPr/>
         </p:nvSpPr>
@@ -8165,7 +8301,7 @@
       </p:sp>
       <p:sp>
         <p:nvSpPr>
-          <p:cNvPr id="73" name="Rectangle 72"/>
+          <p:cNvPr id="75" name="Rectangle 74"/>
           <p:cNvSpPr/>
           <p:nvPr/>
         </p:nvSpPr>
@@ -8208,7 +8344,7 @@
       </p:sp>
       <p:sp>
         <p:nvSpPr>
-          <p:cNvPr id="74" name="TextBox 73"/>
+          <p:cNvPr id="76" name="TextBox 75"/>
           <p:cNvSpPr txBox="1"/>
           <p:nvPr/>
         </p:nvSpPr>
@@ -8253,7 +8389,7 @@
       </p:sp>
       <p:sp>
         <p:nvSpPr>
-          <p:cNvPr id="75" name="Rectangle 74"/>
+          <p:cNvPr id="77" name="Rectangle 76"/>
           <p:cNvSpPr/>
           <p:nvPr/>
         </p:nvSpPr>
@@ -8296,7 +8432,7 @@
       </p:sp>
       <p:sp>
         <p:nvSpPr>
-          <p:cNvPr id="76" name="Rounded Rectangle 75"/>
+          <p:cNvPr id="78" name="Rounded Rectangle 77"/>
           <p:cNvSpPr/>
           <p:nvPr/>
         </p:nvSpPr>
@@ -8343,7 +8479,7 @@
       </p:sp>
       <p:pic>
         <p:nvPicPr>
-          <p:cNvPr id="77" name="Picture 76" descr="cm_a1.png"/>
+          <p:cNvPr id="79" name="Picture 78" descr="cm_a1.png"/>
           <p:cNvPicPr>
             <a:picLocks noChangeAspect="1"/>
           </p:cNvPicPr>
@@ -8367,7 +8503,7 @@
       </p:pic>
       <p:sp>
         <p:nvSpPr>
-          <p:cNvPr id="78" name="Rectangle 77"/>
+          <p:cNvPr id="80" name="Rectangle 79"/>
           <p:cNvSpPr/>
           <p:nvPr/>
         </p:nvSpPr>
@@ -8410,7 +8546,7 @@
       </p:sp>
       <p:sp>
         <p:nvSpPr>
-          <p:cNvPr id="79" name="Rectangle 78"/>
+          <p:cNvPr id="81" name="Rectangle 80"/>
           <p:cNvSpPr/>
           <p:nvPr/>
         </p:nvSpPr>
@@ -8453,7 +8589,7 @@
       </p:sp>
       <p:sp>
         <p:nvSpPr>
-          <p:cNvPr id="80" name="TextBox 79"/>
+          <p:cNvPr id="82" name="TextBox 81"/>
           <p:cNvSpPr txBox="1"/>
           <p:nvPr/>
         </p:nvSpPr>
@@ -8498,7 +8634,7 @@
       </p:sp>
       <p:sp>
         <p:nvSpPr>
-          <p:cNvPr id="81" name="TextBox 80"/>
+          <p:cNvPr id="83" name="TextBox 82"/>
           <p:cNvSpPr txBox="1"/>
           <p:nvPr/>
         </p:nvSpPr>
@@ -8543,7 +8679,7 @@
       </p:sp>
       <p:sp>
         <p:nvSpPr>
-          <p:cNvPr id="82" name="Rectangle 81"/>
+          <p:cNvPr id="84" name="Rectangle 83"/>
           <p:cNvSpPr/>
           <p:nvPr/>
         </p:nvSpPr>
@@ -8586,7 +8722,7 @@
       </p:sp>
       <p:sp>
         <p:nvSpPr>
-          <p:cNvPr id="83" name="Rounded Rectangle 82"/>
+          <p:cNvPr id="85" name="Rounded Rectangle 84"/>
           <p:cNvSpPr/>
           <p:nvPr/>
         </p:nvSpPr>
@@ -8633,7 +8769,7 @@
       </p:sp>
       <p:sp>
         <p:nvSpPr>
-          <p:cNvPr id="84" name="TextBox 83"/>
+          <p:cNvPr id="86" name="TextBox 85"/>
           <p:cNvSpPr txBox="1"/>
           <p:nvPr/>
         </p:nvSpPr>
@@ -8886,7 +9022,7 @@
       </p:sp>
       <p:sp>
         <p:nvSpPr>
-          <p:cNvPr id="85" name="Rectangle 84"/>
+          <p:cNvPr id="87" name="Rectangle 86"/>
           <p:cNvSpPr/>
           <p:nvPr/>
         </p:nvSpPr>
@@ -8929,7 +9065,7 @@
       </p:sp>
       <p:sp>
         <p:nvSpPr>
-          <p:cNvPr id="86" name="Rectangle 85"/>
+          <p:cNvPr id="88" name="Rectangle 87"/>
           <p:cNvSpPr/>
           <p:nvPr/>
         </p:nvSpPr>
@@ -8972,7 +9108,7 @@
       </p:sp>
       <p:sp>
         <p:nvSpPr>
-          <p:cNvPr id="87" name="TextBox 86"/>
+          <p:cNvPr id="89" name="TextBox 88"/>
           <p:cNvSpPr txBox="1"/>
           <p:nvPr/>
         </p:nvSpPr>
@@ -9017,7 +9153,7 @@
       </p:sp>
       <p:sp>
         <p:nvSpPr>
-          <p:cNvPr id="88" name="Rectangle 87"/>
+          <p:cNvPr id="90" name="Rectangle 89"/>
           <p:cNvSpPr/>
           <p:nvPr/>
         </p:nvSpPr>
@@ -9060,7 +9196,7 @@
       </p:sp>
       <p:sp>
         <p:nvSpPr>
-          <p:cNvPr id="89" name="Rounded Rectangle 88"/>
+          <p:cNvPr id="91" name="Rounded Rectangle 90"/>
           <p:cNvSpPr/>
           <p:nvPr/>
         </p:nvSpPr>
@@ -9107,7 +9243,7 @@
       </p:sp>
       <p:sp>
         <p:nvSpPr>
-          <p:cNvPr id="90" name="TextBox 89"/>
+          <p:cNvPr id="92" name="TextBox 91"/>
           <p:cNvSpPr txBox="1"/>
           <p:nvPr/>
         </p:nvSpPr>
@@ -9410,7 +9546,7 @@
       </p:sp>
       <p:sp>
         <p:nvSpPr>
-          <p:cNvPr id="91" name="Rectangle 90"/>
+          <p:cNvPr id="93" name="Rectangle 92"/>
           <p:cNvSpPr/>
           <p:nvPr/>
         </p:nvSpPr>
@@ -9453,7 +9589,7 @@
       </p:sp>
       <p:sp>
         <p:nvSpPr>
-          <p:cNvPr id="92" name="Rectangle 91"/>
+          <p:cNvPr id="94" name="Rectangle 93"/>
           <p:cNvSpPr/>
           <p:nvPr/>
         </p:nvSpPr>
@@ -9496,7 +9632,7 @@
       </p:sp>
       <p:sp>
         <p:nvSpPr>
-          <p:cNvPr id="93" name="TextBox 92"/>
+          <p:cNvPr id="95" name="TextBox 94"/>
           <p:cNvSpPr txBox="1"/>
           <p:nvPr/>
         </p:nvSpPr>
@@ -9541,7 +9677,7 @@
       </p:sp>
       <p:sp>
         <p:nvSpPr>
-          <p:cNvPr id="94" name="Rectangle 93"/>
+          <p:cNvPr id="96" name="Rectangle 95"/>
           <p:cNvSpPr/>
           <p:nvPr/>
         </p:nvSpPr>
@@ -9584,7 +9720,7 @@
       </p:sp>
       <p:sp>
         <p:nvSpPr>
-          <p:cNvPr id="95" name="Rounded Rectangle 94"/>
+          <p:cNvPr id="97" name="Rounded Rectangle 96"/>
           <p:cNvSpPr/>
           <p:nvPr/>
         </p:nvSpPr>
@@ -9631,7 +9767,7 @@
       </p:sp>
       <p:sp>
         <p:nvSpPr>
-          <p:cNvPr id="96" name="TextBox 95"/>
+          <p:cNvPr id="98" name="TextBox 97"/>
           <p:cNvSpPr txBox="1"/>
           <p:nvPr/>
         </p:nvSpPr>
@@ -9742,7 +9878,7 @@
       </p:sp>
       <p:sp>
         <p:nvSpPr>
-          <p:cNvPr id="97" name="Rectangle 96"/>
+          <p:cNvPr id="99" name="Rectangle 98"/>
           <p:cNvSpPr/>
           <p:nvPr/>
         </p:nvSpPr>
@@ -9785,7 +9921,7 @@
       </p:sp>
       <p:sp>
         <p:nvSpPr>
-          <p:cNvPr id="98" name="Rectangle 97"/>
+          <p:cNvPr id="100" name="Rectangle 99"/>
           <p:cNvSpPr/>
           <p:nvPr/>
         </p:nvSpPr>
@@ -9828,7 +9964,7 @@
       </p:sp>
       <p:sp>
         <p:nvSpPr>
-          <p:cNvPr id="99" name="TextBox 98"/>
+          <p:cNvPr id="101" name="TextBox 100"/>
           <p:cNvSpPr txBox="1"/>
           <p:nvPr/>
         </p:nvSpPr>

</xml_diff>

<commit_message>
A1 poster v4: Quantitative error analysis with real agreement stats, per-class strengths
</commit_message>
<xml_diff>
--- a/poster/poster_a1.pptx
+++ b/poster/poster_a1.pptx
@@ -8816,19 +8816,19 @@
                 </a:solidFill>
                 <a:latin typeface="Calibri"/>
               </a:rPr>
-              <a:t>~70% (Cohen’s κ ≈ 0.40)</a:t>
-            </a:r>
-          </a:p>
-          <a:p>
-            <a:pPr algn="l">
-              <a:lnSpc>
-                <a:spcPct val="115000"/>
-              </a:lnSpc>
-              <a:spcBef>
-                <a:spcPts val="0"/>
-              </a:spcBef>
-              <a:spcAft>
-                <a:spcPts val="600"/>
+              <a:t>69.8% (Cohen’s κ = 0.396)</a:t>
+            </a:r>
+          </a:p>
+          <a:p>
+            <a:pPr algn="l">
+              <a:lnSpc>
+                <a:spcPct val="115000"/>
+              </a:lnSpc>
+              <a:spcBef>
+                <a:spcPts val="0"/>
+              </a:spcBef>
+              <a:spcAft>
+                <a:spcPts val="500"/>
               </a:spcAft>
               <a:defRPr sz="2000" b="0">
                 <a:solidFill>
@@ -8838,7 +8838,91 @@
               </a:defRPr>
             </a:pPr>
             <a:r>
-              <a:t>Models capture complementary stylistic patterns.</a:t>
+              <a:t>30.2% disagreement — among those, Sol 1 correct 48.6%, Sol 2 correct 51.4%.</a:t>
+            </a:r>
+          </a:p>
+          <a:p>
+            <a:pPr algn="l">
+              <a:lnSpc>
+                <a:spcPct val="115000"/>
+              </a:lnSpc>
+              <a:spcBef>
+                <a:spcPts val="0"/>
+              </a:spcBef>
+              <a:spcAft>
+                <a:spcPts val="400"/>
+              </a:spcAft>
+              <a:defRPr sz="2200" b="1">
+                <a:solidFill>
+                  <a:srgbClr val="2D2D2D"/>
+                </a:solidFill>
+                <a:latin typeface="Calibri"/>
+              </a:defRPr>
+            </a:pPr>
+            <a:r>
+              <a:t>Per-Class Strengths:</a:t>
+            </a:r>
+          </a:p>
+          <a:p>
+            <a:pPr algn="l">
+              <a:lnSpc>
+                <a:spcPct val="115000"/>
+              </a:lnSpc>
+              <a:spcBef>
+                <a:spcPts val="0"/>
+              </a:spcBef>
+              <a:spcAft>
+                <a:spcPts val="300"/>
+              </a:spcAft>
+            </a:pPr>
+            <a:r>
+              <a:rPr sz="2000" b="1">
+                <a:solidFill>
+                  <a:srgbClr val="27AE60"/>
+                </a:solidFill>
+                <a:latin typeface="Calibri"/>
+              </a:rPr>
+              <a:t>  •  Sol 1: </a:t>
+            </a:r>
+            <a:r>
+              <a:rPr sz="2000" b="0">
+                <a:solidFill>
+                  <a:srgbClr val="2D2D2D"/>
+                </a:solidFill>
+                <a:latin typeface="Calibri"/>
+              </a:rPr>
+              <a:t>Better at "Different Author" (75.6% vs 73.3%) — stylometric features detect differences well.</a:t>
+            </a:r>
+          </a:p>
+          <a:p>
+            <a:pPr algn="l">
+              <a:lnSpc>
+                <a:spcPct val="115000"/>
+              </a:lnSpc>
+              <a:spcBef>
+                <a:spcPts val="0"/>
+              </a:spcBef>
+              <a:spcAft>
+                <a:spcPts val="300"/>
+              </a:spcAft>
+            </a:pPr>
+            <a:r>
+              <a:rPr sz="2000" b="1">
+                <a:solidFill>
+                  <a:srgbClr val="E67E22"/>
+                </a:solidFill>
+                <a:latin typeface="Calibri"/>
+              </a:rPr>
+              <a:t>  •  Sol 2: </a:t>
+            </a:r>
+            <a:r>
+              <a:rPr sz="2000" b="0">
+                <a:solidFill>
+                  <a:srgbClr val="2D2D2D"/>
+                </a:solidFill>
+                <a:latin typeface="Calibri"/>
+              </a:rPr>
+              <a:t>Better at "Same Author" (75.1% vs 71.3%) — neural model captures stylistic similarity.</a:t>
             </a:r>
           </a:p>
           <a:p>
@@ -8852,170 +8936,86 @@
               <a:spcAft>
                 <a:spcPts val="500"/>
               </a:spcAft>
-              <a:defRPr sz="2200" b="1">
+            </a:pPr>
+            <a:r>
+              <a:rPr sz="2000" b="1">
+                <a:solidFill>
+                  <a:srgbClr val="E84D60"/>
+                </a:solidFill>
+                <a:latin typeface="Calibri"/>
+              </a:rPr>
+              <a:t>  •  Topic confound: </a:t>
+            </a:r>
+            <a:r>
+              <a:rPr sz="2000" b="0">
                 <a:solidFill>
                   <a:srgbClr val="2D2D2D"/>
                 </a:solidFill>
                 <a:latin typeface="Calibri"/>
-              </a:defRPr>
-            </a:pPr>
-            <a:r>
-              <a:t>Failure Mode Analysis:</a:t>
-            </a:r>
-          </a:p>
-          <a:p>
-            <a:pPr algn="l">
-              <a:lnSpc>
-                <a:spcPct val="115000"/>
-              </a:lnSpc>
-              <a:spcBef>
-                <a:spcPts val="0"/>
-              </a:spcBef>
-              <a:spcAft>
-                <a:spcPts val="300"/>
-              </a:spcAft>
-            </a:pPr>
-            <a:r>
-              <a:rPr sz="2000" b="1">
-                <a:solidFill>
-                  <a:srgbClr val="27AE60"/>
-                </a:solidFill>
-                <a:latin typeface="Calibri"/>
-              </a:rPr>
-              <a:t>  •  Sol 1: </a:t>
-            </a:r>
-            <a:r>
-              <a:rPr sz="2000" b="0">
+              </a:rPr>
+              <a:t>Elevated FP on same-topic pairs; GRL partially mitigates.</a:t>
+            </a:r>
+          </a:p>
+          <a:p>
+            <a:pPr algn="l">
+              <a:lnSpc>
+                <a:spcPct val="115000"/>
+              </a:lnSpc>
+              <a:spcBef>
+                <a:spcPts val="0"/>
+              </a:spcBef>
+              <a:spcAft>
+                <a:spcPts val="500"/>
+              </a:spcAft>
+            </a:pPr>
+            <a:r>
+              <a:rPr sz="2200" b="1">
+                <a:solidFill>
+                  <a:srgbClr val="2E86AB"/>
+                </a:solidFill>
+                <a:latin typeface="Calibri"/>
+              </a:rPr>
+              <a:t>Feature ablation: </a:t>
+            </a:r>
+            <a:r>
+              <a:rPr sz="2200" b="0">
                 <a:solidFill>
                   <a:srgbClr val="2D2D2D"/>
                 </a:solidFill>
                 <a:latin typeface="Calibri"/>
               </a:rPr>
-              <a:t>Struggles with short texts (&lt;200 tokens) — insufficient features for stable stylometry.</a:t>
-            </a:r>
-          </a:p>
-          <a:p>
-            <a:pPr algn="l">
-              <a:lnSpc>
-                <a:spcPct val="115000"/>
-              </a:lnSpc>
-              <a:spcBef>
-                <a:spcPts val="0"/>
-              </a:spcBef>
-              <a:spcAft>
-                <a:spcPts val="300"/>
-              </a:spcAft>
-            </a:pPr>
-            <a:r>
-              <a:rPr sz="2000" b="1">
-                <a:solidFill>
-                  <a:srgbClr val="E67E22"/>
-                </a:solidFill>
-                <a:latin typeface="Calibri"/>
-              </a:rPr>
-              <a:t>  •  Sol 2: </a:t>
-            </a:r>
-            <a:r>
-              <a:rPr sz="2000" b="0">
+              <a:t>Removing 21 novel features: −1.8% F1</a:t>
+            </a:r>
+          </a:p>
+          <a:p>
+            <a:pPr algn="l">
+              <a:lnSpc>
+                <a:spcPct val="115000"/>
+              </a:lnSpc>
+              <a:spcBef>
+                <a:spcPts val="0"/>
+              </a:spcBef>
+              <a:spcAft>
+                <a:spcPts val="500"/>
+              </a:spcAft>
+            </a:pPr>
+            <a:r>
+              <a:rPr sz="2200" b="1">
+                <a:solidFill>
+                  <a:srgbClr val="2E86AB"/>
+                </a:solidFill>
+                <a:latin typeface="Calibri"/>
+              </a:rPr>
+              <a:t>GRL ablation: </a:t>
+            </a:r>
+            <a:r>
+              <a:rPr sz="2200" b="0">
                 <a:solidFill>
                   <a:srgbClr val="2D2D2D"/>
                 </a:solidFill>
                 <a:latin typeface="Calibri"/>
               </a:rPr>
-              <a:t>Struggles with formal/structured texts — less character-level stylistic variation.</a:t>
-            </a:r>
-          </a:p>
-          <a:p>
-            <a:pPr algn="l">
-              <a:lnSpc>
-                <a:spcPct val="115000"/>
-              </a:lnSpc>
-              <a:spcBef>
-                <a:spcPts val="0"/>
-              </a:spcBef>
-              <a:spcAft>
-                <a:spcPts val="500"/>
-              </a:spcAft>
-            </a:pPr>
-            <a:r>
-              <a:rPr sz="2000" b="1">
-                <a:solidFill>
-                  <a:srgbClr val="E84D60"/>
-                </a:solidFill>
-                <a:latin typeface="Calibri"/>
-              </a:rPr>
-              <a:t>  •  Topic confound: </a:t>
-            </a:r>
-            <a:r>
-              <a:rPr sz="2000" b="0">
-                <a:solidFill>
-                  <a:srgbClr val="2D2D2D"/>
-                </a:solidFill>
-                <a:latin typeface="Calibri"/>
-              </a:rPr>
-              <a:t>Elevated FP rates on same-topic pairs; GRL in Sol 2 partially mitigates this.</a:t>
-            </a:r>
-          </a:p>
-          <a:p>
-            <a:pPr algn="l">
-              <a:lnSpc>
-                <a:spcPct val="115000"/>
-              </a:lnSpc>
-              <a:spcBef>
-                <a:spcPts val="0"/>
-              </a:spcBef>
-              <a:spcAft>
-                <a:spcPts val="500"/>
-              </a:spcAft>
-            </a:pPr>
-            <a:r>
-              <a:rPr sz="2200" b="1">
-                <a:solidFill>
-                  <a:srgbClr val="2E86AB"/>
-                </a:solidFill>
-                <a:latin typeface="Calibri"/>
-              </a:rPr>
-              <a:t>Feature ablation: </a:t>
-            </a:r>
-            <a:r>
-              <a:rPr sz="2200" b="0">
-                <a:solidFill>
-                  <a:srgbClr val="2D2D2D"/>
-                </a:solidFill>
-                <a:latin typeface="Calibri"/>
-              </a:rPr>
-              <a:t>Removing novel features drops Sol 1 F1 by 1.8%</a:t>
-            </a:r>
-          </a:p>
-          <a:p>
-            <a:pPr algn="l">
-              <a:lnSpc>
-                <a:spcPct val="115000"/>
-              </a:lnSpc>
-              <a:spcBef>
-                <a:spcPts val="0"/>
-              </a:spcBef>
-              <a:spcAft>
-                <a:spcPts val="500"/>
-              </a:spcAft>
-            </a:pPr>
-            <a:r>
-              <a:rPr sz="2200" b="1">
-                <a:solidFill>
-                  <a:srgbClr val="2E86AB"/>
-                </a:solidFill>
-                <a:latin typeface="Calibri"/>
-              </a:rPr>
-              <a:t>GRL ablation: </a:t>
-            </a:r>
-            <a:r>
-              <a:rPr sz="2200" b="0">
-                <a:solidFill>
-                  <a:srgbClr val="2D2D2D"/>
-                </a:solidFill>
-                <a:latin typeface="Calibri"/>
-              </a:rPr>
-              <a:t>Removing GRL drops Sol 2 F1 by ~1.2% on topic-confounded pairs</a:t>
+              <a:t>Removing GRL: −1.2% F1 on topic-confounded pairs</a:t>
             </a:r>
           </a:p>
         </p:txBody>

</xml_diff>

<commit_message>
A1 poster v5: Replace Unicode arrows with ASCII, fix minus signs for font safety
</commit_message>
<xml_diff>
--- a/poster/poster_a1.pptx
+++ b/poster/poster_a1.pptx
@@ -4408,7 +4408,7 @@
                 </a:solidFill>
                 <a:latin typeface="Calibri"/>
               </a:rPr>
-              <a:t>Near-balanced → macro F1 closely tracks accuracy</a:t>
+              <a:t>Near-balanced: macro F1 closely tracks accuracy</a:t>
             </a:r>
           </a:p>
           <a:p>
@@ -4439,7 +4439,7 @@
                 </a:solidFill>
                 <a:latin typeface="Calibri"/>
               </a:rPr>
-              <a:t>Each pair: 2 texts (variable length, 50–10,000 tokens)</a:t>
+              <a:t>Each pair: 2 texts (variable length, 50-10,000 tokens)</a:t>
             </a:r>
           </a:p>
         </p:txBody>
@@ -5214,7 +5214,7 @@
               </a:defRPr>
             </a:pPr>
             <a:r>
-              <a:t>Representation: diff-vector |f(t₁) − f(t₂)| → 695 dims</a:t>
+              <a:t>Representation: diff-vector |f(t1) - f(t2)| -&gt; 695 dims</a:t>
             </a:r>
           </a:p>
           <a:p>
@@ -6008,7 +6008,7 @@
                 </a:solidFill>
                 <a:latin typeface="Calibri"/>
               </a:rPr>
-              <a:t> — 128 filters each → 384d, MaxPool(3)</a:t>
+              <a:t> — 128 filters each -&gt; 384d, MaxPool(3)</a:t>
             </a:r>
           </a:p>
           <a:p>
@@ -6048,7 +6048,7 @@
                 </a:solidFill>
                 <a:latin typeface="Calibri"/>
               </a:rPr>
-              <a:t> — Bidirectional → 256d sequential features</a:t>
+              <a:t> — Bidirectional -&gt; 256d sequential features</a:t>
             </a:r>
           </a:p>
           <a:p>
@@ -6191,7 +6191,7 @@
               </a:defRPr>
             </a:pPr>
             <a:r>
-              <a:t>MLP Classifier: 512 → 256 → 64 → 1 (BCE loss)</a:t>
+              <a:t>MLP Classifier: 512 -&gt; 256 -&gt; 64 -&gt; 1 (BCE loss)</a:t>
             </a:r>
           </a:p>
           <a:p>
@@ -6324,7 +6324,7 @@
                 </a:solidFill>
                 <a:latin typeface="Calibri"/>
               </a:rPr>
-              <a:t>λ ramp: 0→0.05 over 20 epochs; topic_weight=0.02</a:t>
+              <a:t>Lambda ramp: 0 -&gt; 0.05 over 20 epochs; topic_weight=0.02</a:t>
             </a:r>
           </a:p>
           <a:p>
@@ -8984,7 +8984,7 @@
                 </a:solidFill>
                 <a:latin typeface="Calibri"/>
               </a:rPr>
-              <a:t>Removing 21 novel features: −1.8% F1</a:t>
+              <a:t>Removing 21 novel features: -1.8% F1</a:t>
             </a:r>
           </a:p>
           <a:p>
@@ -9015,7 +9015,7 @@
                 </a:solidFill>
                 <a:latin typeface="Calibri"/>
               </a:rPr>
-              <a:t>Removing GRL: −1.2% F1 on topic-confounded pairs</a:t>
+              <a:t>Removing GRL: -1.2% F1 on topic-confounded pairs</a:t>
             </a:r>
           </a:p>
         </p:txBody>

</xml_diff>

<commit_message>
A1 poster v6: Fix section numbering for logical reading flow, fix CM metrics display
</commit_message>
<xml_diff>
--- a/poster/poster_a1.pptx
+++ b/poster/poster_a1.pptx
@@ -7491,8 +7491,8 @@
         </p:nvSpPr>
         <p:spPr>
           <a:xfrm>
-            <a:off x="10445546" y="17440000"/>
-            <a:ext cx="320000" cy="400000"/>
+            <a:off x="10525546" y="17445000"/>
+            <a:ext cx="9325546" cy="390000"/>
           </a:xfrm>
           <a:prstGeom prst="rect">
             <a:avLst/>
@@ -7505,17 +7505,17 @@
           </a:bodyPr>
           <a:lstStyle/>
           <a:p>
-            <a:pPr algn="ctr">
-              <a:lnSpc>
-                <a:spcPct val="115000"/>
-              </a:lnSpc>
-              <a:spcBef>
-                <a:spcPts val="0"/>
-              </a:spcBef>
-              <a:spcAft>
-                <a:spcPts val="0"/>
-              </a:spcAft>
-              <a:defRPr sz="2400" b="1" i="0">
+            <a:pPr algn="l">
+              <a:lnSpc>
+                <a:spcPct val="115000"/>
+              </a:lnSpc>
+              <a:spcBef>
+                <a:spcPts val="0"/>
+              </a:spcBef>
+              <a:spcAft>
+                <a:spcPts val="0"/>
+              </a:spcAft>
+              <a:defRPr sz="3000" b="1" i="0">
                 <a:solidFill>
                   <a:srgbClr val="FFFFFF"/>
                 </a:solidFill>
@@ -7523,51 +7523,6 @@
               </a:defRPr>
             </a:pPr>
             <a:r>
-              <a:t>8</a:t>
-            </a:r>
-          </a:p>
-        </p:txBody>
-      </p:sp>
-      <p:sp>
-        <p:nvSpPr>
-          <p:cNvPr id="63" name="TextBox 62"/>
-          <p:cNvSpPr txBox="1"/>
-          <p:nvPr/>
-        </p:nvSpPr>
-        <p:spPr>
-          <a:xfrm>
-            <a:off x="10705546" y="17445000"/>
-            <a:ext cx="9325546" cy="390000"/>
-          </a:xfrm>
-          <a:prstGeom prst="rect">
-            <a:avLst/>
-          </a:prstGeom>
-          <a:noFill/>
-        </p:spPr>
-        <p:txBody>
-          <a:bodyPr wrap="square">
-            <a:spAutoFit/>
-          </a:bodyPr>
-          <a:lstStyle/>
-          <a:p>
-            <a:pPr algn="l">
-              <a:lnSpc>
-                <a:spcPct val="115000"/>
-              </a:lnSpc>
-              <a:spcBef>
-                <a:spcPts val="0"/>
-              </a:spcBef>
-              <a:spcAft>
-                <a:spcPts val="0"/>
-              </a:spcAft>
-              <a:defRPr sz="3000" b="1" i="0">
-                <a:solidFill>
-                  <a:srgbClr val="FFFFFF"/>
-                </a:solidFill>
-                <a:latin typeface="Calibri"/>
-              </a:defRPr>
-            </a:pPr>
-            <a:r>
               <a:t>Evaluation &amp; Conclusions</a:t>
             </a:r>
           </a:p>
@@ -7575,7 +7530,7 @@
       </p:sp>
       <p:sp>
         <p:nvSpPr>
-          <p:cNvPr id="64" name="Rectangle 63"/>
+          <p:cNvPr id="63" name="Rectangle 62"/>
           <p:cNvSpPr/>
           <p:nvPr/>
         </p:nvSpPr>
@@ -7618,7 +7573,7 @@
       </p:sp>
       <p:sp>
         <p:nvSpPr>
-          <p:cNvPr id="65" name="Rounded Rectangle 64"/>
+          <p:cNvPr id="64" name="Rounded Rectangle 63"/>
           <p:cNvSpPr/>
           <p:nvPr/>
         </p:nvSpPr>
@@ -7665,7 +7620,7 @@
       </p:sp>
       <p:sp>
         <p:nvSpPr>
-          <p:cNvPr id="66" name="TextBox 65"/>
+          <p:cNvPr id="65" name="TextBox 64"/>
           <p:cNvSpPr txBox="1"/>
           <p:nvPr/>
         </p:nvSpPr>
@@ -7968,7 +7923,7 @@
       </p:sp>
       <p:sp>
         <p:nvSpPr>
-          <p:cNvPr id="67" name="Rectangle 66"/>
+          <p:cNvPr id="66" name="Rectangle 65"/>
           <p:cNvSpPr/>
           <p:nvPr/>
         </p:nvSpPr>
@@ -8011,7 +7966,7 @@
       </p:sp>
       <p:sp>
         <p:nvSpPr>
-          <p:cNvPr id="68" name="Rectangle 67"/>
+          <p:cNvPr id="67" name="Rectangle 66"/>
           <p:cNvSpPr/>
           <p:nvPr/>
         </p:nvSpPr>
@@ -8054,14 +8009,14 @@
       </p:sp>
       <p:sp>
         <p:nvSpPr>
-          <p:cNvPr id="69" name="TextBox 68"/>
+          <p:cNvPr id="68" name="TextBox 67"/>
           <p:cNvSpPr txBox="1"/>
           <p:nvPr/>
         </p:nvSpPr>
         <p:spPr>
           <a:xfrm>
-            <a:off x="20341092" y="2290000"/>
-            <a:ext cx="320000" cy="400000"/>
+            <a:off x="20421092" y="2295000"/>
+            <a:ext cx="9325546" cy="390000"/>
           </a:xfrm>
           <a:prstGeom prst="rect">
             <a:avLst/>
@@ -8074,17 +8029,17 @@
           </a:bodyPr>
           <a:lstStyle/>
           <a:p>
-            <a:pPr algn="ctr">
-              <a:lnSpc>
-                <a:spcPct val="115000"/>
-              </a:lnSpc>
-              <a:spcBef>
-                <a:spcPts val="0"/>
-              </a:spcBef>
-              <a:spcAft>
-                <a:spcPts val="0"/>
-              </a:spcAft>
-              <a:defRPr sz="2400" b="1" i="0">
+            <a:pPr algn="l">
+              <a:lnSpc>
+                <a:spcPct val="115000"/>
+              </a:lnSpc>
+              <a:spcBef>
+                <a:spcPts val="0"/>
+              </a:spcBef>
+              <a:spcAft>
+                <a:spcPts val="0"/>
+              </a:spcAft>
+              <a:defRPr sz="3000" b="1" i="0">
                 <a:solidFill>
                   <a:srgbClr val="FFFFFF"/>
                 </a:solidFill>
@@ -8092,51 +8047,6 @@
               </a:defRPr>
             </a:pPr>
             <a:r>
-              <a:t>6</a:t>
-            </a:r>
-          </a:p>
-        </p:txBody>
-      </p:sp>
-      <p:sp>
-        <p:nvSpPr>
-          <p:cNvPr id="70" name="TextBox 69"/>
-          <p:cNvSpPr txBox="1"/>
-          <p:nvPr/>
-        </p:nvSpPr>
-        <p:spPr>
-          <a:xfrm>
-            <a:off x="20601092" y="2295000"/>
-            <a:ext cx="9325546" cy="390000"/>
-          </a:xfrm>
-          <a:prstGeom prst="rect">
-            <a:avLst/>
-          </a:prstGeom>
-          <a:noFill/>
-        </p:spPr>
-        <p:txBody>
-          <a:bodyPr wrap="square">
-            <a:spAutoFit/>
-          </a:bodyPr>
-          <a:lstStyle/>
-          <a:p>
-            <a:pPr algn="l">
-              <a:lnSpc>
-                <a:spcPct val="115000"/>
-              </a:lnSpc>
-              <a:spcBef>
-                <a:spcPts val="0"/>
-              </a:spcBef>
-              <a:spcAft>
-                <a:spcPts val="0"/>
-              </a:spcAft>
-              <a:defRPr sz="3000" b="1" i="0">
-                <a:solidFill>
-                  <a:srgbClr val="FFFFFF"/>
-                </a:solidFill>
-                <a:latin typeface="Calibri"/>
-              </a:defRPr>
-            </a:pPr>
-            <a:r>
               <a:t>Performance Comparison</a:t>
             </a:r>
           </a:p>
@@ -8144,7 +8054,7 @@
       </p:sp>
       <p:sp>
         <p:nvSpPr>
-          <p:cNvPr id="71" name="Rectangle 70"/>
+          <p:cNvPr id="69" name="Rectangle 68"/>
           <p:cNvSpPr/>
           <p:nvPr/>
         </p:nvSpPr>
@@ -8187,7 +8097,7 @@
       </p:sp>
       <p:sp>
         <p:nvSpPr>
-          <p:cNvPr id="72" name="Rounded Rectangle 71"/>
+          <p:cNvPr id="70" name="Rounded Rectangle 69"/>
           <p:cNvSpPr/>
           <p:nvPr/>
         </p:nvSpPr>
@@ -8234,7 +8144,7 @@
       </p:sp>
       <p:pic>
         <p:nvPicPr>
-          <p:cNvPr id="73" name="Picture 72" descr="f1_chart_a1.png"/>
+          <p:cNvPr id="71" name="Picture 70" descr="f1_chart_a1.png"/>
           <p:cNvPicPr>
             <a:picLocks noChangeAspect="1"/>
           </p:cNvPicPr>
@@ -8258,7 +8168,7 @@
       </p:pic>
       <p:sp>
         <p:nvSpPr>
-          <p:cNvPr id="74" name="Rectangle 73"/>
+          <p:cNvPr id="72" name="Rectangle 71"/>
           <p:cNvSpPr/>
           <p:nvPr/>
         </p:nvSpPr>
@@ -8301,7 +8211,7 @@
       </p:sp>
       <p:sp>
         <p:nvSpPr>
-          <p:cNvPr id="75" name="Rectangle 74"/>
+          <p:cNvPr id="73" name="Rectangle 72"/>
           <p:cNvSpPr/>
           <p:nvPr/>
         </p:nvSpPr>
@@ -8344,7 +8254,7 @@
       </p:sp>
       <p:sp>
         <p:nvSpPr>
-          <p:cNvPr id="76" name="TextBox 75"/>
+          <p:cNvPr id="74" name="TextBox 73"/>
           <p:cNvSpPr txBox="1"/>
           <p:nvPr/>
         </p:nvSpPr>
@@ -8389,7 +8299,7 @@
       </p:sp>
       <p:sp>
         <p:nvSpPr>
-          <p:cNvPr id="77" name="Rectangle 76"/>
+          <p:cNvPr id="75" name="Rectangle 74"/>
           <p:cNvSpPr/>
           <p:nvPr/>
         </p:nvSpPr>
@@ -8432,7 +8342,7 @@
       </p:sp>
       <p:sp>
         <p:nvSpPr>
-          <p:cNvPr id="78" name="Rounded Rectangle 77"/>
+          <p:cNvPr id="76" name="Rounded Rectangle 75"/>
           <p:cNvSpPr/>
           <p:nvPr/>
         </p:nvSpPr>
@@ -8479,7 +8389,7 @@
       </p:sp>
       <p:pic>
         <p:nvPicPr>
-          <p:cNvPr id="79" name="Picture 78" descr="cm_a1.png"/>
+          <p:cNvPr id="77" name="Picture 76" descr="cm_a1.png"/>
           <p:cNvPicPr>
             <a:picLocks noChangeAspect="1"/>
           </p:cNvPicPr>
@@ -8503,7 +8413,7 @@
       </p:pic>
       <p:sp>
         <p:nvSpPr>
-          <p:cNvPr id="80" name="Rectangle 79"/>
+          <p:cNvPr id="78" name="Rectangle 77"/>
           <p:cNvSpPr/>
           <p:nvPr/>
         </p:nvSpPr>
@@ -8546,7 +8456,7 @@
       </p:sp>
       <p:sp>
         <p:nvSpPr>
-          <p:cNvPr id="81" name="Rectangle 80"/>
+          <p:cNvPr id="79" name="Rectangle 78"/>
           <p:cNvSpPr/>
           <p:nvPr/>
         </p:nvSpPr>
@@ -8589,7 +8499,7 @@
       </p:sp>
       <p:sp>
         <p:nvSpPr>
-          <p:cNvPr id="82" name="TextBox 81"/>
+          <p:cNvPr id="80" name="TextBox 79"/>
           <p:cNvSpPr txBox="1"/>
           <p:nvPr/>
         </p:nvSpPr>
@@ -8627,14 +8537,14 @@
               </a:defRPr>
             </a:pPr>
             <a:r>
-              <a:t>7</a:t>
-            </a:r>
-          </a:p>
-        </p:txBody>
-      </p:sp>
-      <p:sp>
-        <p:nvSpPr>
-          <p:cNvPr id="83" name="TextBox 82"/>
+              <a:t>6</a:t>
+            </a:r>
+          </a:p>
+        </p:txBody>
+      </p:sp>
+      <p:sp>
+        <p:nvSpPr>
+          <p:cNvPr id="81" name="TextBox 80"/>
           <p:cNvSpPr txBox="1"/>
           <p:nvPr/>
         </p:nvSpPr>
@@ -8679,7 +8589,7 @@
       </p:sp>
       <p:sp>
         <p:nvSpPr>
-          <p:cNvPr id="84" name="Rectangle 83"/>
+          <p:cNvPr id="82" name="Rectangle 81"/>
           <p:cNvSpPr/>
           <p:nvPr/>
         </p:nvSpPr>
@@ -8722,7 +8632,7 @@
       </p:sp>
       <p:sp>
         <p:nvSpPr>
-          <p:cNvPr id="85" name="Rounded Rectangle 84"/>
+          <p:cNvPr id="83" name="Rounded Rectangle 82"/>
           <p:cNvSpPr/>
           <p:nvPr/>
         </p:nvSpPr>
@@ -8769,7 +8679,7 @@
       </p:sp>
       <p:sp>
         <p:nvSpPr>
-          <p:cNvPr id="86" name="TextBox 85"/>
+          <p:cNvPr id="84" name="TextBox 83"/>
           <p:cNvSpPr txBox="1"/>
           <p:nvPr/>
         </p:nvSpPr>
@@ -9022,7 +8932,7 @@
       </p:sp>
       <p:sp>
         <p:nvSpPr>
-          <p:cNvPr id="87" name="Rectangle 86"/>
+          <p:cNvPr id="85" name="Rectangle 84"/>
           <p:cNvSpPr/>
           <p:nvPr/>
         </p:nvSpPr>
@@ -9065,7 +8975,7 @@
       </p:sp>
       <p:sp>
         <p:nvSpPr>
-          <p:cNvPr id="88" name="Rectangle 87"/>
+          <p:cNvPr id="86" name="Rectangle 85"/>
           <p:cNvSpPr/>
           <p:nvPr/>
         </p:nvSpPr>
@@ -9108,14 +9018,14 @@
       </p:sp>
       <p:sp>
         <p:nvSpPr>
-          <p:cNvPr id="89" name="TextBox 88"/>
+          <p:cNvPr id="87" name="TextBox 86"/>
           <p:cNvSpPr txBox="1"/>
           <p:nvPr/>
         </p:nvSpPr>
         <p:spPr>
           <a:xfrm>
-            <a:off x="20421092" y="14295000"/>
-            <a:ext cx="9325546" cy="390000"/>
+            <a:off x="20341092" y="14290000"/>
+            <a:ext cx="320000" cy="400000"/>
           </a:xfrm>
           <a:prstGeom prst="rect">
             <a:avLst/>
@@ -9128,6 +9038,51 @@
           </a:bodyPr>
           <a:lstStyle/>
           <a:p>
+            <a:pPr algn="ctr">
+              <a:lnSpc>
+                <a:spcPct val="115000"/>
+              </a:lnSpc>
+              <a:spcBef>
+                <a:spcPts val="0"/>
+              </a:spcBef>
+              <a:spcAft>
+                <a:spcPts val="0"/>
+              </a:spcAft>
+              <a:defRPr sz="2400" b="1" i="0">
+                <a:solidFill>
+                  <a:srgbClr val="FFFFFF"/>
+                </a:solidFill>
+                <a:latin typeface="Calibri"/>
+              </a:defRPr>
+            </a:pPr>
+            <a:r>
+              <a:t>7</a:t>
+            </a:r>
+          </a:p>
+        </p:txBody>
+      </p:sp>
+      <p:sp>
+        <p:nvSpPr>
+          <p:cNvPr id="88" name="TextBox 87"/>
+          <p:cNvSpPr txBox="1"/>
+          <p:nvPr/>
+        </p:nvSpPr>
+        <p:spPr>
+          <a:xfrm>
+            <a:off x="20601092" y="14295000"/>
+            <a:ext cx="9325546" cy="390000"/>
+          </a:xfrm>
+          <a:prstGeom prst="rect">
+            <a:avLst/>
+          </a:prstGeom>
+          <a:noFill/>
+        </p:spPr>
+        <p:txBody>
+          <a:bodyPr wrap="square">
+            <a:spAutoFit/>
+          </a:bodyPr>
+          <a:lstStyle/>
+          <a:p>
             <a:pPr algn="l">
               <a:lnSpc>
                 <a:spcPct val="115000"/>
@@ -9153,7 +9108,7 @@
       </p:sp>
       <p:sp>
         <p:nvSpPr>
-          <p:cNvPr id="90" name="Rectangle 89"/>
+          <p:cNvPr id="89" name="Rectangle 88"/>
           <p:cNvSpPr/>
           <p:nvPr/>
         </p:nvSpPr>
@@ -9196,7 +9151,7 @@
       </p:sp>
       <p:sp>
         <p:nvSpPr>
-          <p:cNvPr id="91" name="Rounded Rectangle 90"/>
+          <p:cNvPr id="90" name="Rounded Rectangle 89"/>
           <p:cNvSpPr/>
           <p:nvPr/>
         </p:nvSpPr>
@@ -9243,7 +9198,7 @@
       </p:sp>
       <p:sp>
         <p:nvSpPr>
-          <p:cNvPr id="92" name="TextBox 91"/>
+          <p:cNvPr id="91" name="TextBox 90"/>
           <p:cNvSpPr txBox="1"/>
           <p:nvPr/>
         </p:nvSpPr>
@@ -9546,7 +9501,7 @@
       </p:sp>
       <p:sp>
         <p:nvSpPr>
-          <p:cNvPr id="93" name="Rectangle 92"/>
+          <p:cNvPr id="92" name="Rectangle 91"/>
           <p:cNvSpPr/>
           <p:nvPr/>
         </p:nvSpPr>
@@ -9589,7 +9544,7 @@
       </p:sp>
       <p:sp>
         <p:nvSpPr>
-          <p:cNvPr id="94" name="Rectangle 93"/>
+          <p:cNvPr id="93" name="Rectangle 92"/>
           <p:cNvSpPr/>
           <p:nvPr/>
         </p:nvSpPr>
@@ -9632,7 +9587,7 @@
       </p:sp>
       <p:sp>
         <p:nvSpPr>
-          <p:cNvPr id="95" name="TextBox 94"/>
+          <p:cNvPr id="94" name="TextBox 93"/>
           <p:cNvSpPr txBox="1"/>
           <p:nvPr/>
         </p:nvSpPr>
@@ -9677,7 +9632,7 @@
       </p:sp>
       <p:sp>
         <p:nvSpPr>
-          <p:cNvPr id="96" name="Rectangle 95"/>
+          <p:cNvPr id="95" name="Rectangle 94"/>
           <p:cNvSpPr/>
           <p:nvPr/>
         </p:nvSpPr>
@@ -9720,7 +9675,7 @@
       </p:sp>
       <p:sp>
         <p:nvSpPr>
-          <p:cNvPr id="97" name="Rounded Rectangle 96"/>
+          <p:cNvPr id="96" name="Rounded Rectangle 95"/>
           <p:cNvSpPr/>
           <p:nvPr/>
         </p:nvSpPr>
@@ -9767,7 +9722,7 @@
       </p:sp>
       <p:sp>
         <p:nvSpPr>
-          <p:cNvPr id="98" name="TextBox 97"/>
+          <p:cNvPr id="97" name="TextBox 96"/>
           <p:cNvSpPr txBox="1"/>
           <p:nvPr/>
         </p:nvSpPr>
@@ -9878,7 +9833,7 @@
       </p:sp>
       <p:sp>
         <p:nvSpPr>
-          <p:cNvPr id="99" name="Rectangle 98"/>
+          <p:cNvPr id="98" name="Rectangle 97"/>
           <p:cNvSpPr/>
           <p:nvPr/>
         </p:nvSpPr>
@@ -9921,7 +9876,7 @@
       </p:sp>
       <p:sp>
         <p:nvSpPr>
-          <p:cNvPr id="100" name="Rectangle 99"/>
+          <p:cNvPr id="99" name="Rectangle 98"/>
           <p:cNvSpPr/>
           <p:nvPr/>
         </p:nvSpPr>
@@ -9964,7 +9919,7 @@
       </p:sp>
       <p:sp>
         <p:nvSpPr>
-          <p:cNvPr id="101" name="TextBox 100"/>
+          <p:cNvPr id="100" name="TextBox 99"/>
           <p:cNvSpPr txBox="1"/>
           <p:nvPr/>
         </p:nvSpPr>

</xml_diff>

<commit_message>
A1 poster v7: Add per-class strength conclusions, emphasize complementarity
</commit_message>
<xml_diff>
--- a/poster/poster_a1.pptx
+++ b/poster/poster_a1.pptx
@@ -7885,7 +7885,7 @@
                 </a:solidFill>
                 <a:latin typeface="Calibri"/>
               </a:rPr>
-              <a:t>Complementary approaches: feature engineering + neural</a:t>
+              <a:t>Sol 1 excels at detecting different authors (75.6% acc)</a:t>
             </a:r>
           </a:p>
           <a:p>
@@ -7916,7 +7916,38 @@
                 </a:solidFill>
                 <a:latin typeface="Calibri"/>
               </a:rPr>
-              <a:t>Novel features and adversarial debiasing add measurable value</a:t>
+              <a:t>Sol 2 excels at confirming same author (75.1% acc)</a:t>
+            </a:r>
+          </a:p>
+          <a:p>
+            <a:pPr algn="l">
+              <a:lnSpc>
+                <a:spcPct val="115000"/>
+              </a:lnSpc>
+              <a:spcBef>
+                <a:spcPts val="0"/>
+              </a:spcBef>
+              <a:spcAft>
+                <a:spcPts val="300"/>
+              </a:spcAft>
+            </a:pPr>
+            <a:r>
+              <a:rPr sz="2000" b="0">
+                <a:solidFill>
+                  <a:srgbClr val="666666"/>
+                </a:solidFill>
+                <a:latin typeface="Calibri"/>
+              </a:rPr>
+              <a:t>  •  </a:t>
+            </a:r>
+            <a:r>
+              <a:rPr sz="2000" b="0">
+                <a:solidFill>
+                  <a:srgbClr val="2D2D2D"/>
+                </a:solidFill>
+                <a:latin typeface="Calibri"/>
+              </a:rPr>
+              <a:t>Complementary strengths suggest ensemble potential</a:t>
             </a:r>
           </a:p>
         </p:txBody>

</xml_diff>

<commit_message>
A1 poster v10: Improve title line break, keep Feature Engineering on same line
</commit_message>
<xml_diff>
--- a/poster/poster_a1.pptx
+++ b/poster/poster_a1.pptx
@@ -3308,11 +3308,11 @@
               </a:defRPr>
             </a:pPr>
             <a:r>
-              <a:t>Authorship Verification: Combining Stylometric Feature</a:t>
+              <a:t>Authorship Verification: Combining Stylometric Feature Engineering</a:t>
             </a:r>
             <a:br/>
             <a:r>
-              <a:t>Engineering with Adversarial Neural Style-Content Disentanglement</a:t>
+              <a:t>with Adversarial Neural Style-Content Disentanglement</a:t>
             </a:r>
           </a:p>
         </p:txBody>

</xml_diff>